<commit_message>
Deck V4: combined production/conflict chart on slide 2, Russia removed, citations added
- Slide 2 rebuilt as one chart: stacked arms-production bars by region
  (Russia excluded) with a single global armed-conflict line on a right axis.
- Slide 7 rebuilt as a true-relative-scale TAM/SAM/SOM visual.
- 18 numbered citations with superscripts throughout; two source slides added.
- Corrected two stockpile figures that could not be verified against primary
  sources: 303,772 short tons and the 361,220 FY30 forecast are replaced by the
  Army FY2026 budget justification figure of 309,065 tons as of 30 Jan 2025.
  Added the verified demilitarization-throughput collapse (82,000 t in FY2015
  to a funded 29,313 t in FY2026).
</commit_message>
<xml_diff>
--- a/deck/TWB_Investment_Deck.pptx
+++ b/deck/TWB_Investment_Deck.pptx
@@ -20,9 +20,11 @@
     <p:sldId id="268" r:id="rId14"/>
     <p:sldId id="269" r:id="rId15"/>
     <p:sldId id="270" r:id="rId16"/>
+    <p:sldId id="271" r:id="rId17"/>
+    <p:sldId id="272" r:id="rId18"/>
   </p:sldIdLst>
   <p:notesMasterIdLst>
-    <p:notesMasterId r:id="rId17"/>
+    <p:notesMasterId r:id="rId19"/>
   </p:notesMasterIdLst>
   <p:sldSz cx="12192000" cy="6858000"/>
   <p:notesSz cx="6858000" cy="12192000"/>
@@ -1086,6 +1088,182 @@
 </p:notes>
 </file>
 
+<file path=ppt/notesSlides/notesSlide16.xml><?xml version="1.0" encoding="utf-8"?>
+<p:notes xmlns:a="http://schemas.openxmlformats.org/drawingml/2006/main" xmlns:r="http://schemas.openxmlformats.org/officeDocument/2006/relationships" xmlns:p="http://schemas.openxmlformats.org/presentationml/2006/main">
+  <p:cSld>
+    <p:spTree>
+      <p:nvGrpSpPr>
+        <p:cNvPr id="1" name=""/>
+        <p:cNvGrpSpPr/>
+        <p:nvPr/>
+      </p:nvGrpSpPr>
+      <p:grpSpPr>
+        <a:xfrm>
+          <a:off x="0" y="0"/>
+          <a:ext cx="0" cy="0"/>
+          <a:chOff x="0" y="0"/>
+          <a:chExt cx="0" cy="0"/>
+        </a:xfrm>
+      </p:grpSpPr>
+      <p:sp>
+        <p:nvSpPr>
+          <p:cNvPr id="2" name="Slide Image Placeholder 1"/>
+          <p:cNvSpPr>
+            <a:spLocks noGrp="1" noRot="1" noChangeAspect="1"/>
+          </p:cNvSpPr>
+          <p:nvPr>
+            <p:ph type="sldImg"/>
+          </p:nvPr>
+        </p:nvSpPr>
+        <p:spPr/>
+      </p:sp>
+      <p:sp>
+        <p:nvSpPr>
+          <p:cNvPr id="3" name="Notes Placeholder 2"/>
+          <p:cNvSpPr>
+            <a:spLocks noGrp="1"/>
+          </p:cNvSpPr>
+          <p:nvPr>
+            <p:ph type="body" idx="1"/>
+          </p:nvPr>
+        </p:nvSpPr>
+        <p:spPr/>
+        <p:txBody>
+          <a:bodyPr/>
+          <a:lstStyle/>
+          <a:p>
+            <a:r>
+              <a:rPr lang="en-US" dirty="0"/>
+              <a:t>Leave these up during Q&amp;A. The point is not that anyone reads them in the room — it is that the deck visibly survives being checked. If challenged on a number, go to the superscript, not to memory.</a:t>
+            </a:r>
+            <a:endParaRPr lang="en-US" dirty="0"/>
+          </a:p>
+        </p:txBody>
+      </p:sp>
+      <p:sp>
+        <p:nvSpPr>
+          <p:cNvPr id="4" name="Slide Number Placeholder 3"/>
+          <p:cNvSpPr>
+            <a:spLocks noGrp="1"/>
+          </p:cNvSpPr>
+          <p:nvPr>
+            <p:ph type="sldNum" sz="quarter" idx="10"/>
+          </p:nvPr>
+        </p:nvSpPr>
+        <p:spPr/>
+        <p:txBody>
+          <a:bodyPr/>
+          <a:lstStyle/>
+          <a:p>
+            <a:fld id="{F7021451-1387-4CA6-816F-3879F97B5CBC}" type="slidenum">
+              <a:rPr lang="en-US"/>
+              <a:t>16</a:t>
+            </a:fld>
+            <a:endParaRPr lang="en-US"/>
+          </a:p>
+        </p:txBody>
+      </p:sp>
+    </p:spTree>
+    <p:extLst>
+      <p:ext uri="{BB962C8B-B14F-4D97-AF65-F5344CB8AC3E}">
+        <p14:creationId xmlns:p14="http://schemas.microsoft.com/office/powerpoint/2010/main" val="1024086991"/>
+      </p:ext>
+    </p:extLst>
+  </p:cSld>
+  <p:clrMapOvr>
+    <a:masterClrMapping/>
+  </p:clrMapOvr>
+</p:notes>
+</file>
+
+<file path=ppt/notesSlides/notesSlide17.xml><?xml version="1.0" encoding="utf-8"?>
+<p:notes xmlns:a="http://schemas.openxmlformats.org/drawingml/2006/main" xmlns:r="http://schemas.openxmlformats.org/officeDocument/2006/relationships" xmlns:p="http://schemas.openxmlformats.org/presentationml/2006/main">
+  <p:cSld>
+    <p:spTree>
+      <p:nvGrpSpPr>
+        <p:cNvPr id="1" name=""/>
+        <p:cNvGrpSpPr/>
+        <p:nvPr/>
+      </p:nvGrpSpPr>
+      <p:grpSpPr>
+        <a:xfrm>
+          <a:off x="0" y="0"/>
+          <a:ext cx="0" cy="0"/>
+          <a:chOff x="0" y="0"/>
+          <a:chExt cx="0" cy="0"/>
+        </a:xfrm>
+      </p:grpSpPr>
+      <p:sp>
+        <p:nvSpPr>
+          <p:cNvPr id="2" name="Slide Image Placeholder 1"/>
+          <p:cNvSpPr>
+            <a:spLocks noGrp="1" noRot="1" noChangeAspect="1"/>
+          </p:cNvSpPr>
+          <p:nvPr>
+            <p:ph type="sldImg"/>
+          </p:nvPr>
+        </p:nvSpPr>
+        <p:spPr/>
+      </p:sp>
+      <p:sp>
+        <p:nvSpPr>
+          <p:cNvPr id="3" name="Notes Placeholder 2"/>
+          <p:cNvSpPr>
+            <a:spLocks noGrp="1"/>
+          </p:cNvSpPr>
+          <p:nvPr>
+            <p:ph type="body" idx="1"/>
+          </p:nvPr>
+        </p:nvSpPr>
+        <p:spPr/>
+        <p:txBody>
+          <a:bodyPr/>
+          <a:lstStyle/>
+          <a:p>
+            <a:r>
+              <a:rPr lang="en-US" dirty="0"/>
+              <a:t>Leave these up during Q&amp;A. The point is not that anyone reads them in the room — it is that the deck visibly survives being checked. If challenged on a number, go to the superscript, not to memory.</a:t>
+            </a:r>
+            <a:endParaRPr lang="en-US" dirty="0"/>
+          </a:p>
+        </p:txBody>
+      </p:sp>
+      <p:sp>
+        <p:nvSpPr>
+          <p:cNvPr id="4" name="Slide Number Placeholder 3"/>
+          <p:cNvSpPr>
+            <a:spLocks noGrp="1"/>
+          </p:cNvSpPr>
+          <p:nvPr>
+            <p:ph type="sldNum" sz="quarter" idx="10"/>
+          </p:nvPr>
+        </p:nvSpPr>
+        <p:spPr/>
+        <p:txBody>
+          <a:bodyPr/>
+          <a:lstStyle/>
+          <a:p>
+            <a:fld id="{F7021451-1387-4CA6-816F-3879F97B5CBC}" type="slidenum">
+              <a:rPr lang="en-US"/>
+              <a:t>17</a:t>
+            </a:fld>
+            <a:endParaRPr lang="en-US"/>
+          </a:p>
+        </p:txBody>
+      </p:sp>
+    </p:spTree>
+    <p:extLst>
+      <p:ext uri="{BB962C8B-B14F-4D97-AF65-F5344CB8AC3E}">
+        <p14:creationId xmlns:p14="http://schemas.microsoft.com/office/powerpoint/2010/main" val="1024086991"/>
+      </p:ext>
+    </p:extLst>
+  </p:cSld>
+  <p:clrMapOvr>
+    <a:masterClrMapping/>
+  </p:clrMapOvr>
+</p:notes>
+</file>
+
 <file path=ppt/notesSlides/notesSlide2.xml><?xml version="1.0" encoding="utf-8"?>
 <p:notes xmlns:a="http://schemas.openxmlformats.org/drawingml/2006/main" xmlns:r="http://schemas.openxmlformats.org/officeDocument/2006/relationships" xmlns:p="http://schemas.openxmlformats.org/presentationml/2006/main">
   <p:cSld>
@@ -1132,7 +1310,7 @@
           <a:p>
             <a:r>
               <a:rPr lang="en-US" dirty="0"/>
-              <a:t>Let the room feel smart — they know these numbers, they own the producers. Then take the turn: the buildup has a second half nobody has capitalised. Do not rush the last line; it is the thesis.</a:t>
+              <a:t>The chart is the argument: production climbing for a decade across every region, conflicts climbing with it to a post-1946 record. Two panels, one timeline, one axis each — deliberately NOT a dual-axis overlay, so nobody can accuse us of scaling two series to look correlated. Note the honest gap: no 2025 production bar because SIPRI has not published it. If asked why arms-company revenue rather than 'ammunition production': there is no audited global ammunition-production series — the market-research numbers are unsourced and contradict each other. This is the closest verifiable proxy and it is checkable in two clicks.</a:t>
             </a:r>
             <a:endParaRPr lang="en-US" dirty="0"/>
           </a:p>
@@ -1572,7 +1750,7 @@
           <a:p>
             <a:r>
               <a:rPr lang="en-US" dirty="0"/>
-              <a:t>Say it plainly: this TAM is our construction, and that is a feature — an uncovered market with no index is where category-defining returns live. Let the type visibly shrink tier to tier — the taper itself argues the funnel. Never let this be re-scored on tons/year.</a:t>
+              <a:t>The scale drawing does the work a table cannot: SOM is visibly a sliver of TAM, which is the honest shape of a venture case and pre-empts the 'your SOM is your TAM' objection before it is raised. Say plainly that this construction is ours — an uncovered market with no index is where category-defining returns live. Never let it be re-scored on tons per year.</a:t>
             </a:r>
             <a:endParaRPr lang="en-US" dirty="0"/>
           </a:p>
@@ -2769,7 +2947,7 @@
                 <a:ea typeface="IBM Plex Mono" pitchFamily="34" charset="-122"/>
                 <a:cs typeface="IBM Plex Mono" pitchFamily="34" charset="-120"/>
               </a:rPr>
-              <a:t>YEARS OPERATING — EMACS, IN SERVICE SINCE 2001, CO-DEVELOPED WITH THE RCMP</a:t>
+              <a:t>YEARS OPERATING — EMACS, IN SERVICE SINCE 2001, CO-DEVELOPED WITH THE RCMP¹⁶</a:t>
             </a:r>
             <a:endParaRPr lang="en-US" sz="1050" dirty="0"/>
           </a:p>
@@ -3081,7 +3259,7 @@
                 <a:ea typeface="Helvetica Neue" pitchFamily="34" charset="-122"/>
                 <a:cs typeface="Helvetica Neue" pitchFamily="34" charset="-120"/>
               </a:rPr>
-              <a:t>Closed chamber — categorically not open burning under 40 CFR 260.10</a:t>
+              <a:t>Closed chamber — categorically not open burning under 40 CFR 260.10¹⁴</a:t>
             </a:r>
             <a:endParaRPr lang="en-US" sz="950" dirty="0"/>
           </a:p>
@@ -5012,7 +5190,7 @@
                 <a:ea typeface="IBM Plex Mono" pitchFamily="34" charset="-122"/>
                 <a:cs typeface="IBM Plex Mono" pitchFamily="34" charset="-120"/>
               </a:rPr>
-              <a:t>ARMED CONFLICTS, 2025. NO GOVERNMENT WANTS ITS MUNITIONS — OR THE CRITICAL METALS INSIDE THEM — CROSSING BORDERS TO DIE</a:t>
+              <a:t>ARMED CONFLICTS, 2025. NO GOVERNMENT WANTS ITS MUNITIONS — OR THE CRITICAL METALS INSIDE THEM — CROSSING BORDERS TO DIE²</a:t>
             </a:r>
             <a:endParaRPr lang="en-US" sz="1050" dirty="0"/>
           </a:p>
@@ -5306,7 +5484,7 @@
                 <a:ea typeface="Helvetica Neue" pitchFamily="34" charset="-122"/>
                 <a:cs typeface="Helvetica Neue" pitchFamily="34" charset="-120"/>
               </a:rPr>
-              <a:t>Canada is a DFARS 225.872 qualifying country — Canadian end products exempt from Buy American in US defence acquisition. Checkable, and underused. US entity planned; US-ready, allied-forward.</a:t>
+              <a:t>Canada is a DFARS 225.872 qualifying country — Canadian end products exempt from Buy American in US defence acquisition.¹³ Checkable, and underused. US entity planned; US-ready, allied-forward.</a:t>
             </a:r>
             <a:endParaRPr lang="en-US" sz="1050" dirty="0"/>
           </a:p>
@@ -5642,7 +5820,7 @@
                 <a:ea typeface="IBM Plex Mono" pitchFamily="34" charset="-122"/>
                 <a:cs typeface="IBM Plex Mono" pitchFamily="34" charset="-120"/>
               </a:rPr>
-              <a:t>PER TON — THE PUBLISHED MARKET RATE FOR CONVENTIONAL DEMIL, TODAY (GAO FY15 / NAS)</a:t>
+              <a:t>PER TON — THE PUBLISHED MARKET RATE FOR CONVENTIONAL DEMIL, TODAY (GAO FY15 / NAS)⁶</a:t>
             </a:r>
             <a:endParaRPr lang="en-US" sz="1050" dirty="0"/>
           </a:p>
@@ -6644,7 +6822,7 @@
                 <a:ea typeface="Helvetica Neue" pitchFamily="34" charset="-122"/>
                 <a:cs typeface="Helvetica Neue" pitchFamily="34" charset="-120"/>
               </a:rPr>
-              <a:t>The EPA is closing open burn / open detonation — 67 facilities targeted. The incumbent method is being outlawed in real time.</a:t>
+              <a:t>The EPA is closing open burn / open detonation — 67 facilities targeted. The incumbent method is being outlawed in real time.⁸</a:t>
             </a:r>
             <a:endParaRPr lang="en-US" sz="1100" dirty="0"/>
           </a:p>
@@ -6750,7 +6928,7 @@
                 <a:ea typeface="Helvetica Neue" pitchFamily="34" charset="-122"/>
                 <a:cs typeface="Helvetica Neue" pitchFamily="34" charset="-120"/>
               </a:rPr>
-              <a:t>Copper, lead and antimony repriced by policy — the output of destruction became strategic feedstock.</a:t>
+              <a:t>Copper, lead and antimony repriced by policy — the output of destruction became strategic feedstock.¹¹</a:t>
             </a:r>
             <a:endParaRPr lang="en-US" sz="1100" dirty="0"/>
           </a:p>
@@ -6856,7 +7034,7 @@
                 <a:ea typeface="Helvetica Neue" pitchFamily="34" charset="-122"/>
                 <a:cs typeface="Helvetica Neue" pitchFamily="34" charset="-120"/>
               </a:rPr>
-              <a:t>The founder generation that holds the capability is retiring — pricing the M&amp;A at 4–7× EBITDA, for now.</a:t>
+              <a:t>The founder generation that holds the capability is retiring — pricing the M&amp;A at 4–7× EBITDA, for now.¹⁷</a:t>
             </a:r>
             <a:endParaRPr lang="en-US" sz="1100" dirty="0"/>
           </a:p>
@@ -7647,6 +7825,2807 @@
 </p:sld>
 </file>
 
+<file path=ppt/slides/slide16.xml><?xml version="1.0" encoding="utf-8"?>
+<p:sld xmlns:a="http://schemas.openxmlformats.org/drawingml/2006/main" xmlns:r="http://schemas.openxmlformats.org/officeDocument/2006/relationships" xmlns:p="http://schemas.openxmlformats.org/presentationml/2006/main">
+  <p:cSld name="Slide 16">
+    <p:bg>
+      <p:bgPr>
+        <a:solidFill>
+          <a:srgbClr val="FFFFFF"/>
+        </a:solidFill>
+      </p:bgPr>
+    </p:bg>
+    <p:spTree>
+      <p:nvGrpSpPr>
+        <p:cNvPr id="1" name=""/>
+        <p:cNvGrpSpPr/>
+        <p:nvPr/>
+      </p:nvGrpSpPr>
+      <p:grpSpPr>
+        <a:xfrm>
+          <a:off x="0" y="0"/>
+          <a:ext cx="0" cy="0"/>
+          <a:chOff x="0" y="0"/>
+          <a:chExt cx="0" cy="0"/>
+        </a:xfrm>
+      </p:grpSpPr>
+      <p:sp>
+        <p:nvSpPr>
+          <p:cNvPr id="2" name="Text 0"/>
+          <p:cNvSpPr txBox="1"/>
+          <p:nvPr/>
+        </p:nvSpPr>
+        <p:spPr>
+          <a:xfrm>
+            <a:off x="640080" y="475488"/>
+            <a:ext cx="10908792" cy="274320"/>
+          </a:xfrm>
+          <a:prstGeom prst="rect">
+            <a:avLst/>
+          </a:prstGeom>
+          <a:noFill/>
+          <a:ln/>
+        </p:spPr>
+        <p:txBody>
+          <a:bodyPr wrap="square" lIns="0" tIns="0" rIns="0" bIns="0" rtlCol="0" anchor="ctr"/>
+          <a:lstStyle/>
+          <a:p>
+            <a:pPr algn="l" indent="0" marL="0">
+              <a:buNone/>
+            </a:pPr>
+            <a:r>
+              <a:rPr lang="en-US" sz="1000" spc="200" kern="0" dirty="0">
+                <a:solidFill>
+                  <a:srgbClr val="6E6C66"/>
+                </a:solidFill>
+                <a:latin typeface="IBM Plex Mono" pitchFamily="34" charset="0"/>
+                <a:ea typeface="IBM Plex Mono" pitchFamily="34" charset="-122"/>
+                <a:cs typeface="IBM Plex Mono" pitchFamily="34" charset="-120"/>
+              </a:rPr>
+              <a:t>SOURCES &amp; CITATIONS — 1 OF 2</a:t>
+            </a:r>
+            <a:endParaRPr lang="en-US" sz="1000" dirty="0"/>
+          </a:p>
+        </p:txBody>
+      </p:sp>
+      <p:sp>
+        <p:nvSpPr>
+          <p:cNvPr id="3" name="Text 1"/>
+          <p:cNvSpPr txBox="1"/>
+          <p:nvPr/>
+        </p:nvSpPr>
+        <p:spPr>
+          <a:xfrm>
+            <a:off x="640080" y="822960"/>
+            <a:ext cx="7863840" cy="548640"/>
+          </a:xfrm>
+          <a:prstGeom prst="rect">
+            <a:avLst/>
+          </a:prstGeom>
+          <a:noFill/>
+          <a:ln/>
+        </p:spPr>
+        <p:txBody>
+          <a:bodyPr wrap="square" lIns="0" tIns="0" rIns="0" bIns="0" rtlCol="0" anchor="ctr"/>
+          <a:lstStyle/>
+          <a:p>
+            <a:pPr indent="0" marL="0">
+              <a:buNone/>
+            </a:pPr>
+            <a:r>
+              <a:rPr lang="en-US" sz="2500" spc="-30" kern="0" dirty="0">
+                <a:solidFill>
+                  <a:srgbClr val="000000"/>
+                </a:solidFill>
+                <a:latin typeface="Helvetica Neue" pitchFamily="34" charset="0"/>
+                <a:ea typeface="Helvetica Neue" pitchFamily="34" charset="-122"/>
+                <a:cs typeface="Helvetica Neue" pitchFamily="34" charset="-120"/>
+              </a:rPr>
+              <a:t>Every number on the page, traceable.</a:t>
+            </a:r>
+            <a:endParaRPr lang="en-US" sz="2500" dirty="0"/>
+          </a:p>
+        </p:txBody>
+      </p:sp>
+      <p:sp>
+        <p:nvSpPr>
+          <p:cNvPr id="4" name="Text 2"/>
+          <p:cNvSpPr txBox="1"/>
+          <p:nvPr/>
+        </p:nvSpPr>
+        <p:spPr>
+          <a:xfrm>
+            <a:off x="640080" y="1389888"/>
+            <a:ext cx="10881360" cy="365760"/>
+          </a:xfrm>
+          <a:prstGeom prst="rect">
+            <a:avLst/>
+          </a:prstGeom>
+          <a:noFill/>
+          <a:ln/>
+        </p:spPr>
+        <p:txBody>
+          <a:bodyPr wrap="square" lIns="0" tIns="0" rIns="0" bIns="0" rtlCol="0" anchor="ctr"/>
+          <a:lstStyle/>
+          <a:p>
+            <a:pPr indent="0" marL="0">
+              <a:buNone/>
+            </a:pPr>
+            <a:r>
+              <a:rPr lang="en-US" sz="1150" b="1" dirty="0">
+                <a:solidFill>
+                  <a:srgbClr val="000000"/>
+                </a:solidFill>
+                <a:latin typeface="Helvetica Neue" pitchFamily="34" charset="0"/>
+                <a:ea typeface="Helvetica Neue" pitchFamily="34" charset="-122"/>
+                <a:cs typeface="Helvetica Neue" pitchFamily="34" charset="-120"/>
+              </a:rPr>
+              <a:t>Superscripts throughout the deck map to this list. </a:t>
+            </a:r>
+            <a:pPr indent="0" marL="0">
+              <a:buNone/>
+            </a:pPr>
+            <a:r>
+              <a:rPr lang="en-US" sz="1150" dirty="0">
+                <a:solidFill>
+                  <a:srgbClr val="33332F"/>
+                </a:solidFill>
+                <a:latin typeface="Helvetica Neue" pitchFamily="34" charset="0"/>
+                <a:ea typeface="Helvetica Neue" pitchFamily="34" charset="-122"/>
+                <a:cs typeface="Helvetica Neue" pitchFamily="34" charset="-120"/>
+              </a:rPr>
+              <a:t>Where a figure is our construction rather than a published one, it is labelled as such on the slide it appears.</a:t>
+            </a:r>
+            <a:endParaRPr lang="en-US" sz="1150" dirty="0"/>
+          </a:p>
+        </p:txBody>
+      </p:sp>
+      <p:sp>
+        <p:nvSpPr>
+          <p:cNvPr id="5" name="Shape 3"/>
+          <p:cNvSpPr/>
+          <p:nvPr/>
+        </p:nvSpPr>
+        <p:spPr>
+          <a:xfrm>
+            <a:off x="640080" y="1874520"/>
+            <a:ext cx="10908792" cy="0"/>
+          </a:xfrm>
+          <a:prstGeom prst="line">
+            <a:avLst/>
+          </a:prstGeom>
+          <a:noFill/>
+          <a:ln w="9525">
+            <a:solidFill>
+              <a:srgbClr val="E2E1DA"/>
+            </a:solidFill>
+            <a:prstDash val="solid"/>
+          </a:ln>
+        </p:spPr>
+      </p:sp>
+      <p:sp>
+        <p:nvSpPr>
+          <p:cNvPr id="6" name="Text 4"/>
+          <p:cNvSpPr txBox="1"/>
+          <p:nvPr/>
+        </p:nvSpPr>
+        <p:spPr>
+          <a:xfrm>
+            <a:off x="640080" y="2084832"/>
+            <a:ext cx="384048" cy="274320"/>
+          </a:xfrm>
+          <a:prstGeom prst="rect">
+            <a:avLst/>
+          </a:prstGeom>
+          <a:noFill/>
+          <a:ln/>
+        </p:spPr>
+        <p:txBody>
+          <a:bodyPr wrap="square" lIns="0" tIns="0" rIns="0" bIns="0" rtlCol="0" anchor="ctr"/>
+          <a:lstStyle/>
+          <a:p>
+            <a:pPr indent="0" marL="0">
+              <a:buNone/>
+            </a:pPr>
+            <a:r>
+              <a:rPr lang="en-US" sz="1100" b="1" dirty="0">
+                <a:solidFill>
+                  <a:srgbClr val="66705F"/>
+                </a:solidFill>
+                <a:latin typeface="IBM Plex Mono" pitchFamily="34" charset="0"/>
+                <a:ea typeface="IBM Plex Mono" pitchFamily="34" charset="-122"/>
+                <a:cs typeface="IBM Plex Mono" pitchFamily="34" charset="-120"/>
+              </a:rPr>
+              <a:t>1</a:t>
+            </a:r>
+            <a:endParaRPr lang="en-US" sz="1100" dirty="0"/>
+          </a:p>
+        </p:txBody>
+      </p:sp>
+      <p:sp>
+        <p:nvSpPr>
+          <p:cNvPr id="7" name="Text 5"/>
+          <p:cNvSpPr txBox="1"/>
+          <p:nvPr/>
+        </p:nvSpPr>
+        <p:spPr>
+          <a:xfrm>
+            <a:off x="1060704" y="2098548"/>
+            <a:ext cx="4782312" cy="219456"/>
+          </a:xfrm>
+          <a:prstGeom prst="rect">
+            <a:avLst/>
+          </a:prstGeom>
+          <a:noFill/>
+          <a:ln/>
+        </p:spPr>
+        <p:txBody>
+          <a:bodyPr wrap="square" lIns="0" tIns="0" rIns="0" bIns="0" rtlCol="0" anchor="ctr"/>
+          <a:lstStyle/>
+          <a:p>
+            <a:pPr indent="0" marL="0">
+              <a:buNone/>
+            </a:pPr>
+            <a:r>
+              <a:rPr lang="en-US" sz="850" b="1" spc="150" kern="0" dirty="0">
+                <a:solidFill>
+                  <a:srgbClr val="000000"/>
+                </a:solidFill>
+                <a:latin typeface="IBM Plex Mono" pitchFamily="34" charset="0"/>
+                <a:ea typeface="IBM Plex Mono" pitchFamily="34" charset="-122"/>
+                <a:cs typeface="IBM Plex Mono" pitchFamily="34" charset="-120"/>
+              </a:rPr>
+              <a:t>SIPRI</a:t>
+            </a:r>
+            <a:endParaRPr lang="en-US" sz="850" dirty="0"/>
+          </a:p>
+        </p:txBody>
+      </p:sp>
+      <p:sp>
+        <p:nvSpPr>
+          <p:cNvPr id="8" name="Text 6"/>
+          <p:cNvSpPr txBox="1"/>
+          <p:nvPr/>
+        </p:nvSpPr>
+        <p:spPr>
+          <a:xfrm>
+            <a:off x="1060704" y="2322576"/>
+            <a:ext cx="4782312" cy="566928"/>
+          </a:xfrm>
+          <a:prstGeom prst="rect">
+            <a:avLst/>
+          </a:prstGeom>
+          <a:noFill/>
+          <a:ln/>
+        </p:spPr>
+        <p:txBody>
+          <a:bodyPr wrap="square" lIns="0" tIns="0" rIns="0" bIns="0" rtlCol="0" anchor="ctr"/>
+          <a:lstStyle/>
+          <a:p>
+            <a:pPr indent="0" marL="0">
+              <a:lnSpc>
+                <a:spcPct val="120000"/>
+              </a:lnSpc>
+              <a:buNone/>
+            </a:pPr>
+            <a:r>
+              <a:rPr lang="en-US" sz="850" dirty="0">
+                <a:solidFill>
+                  <a:srgbClr val="33332F"/>
+                </a:solidFill>
+                <a:latin typeface="Helvetica Neue" pitchFamily="34" charset="0"/>
+                <a:ea typeface="Helvetica Neue" pitchFamily="34" charset="-122"/>
+                <a:cs typeface="Helvetica Neue" pitchFamily="34" charset="-120"/>
+              </a:rPr>
+              <a:t>Trends in World Military Expenditure, 2025. SIPRI Fact Sheet, April 2026. World total US$2,887bn, constant 2024 prices; 11th consecutive annual rise.</a:t>
+            </a:r>
+            <a:endParaRPr lang="en-US" sz="850" dirty="0"/>
+          </a:p>
+        </p:txBody>
+      </p:sp>
+      <p:sp>
+        <p:nvSpPr>
+          <p:cNvPr id="9" name="Text 7"/>
+          <p:cNvSpPr txBox="1"/>
+          <p:nvPr/>
+        </p:nvSpPr>
+        <p:spPr>
+          <a:xfrm>
+            <a:off x="640080" y="2926080"/>
+            <a:ext cx="384048" cy="274320"/>
+          </a:xfrm>
+          <a:prstGeom prst="rect">
+            <a:avLst/>
+          </a:prstGeom>
+          <a:noFill/>
+          <a:ln/>
+        </p:spPr>
+        <p:txBody>
+          <a:bodyPr wrap="square" lIns="0" tIns="0" rIns="0" bIns="0" rtlCol="0" anchor="ctr"/>
+          <a:lstStyle/>
+          <a:p>
+            <a:pPr indent="0" marL="0">
+              <a:buNone/>
+            </a:pPr>
+            <a:r>
+              <a:rPr lang="en-US" sz="1100" b="1" dirty="0">
+                <a:solidFill>
+                  <a:srgbClr val="66705F"/>
+                </a:solidFill>
+                <a:latin typeface="IBM Plex Mono" pitchFamily="34" charset="0"/>
+                <a:ea typeface="IBM Plex Mono" pitchFamily="34" charset="-122"/>
+                <a:cs typeface="IBM Plex Mono" pitchFamily="34" charset="-120"/>
+              </a:rPr>
+              <a:t>2</a:t>
+            </a:r>
+            <a:endParaRPr lang="en-US" sz="1100" dirty="0"/>
+          </a:p>
+        </p:txBody>
+      </p:sp>
+      <p:sp>
+        <p:nvSpPr>
+          <p:cNvPr id="10" name="Text 8"/>
+          <p:cNvSpPr txBox="1"/>
+          <p:nvPr/>
+        </p:nvSpPr>
+        <p:spPr>
+          <a:xfrm>
+            <a:off x="1060704" y="2939796"/>
+            <a:ext cx="4782312" cy="219456"/>
+          </a:xfrm>
+          <a:prstGeom prst="rect">
+            <a:avLst/>
+          </a:prstGeom>
+          <a:noFill/>
+          <a:ln/>
+        </p:spPr>
+        <p:txBody>
+          <a:bodyPr wrap="square" lIns="0" tIns="0" rIns="0" bIns="0" rtlCol="0" anchor="ctr"/>
+          <a:lstStyle/>
+          <a:p>
+            <a:pPr indent="0" marL="0">
+              <a:buNone/>
+            </a:pPr>
+            <a:r>
+              <a:rPr lang="en-US" sz="850" b="1" spc="150" kern="0" dirty="0">
+                <a:solidFill>
+                  <a:srgbClr val="000000"/>
+                </a:solidFill>
+                <a:latin typeface="IBM Plex Mono" pitchFamily="34" charset="0"/>
+                <a:ea typeface="IBM Plex Mono" pitchFamily="34" charset="-122"/>
+                <a:cs typeface="IBM Plex Mono" pitchFamily="34" charset="-120"/>
+              </a:rPr>
+              <a:t>UCDP / PRIO</a:t>
+            </a:r>
+            <a:endParaRPr lang="en-US" sz="850" dirty="0"/>
+          </a:p>
+        </p:txBody>
+      </p:sp>
+      <p:sp>
+        <p:nvSpPr>
+          <p:cNvPr id="11" name="Text 9"/>
+          <p:cNvSpPr txBox="1"/>
+          <p:nvPr/>
+        </p:nvSpPr>
+        <p:spPr>
+          <a:xfrm>
+            <a:off x="1060704" y="3163824"/>
+            <a:ext cx="4782312" cy="566928"/>
+          </a:xfrm>
+          <a:prstGeom prst="rect">
+            <a:avLst/>
+          </a:prstGeom>
+          <a:noFill/>
+          <a:ln/>
+        </p:spPr>
+        <p:txBody>
+          <a:bodyPr wrap="square" lIns="0" tIns="0" rIns="0" bIns="0" rtlCol="0" anchor="ctr"/>
+          <a:lstStyle/>
+          <a:p>
+            <a:pPr indent="0" marL="0">
+              <a:lnSpc>
+                <a:spcPct val="120000"/>
+              </a:lnSpc>
+              <a:buNone/>
+            </a:pPr>
+            <a:r>
+              <a:rPr lang="en-US" sz="850" dirty="0">
+                <a:solidFill>
+                  <a:srgbClr val="33332F"/>
+                </a:solidFill>
+                <a:latin typeface="Helvetica Neue" pitchFamily="34" charset="0"/>
+                <a:ea typeface="Helvetica Neue" pitchFamily="34" charset="-122"/>
+                <a:cs typeface="Helvetica Neue" pitchFamily="34" charset="-120"/>
+              </a:rPr>
+              <a:t>UCDP–PRIO Armed Conflict Dataset v26.1 (Uppsala Conflict Data Program, 2026); Davies, Pettersson &amp; Öberg, “Organized violence 1989–2025”, Journal of Peace Research, 2026. 65 state-based armed conflicts in 2025, the highest since records began in 1946. Regional series via Our World in Data.</a:t>
+            </a:r>
+            <a:endParaRPr lang="en-US" sz="850" dirty="0"/>
+          </a:p>
+        </p:txBody>
+      </p:sp>
+      <p:sp>
+        <p:nvSpPr>
+          <p:cNvPr id="12" name="Text 10"/>
+          <p:cNvSpPr txBox="1"/>
+          <p:nvPr/>
+        </p:nvSpPr>
+        <p:spPr>
+          <a:xfrm>
+            <a:off x="640080" y="3767328"/>
+            <a:ext cx="384048" cy="274320"/>
+          </a:xfrm>
+          <a:prstGeom prst="rect">
+            <a:avLst/>
+          </a:prstGeom>
+          <a:noFill/>
+          <a:ln/>
+        </p:spPr>
+        <p:txBody>
+          <a:bodyPr wrap="square" lIns="0" tIns="0" rIns="0" bIns="0" rtlCol="0" anchor="ctr"/>
+          <a:lstStyle/>
+          <a:p>
+            <a:pPr indent="0" marL="0">
+              <a:buNone/>
+            </a:pPr>
+            <a:r>
+              <a:rPr lang="en-US" sz="1100" b="1" dirty="0">
+                <a:solidFill>
+                  <a:srgbClr val="66705F"/>
+                </a:solidFill>
+                <a:latin typeface="IBM Plex Mono" pitchFamily="34" charset="0"/>
+                <a:ea typeface="IBM Plex Mono" pitchFamily="34" charset="-122"/>
+                <a:cs typeface="IBM Plex Mono" pitchFamily="34" charset="-120"/>
+              </a:rPr>
+              <a:t>3</a:t>
+            </a:r>
+            <a:endParaRPr lang="en-US" sz="1100" dirty="0"/>
+          </a:p>
+        </p:txBody>
+      </p:sp>
+      <p:sp>
+        <p:nvSpPr>
+          <p:cNvPr id="13" name="Text 11"/>
+          <p:cNvSpPr txBox="1"/>
+          <p:nvPr/>
+        </p:nvSpPr>
+        <p:spPr>
+          <a:xfrm>
+            <a:off x="1060704" y="3781044"/>
+            <a:ext cx="4782312" cy="219456"/>
+          </a:xfrm>
+          <a:prstGeom prst="rect">
+            <a:avLst/>
+          </a:prstGeom>
+          <a:noFill/>
+          <a:ln/>
+        </p:spPr>
+        <p:txBody>
+          <a:bodyPr wrap="square" lIns="0" tIns="0" rIns="0" bIns="0" rtlCol="0" anchor="ctr"/>
+          <a:lstStyle/>
+          <a:p>
+            <a:pPr indent="0" marL="0">
+              <a:buNone/>
+            </a:pPr>
+            <a:r>
+              <a:rPr lang="en-US" sz="850" b="1" spc="150" kern="0" dirty="0">
+                <a:solidFill>
+                  <a:srgbClr val="000000"/>
+                </a:solidFill>
+                <a:latin typeface="IBM Plex Mono" pitchFamily="34" charset="0"/>
+                <a:ea typeface="IBM Plex Mono" pitchFamily="34" charset="-122"/>
+                <a:cs typeface="IBM Plex Mono" pitchFamily="34" charset="-120"/>
+              </a:rPr>
+              <a:t>SIPRI</a:t>
+            </a:r>
+            <a:endParaRPr lang="en-US" sz="850" dirty="0"/>
+          </a:p>
+        </p:txBody>
+      </p:sp>
+      <p:sp>
+        <p:nvSpPr>
+          <p:cNvPr id="14" name="Text 12"/>
+          <p:cNvSpPr txBox="1"/>
+          <p:nvPr/>
+        </p:nvSpPr>
+        <p:spPr>
+          <a:xfrm>
+            <a:off x="1060704" y="4005072"/>
+            <a:ext cx="4782312" cy="566928"/>
+          </a:xfrm>
+          <a:prstGeom prst="rect">
+            <a:avLst/>
+          </a:prstGeom>
+          <a:noFill/>
+          <a:ln/>
+        </p:spPr>
+        <p:txBody>
+          <a:bodyPr wrap="square" lIns="0" tIns="0" rIns="0" bIns="0" rtlCol="0" anchor="ctr"/>
+          <a:lstStyle/>
+          <a:p>
+            <a:pPr indent="0" marL="0">
+              <a:lnSpc>
+                <a:spcPct val="120000"/>
+              </a:lnSpc>
+              <a:buNone/>
+            </a:pPr>
+            <a:r>
+              <a:rPr lang="en-US" sz="850" dirty="0">
+                <a:solidFill>
+                  <a:srgbClr val="33332F"/>
+                </a:solidFill>
+                <a:latin typeface="Helvetica Neue" pitchFamily="34" charset="0"/>
+                <a:ea typeface="Helvetica Neue" pitchFamily="34" charset="-122"/>
+                <a:cs typeface="Helvetica Neue" pitchFamily="34" charset="-120"/>
+              </a:rPr>
+              <a:t>SIPRI Arms Industry Database — Top 100 arms-producing and military services companies, 2002–24 workbook, retrieved December 2025. Constant 2024 US$. Regional totals aggregated by headquarters country — TWB calculation, not a SIPRI-published breakdown; reconciles to SIPRI totals within rounding.</a:t>
+            </a:r>
+            <a:endParaRPr lang="en-US" sz="850" dirty="0"/>
+          </a:p>
+        </p:txBody>
+      </p:sp>
+      <p:sp>
+        <p:nvSpPr>
+          <p:cNvPr id="15" name="Text 13"/>
+          <p:cNvSpPr txBox="1"/>
+          <p:nvPr/>
+        </p:nvSpPr>
+        <p:spPr>
+          <a:xfrm>
+            <a:off x="640080" y="4608576"/>
+            <a:ext cx="384048" cy="274320"/>
+          </a:xfrm>
+          <a:prstGeom prst="rect">
+            <a:avLst/>
+          </a:prstGeom>
+          <a:noFill/>
+          <a:ln/>
+        </p:spPr>
+        <p:txBody>
+          <a:bodyPr wrap="square" lIns="0" tIns="0" rIns="0" bIns="0" rtlCol="0" anchor="ctr"/>
+          <a:lstStyle/>
+          <a:p>
+            <a:pPr indent="0" marL="0">
+              <a:buNone/>
+            </a:pPr>
+            <a:r>
+              <a:rPr lang="en-US" sz="1100" b="1" dirty="0">
+                <a:solidFill>
+                  <a:srgbClr val="66705F"/>
+                </a:solidFill>
+                <a:latin typeface="IBM Plex Mono" pitchFamily="34" charset="0"/>
+                <a:ea typeface="IBM Plex Mono" pitchFamily="34" charset="-122"/>
+                <a:cs typeface="IBM Plex Mono" pitchFamily="34" charset="-120"/>
+              </a:rPr>
+              <a:t>4</a:t>
+            </a:r>
+            <a:endParaRPr lang="en-US" sz="1100" dirty="0"/>
+          </a:p>
+        </p:txBody>
+      </p:sp>
+      <p:sp>
+        <p:nvSpPr>
+          <p:cNvPr id="16" name="Text 14"/>
+          <p:cNvSpPr txBox="1"/>
+          <p:nvPr/>
+        </p:nvSpPr>
+        <p:spPr>
+          <a:xfrm>
+            <a:off x="1060704" y="4622292"/>
+            <a:ext cx="4782312" cy="219456"/>
+          </a:xfrm>
+          <a:prstGeom prst="rect">
+            <a:avLst/>
+          </a:prstGeom>
+          <a:noFill/>
+          <a:ln/>
+        </p:spPr>
+        <p:txBody>
+          <a:bodyPr wrap="square" lIns="0" tIns="0" rIns="0" bIns="0" rtlCol="0" anchor="ctr"/>
+          <a:lstStyle/>
+          <a:p>
+            <a:pPr indent="0" marL="0">
+              <a:buNone/>
+            </a:pPr>
+            <a:r>
+              <a:rPr lang="en-US" sz="850" b="1" spc="150" kern="0" dirty="0">
+                <a:solidFill>
+                  <a:srgbClr val="000000"/>
+                </a:solidFill>
+                <a:latin typeface="IBM Plex Mono" pitchFamily="34" charset="0"/>
+                <a:ea typeface="IBM Plex Mono" pitchFamily="34" charset="-122"/>
+                <a:cs typeface="IBM Plex Mono" pitchFamily="34" charset="-120"/>
+              </a:rPr>
+              <a:t>RHEINMETALL AG</a:t>
+            </a:r>
+            <a:endParaRPr lang="en-US" sz="850" dirty="0"/>
+          </a:p>
+        </p:txBody>
+      </p:sp>
+      <p:sp>
+        <p:nvSpPr>
+          <p:cNvPr id="17" name="Text 15"/>
+          <p:cNvSpPr txBox="1"/>
+          <p:nvPr/>
+        </p:nvSpPr>
+        <p:spPr>
+          <a:xfrm>
+            <a:off x="1060704" y="4846320"/>
+            <a:ext cx="4782312" cy="566928"/>
+          </a:xfrm>
+          <a:prstGeom prst="rect">
+            <a:avLst/>
+          </a:prstGeom>
+          <a:noFill/>
+          <a:ln/>
+        </p:spPr>
+        <p:txBody>
+          <a:bodyPr wrap="square" lIns="0" tIns="0" rIns="0" bIns="0" rtlCol="0" anchor="ctr"/>
+          <a:lstStyle/>
+          <a:p>
+            <a:pPr indent="0" marL="0">
+              <a:lnSpc>
+                <a:spcPct val="120000"/>
+              </a:lnSpc>
+              <a:buNone/>
+            </a:pPr>
+            <a:r>
+              <a:rPr lang="en-US" sz="850" dirty="0">
+                <a:solidFill>
+                  <a:srgbClr val="33332F"/>
+                </a:solidFill>
+                <a:latin typeface="Helvetica Neue" pitchFamily="34" charset="0"/>
+                <a:ea typeface="Helvetica Neue" pitchFamily="34" charset="-122"/>
+                <a:cs typeface="Helvetica Neue" pitchFamily="34" charset="-120"/>
+              </a:rPr>
+              <a:t>Publicly stated 155mm artillery ammunition capacity target of 1.5 million rounds per year by 2027.</a:t>
+            </a:r>
+            <a:endParaRPr lang="en-US" sz="850" dirty="0"/>
+          </a:p>
+        </p:txBody>
+      </p:sp>
+      <p:sp>
+        <p:nvSpPr>
+          <p:cNvPr id="18" name="Text 16"/>
+          <p:cNvSpPr txBox="1"/>
+          <p:nvPr/>
+        </p:nvSpPr>
+        <p:spPr>
+          <a:xfrm>
+            <a:off x="640080" y="5449824"/>
+            <a:ext cx="384048" cy="274320"/>
+          </a:xfrm>
+          <a:prstGeom prst="rect">
+            <a:avLst/>
+          </a:prstGeom>
+          <a:noFill/>
+          <a:ln/>
+        </p:spPr>
+        <p:txBody>
+          <a:bodyPr wrap="square" lIns="0" tIns="0" rIns="0" bIns="0" rtlCol="0" anchor="ctr"/>
+          <a:lstStyle/>
+          <a:p>
+            <a:pPr indent="0" marL="0">
+              <a:buNone/>
+            </a:pPr>
+            <a:r>
+              <a:rPr lang="en-US" sz="1100" b="1" dirty="0">
+                <a:solidFill>
+                  <a:srgbClr val="66705F"/>
+                </a:solidFill>
+                <a:latin typeface="IBM Plex Mono" pitchFamily="34" charset="0"/>
+                <a:ea typeface="IBM Plex Mono" pitchFamily="34" charset="-122"/>
+                <a:cs typeface="IBM Plex Mono" pitchFamily="34" charset="-120"/>
+              </a:rPr>
+              <a:t>5</a:t>
+            </a:r>
+            <a:endParaRPr lang="en-US" sz="1100" dirty="0"/>
+          </a:p>
+        </p:txBody>
+      </p:sp>
+      <p:sp>
+        <p:nvSpPr>
+          <p:cNvPr id="19" name="Text 17"/>
+          <p:cNvSpPr txBox="1"/>
+          <p:nvPr/>
+        </p:nvSpPr>
+        <p:spPr>
+          <a:xfrm>
+            <a:off x="1060704" y="5463540"/>
+            <a:ext cx="4782312" cy="219456"/>
+          </a:xfrm>
+          <a:prstGeom prst="rect">
+            <a:avLst/>
+          </a:prstGeom>
+          <a:noFill/>
+          <a:ln/>
+        </p:spPr>
+        <p:txBody>
+          <a:bodyPr wrap="square" lIns="0" tIns="0" rIns="0" bIns="0" rtlCol="0" anchor="ctr"/>
+          <a:lstStyle/>
+          <a:p>
+            <a:pPr indent="0" marL="0">
+              <a:buNone/>
+            </a:pPr>
+            <a:r>
+              <a:rPr lang="en-US" sz="850" b="1" spc="150" kern="0" dirty="0">
+                <a:solidFill>
+                  <a:srgbClr val="000000"/>
+                </a:solidFill>
+                <a:latin typeface="IBM Plex Mono" pitchFamily="34" charset="0"/>
+                <a:ea typeface="IBM Plex Mono" pitchFamily="34" charset="-122"/>
+                <a:cs typeface="IBM Plex Mono" pitchFamily="34" charset="-120"/>
+              </a:rPr>
+              <a:t>US ARMY</a:t>
+            </a:r>
+            <a:endParaRPr lang="en-US" sz="850" dirty="0"/>
+          </a:p>
+        </p:txBody>
+      </p:sp>
+      <p:sp>
+        <p:nvSpPr>
+          <p:cNvPr id="20" name="Text 18"/>
+          <p:cNvSpPr txBox="1"/>
+          <p:nvPr/>
+        </p:nvSpPr>
+        <p:spPr>
+          <a:xfrm>
+            <a:off x="1060704" y="5687568"/>
+            <a:ext cx="4782312" cy="566928"/>
+          </a:xfrm>
+          <a:prstGeom prst="rect">
+            <a:avLst/>
+          </a:prstGeom>
+          <a:noFill/>
+          <a:ln/>
+        </p:spPr>
+        <p:txBody>
+          <a:bodyPr wrap="square" lIns="0" tIns="0" rIns="0" bIns="0" rtlCol="0" anchor="ctr"/>
+          <a:lstStyle/>
+          <a:p>
+            <a:pPr indent="0" marL="0">
+              <a:lnSpc>
+                <a:spcPct val="120000"/>
+              </a:lnSpc>
+              <a:buNone/>
+            </a:pPr>
+            <a:r>
+              <a:rPr lang="en-US" sz="850" dirty="0">
+                <a:solidFill>
+                  <a:srgbClr val="33332F"/>
+                </a:solidFill>
+                <a:latin typeface="Helvetica Neue" pitchFamily="34" charset="0"/>
+                <a:ea typeface="Helvetica Neue" pitchFamily="34" charset="-122"/>
+                <a:cs typeface="Helvetica Neue" pitchFamily="34" charset="-120"/>
+              </a:rPr>
+              <a:t>FY2026 President’s Budget, Procurement of Ammunition justification book (June 2025), line 4099EP1700: as of 30 January 2025 the SMCA Resource, Recovery and Disposition Account (B5A) held 309,065 tons — 260,032 tons conventional ammunition and 49,033 tons missile components. “Over 7,000 items” per Army AL&amp;T, Fall 2024, and National Academies (2019).</a:t>
+            </a:r>
+            <a:endParaRPr lang="en-US" sz="850" dirty="0"/>
+          </a:p>
+        </p:txBody>
+      </p:sp>
+      <p:sp>
+        <p:nvSpPr>
+          <p:cNvPr id="21" name="Text 19"/>
+          <p:cNvSpPr txBox="1"/>
+          <p:nvPr/>
+        </p:nvSpPr>
+        <p:spPr>
+          <a:xfrm>
+            <a:off x="6345936" y="2084832"/>
+            <a:ext cx="384048" cy="274320"/>
+          </a:xfrm>
+          <a:prstGeom prst="rect">
+            <a:avLst/>
+          </a:prstGeom>
+          <a:noFill/>
+          <a:ln/>
+        </p:spPr>
+        <p:txBody>
+          <a:bodyPr wrap="square" lIns="0" tIns="0" rIns="0" bIns="0" rtlCol="0" anchor="ctr"/>
+          <a:lstStyle/>
+          <a:p>
+            <a:pPr indent="0" marL="0">
+              <a:buNone/>
+            </a:pPr>
+            <a:r>
+              <a:rPr lang="en-US" sz="1100" b="1" dirty="0">
+                <a:solidFill>
+                  <a:srgbClr val="66705F"/>
+                </a:solidFill>
+                <a:latin typeface="IBM Plex Mono" pitchFamily="34" charset="0"/>
+                <a:ea typeface="IBM Plex Mono" pitchFamily="34" charset="-122"/>
+                <a:cs typeface="IBM Plex Mono" pitchFamily="34" charset="-120"/>
+              </a:rPr>
+              <a:t>6</a:t>
+            </a:r>
+            <a:endParaRPr lang="en-US" sz="1100" dirty="0"/>
+          </a:p>
+        </p:txBody>
+      </p:sp>
+      <p:sp>
+        <p:nvSpPr>
+          <p:cNvPr id="22" name="Text 20"/>
+          <p:cNvSpPr txBox="1"/>
+          <p:nvPr/>
+        </p:nvSpPr>
+        <p:spPr>
+          <a:xfrm>
+            <a:off x="6766560" y="2098548"/>
+            <a:ext cx="4782312" cy="219456"/>
+          </a:xfrm>
+          <a:prstGeom prst="rect">
+            <a:avLst/>
+          </a:prstGeom>
+          <a:noFill/>
+          <a:ln/>
+        </p:spPr>
+        <p:txBody>
+          <a:bodyPr wrap="square" lIns="0" tIns="0" rIns="0" bIns="0" rtlCol="0" anchor="ctr"/>
+          <a:lstStyle/>
+          <a:p>
+            <a:pPr indent="0" marL="0">
+              <a:buNone/>
+            </a:pPr>
+            <a:r>
+              <a:rPr lang="en-US" sz="850" b="1" spc="150" kern="0" dirty="0">
+                <a:solidFill>
+                  <a:srgbClr val="000000"/>
+                </a:solidFill>
+                <a:latin typeface="IBM Plex Mono" pitchFamily="34" charset="0"/>
+                <a:ea typeface="IBM Plex Mono" pitchFamily="34" charset="-122"/>
+                <a:cs typeface="IBM Plex Mono" pitchFamily="34" charset="-120"/>
+              </a:rPr>
+              <a:t>US GAO / NAS</a:t>
+            </a:r>
+            <a:endParaRPr lang="en-US" sz="850" dirty="0"/>
+          </a:p>
+        </p:txBody>
+      </p:sp>
+      <p:sp>
+        <p:nvSpPr>
+          <p:cNvPr id="23" name="Text 21"/>
+          <p:cNvSpPr txBox="1"/>
+          <p:nvPr/>
+        </p:nvSpPr>
+        <p:spPr>
+          <a:xfrm>
+            <a:off x="6766560" y="2322576"/>
+            <a:ext cx="4782312" cy="566928"/>
+          </a:xfrm>
+          <a:prstGeom prst="rect">
+            <a:avLst/>
+          </a:prstGeom>
+          <a:noFill/>
+          <a:ln/>
+        </p:spPr>
+        <p:txBody>
+          <a:bodyPr wrap="square" lIns="0" tIns="0" rIns="0" bIns="0" rtlCol="0" anchor="ctr"/>
+          <a:lstStyle/>
+          <a:p>
+            <a:pPr indent="0" marL="0">
+              <a:lnSpc>
+                <a:spcPct val="120000"/>
+              </a:lnSpc>
+              <a:buNone/>
+            </a:pPr>
+            <a:r>
+              <a:rPr lang="en-US" sz="850" dirty="0">
+                <a:solidFill>
+                  <a:srgbClr val="33332F"/>
+                </a:solidFill>
+                <a:latin typeface="Helvetica Neue" pitchFamily="34" charset="0"/>
+                <a:ea typeface="Helvetica Neue" pitchFamily="34" charset="-122"/>
+                <a:cs typeface="Helvetica Neue" pitchFamily="34" charset="-120"/>
+              </a:rPr>
+              <a:t>US Government Accountability Office (FY2015) and National Academies of Sciences, Engineering and Medicine — published conventional demilitarization cost of approximately US$2,000–2,890 per ton.</a:t>
+            </a:r>
+            <a:endParaRPr lang="en-US" sz="850" dirty="0"/>
+          </a:p>
+        </p:txBody>
+      </p:sp>
+      <p:sp>
+        <p:nvSpPr>
+          <p:cNvPr id="24" name="Text 22"/>
+          <p:cNvSpPr txBox="1"/>
+          <p:nvPr/>
+        </p:nvSpPr>
+        <p:spPr>
+          <a:xfrm>
+            <a:off x="6345936" y="2926080"/>
+            <a:ext cx="384048" cy="274320"/>
+          </a:xfrm>
+          <a:prstGeom prst="rect">
+            <a:avLst/>
+          </a:prstGeom>
+          <a:noFill/>
+          <a:ln/>
+        </p:spPr>
+        <p:txBody>
+          <a:bodyPr wrap="square" lIns="0" tIns="0" rIns="0" bIns="0" rtlCol="0" anchor="ctr"/>
+          <a:lstStyle/>
+          <a:p>
+            <a:pPr indent="0" marL="0">
+              <a:buNone/>
+            </a:pPr>
+            <a:r>
+              <a:rPr lang="en-US" sz="1100" b="1" dirty="0">
+                <a:solidFill>
+                  <a:srgbClr val="66705F"/>
+                </a:solidFill>
+                <a:latin typeface="IBM Plex Mono" pitchFamily="34" charset="0"/>
+                <a:ea typeface="IBM Plex Mono" pitchFamily="34" charset="-122"/>
+                <a:cs typeface="IBM Plex Mono" pitchFamily="34" charset="-120"/>
+              </a:rPr>
+              <a:t>7</a:t>
+            </a:r>
+            <a:endParaRPr lang="en-US" sz="1100" dirty="0"/>
+          </a:p>
+        </p:txBody>
+      </p:sp>
+      <p:sp>
+        <p:nvSpPr>
+          <p:cNvPr id="25" name="Text 23"/>
+          <p:cNvSpPr txBox="1"/>
+          <p:nvPr/>
+        </p:nvSpPr>
+        <p:spPr>
+          <a:xfrm>
+            <a:off x="6766560" y="2939796"/>
+            <a:ext cx="4782312" cy="219456"/>
+          </a:xfrm>
+          <a:prstGeom prst="rect">
+            <a:avLst/>
+          </a:prstGeom>
+          <a:noFill/>
+          <a:ln/>
+        </p:spPr>
+        <p:txBody>
+          <a:bodyPr wrap="square" lIns="0" tIns="0" rIns="0" bIns="0" rtlCol="0" anchor="ctr"/>
+          <a:lstStyle/>
+          <a:p>
+            <a:pPr indent="0" marL="0">
+              <a:buNone/>
+            </a:pPr>
+            <a:r>
+              <a:rPr lang="en-US" sz="850" b="1" spc="150" kern="0" dirty="0">
+                <a:solidFill>
+                  <a:srgbClr val="000000"/>
+                </a:solidFill>
+                <a:latin typeface="IBM Plex Mono" pitchFamily="34" charset="0"/>
+                <a:ea typeface="IBM Plex Mono" pitchFamily="34" charset="-122"/>
+                <a:cs typeface="IBM Plex Mono" pitchFamily="34" charset="-120"/>
+              </a:rPr>
+              <a:t>LASD</a:t>
+            </a:r>
+            <a:endParaRPr lang="en-US" sz="850" dirty="0"/>
+          </a:p>
+        </p:txBody>
+      </p:sp>
+      <p:sp>
+        <p:nvSpPr>
+          <p:cNvPr id="26" name="Text 24"/>
+          <p:cNvSpPr txBox="1"/>
+          <p:nvPr/>
+        </p:nvSpPr>
+        <p:spPr>
+          <a:xfrm>
+            <a:off x="6766560" y="3163824"/>
+            <a:ext cx="4782312" cy="566928"/>
+          </a:xfrm>
+          <a:prstGeom prst="rect">
+            <a:avLst/>
+          </a:prstGeom>
+          <a:noFill/>
+          <a:ln/>
+        </p:spPr>
+        <p:txBody>
+          <a:bodyPr wrap="square" lIns="0" tIns="0" rIns="0" bIns="0" rtlCol="0" anchor="ctr"/>
+          <a:lstStyle/>
+          <a:p>
+            <a:pPr indent="0" marL="0">
+              <a:lnSpc>
+                <a:spcPct val="120000"/>
+              </a:lnSpc>
+              <a:buNone/>
+            </a:pPr>
+            <a:r>
+              <a:rPr lang="en-US" sz="850" dirty="0">
+                <a:solidFill>
+                  <a:srgbClr val="33332F"/>
+                </a:solidFill>
+                <a:latin typeface="Helvetica Neue" pitchFamily="34" charset="0"/>
+                <a:ea typeface="Helvetica Neue" pitchFamily="34" charset="-122"/>
+                <a:cs typeface="Helvetica Neue" pitchFamily="34" charset="-120"/>
+              </a:rPr>
+              <a:t>Los Angeles County Sheriff’s Department — incident of 18 July 2025; three detectives killed while processing seized ordnance.</a:t>
+            </a:r>
+            <a:endParaRPr lang="en-US" sz="850" dirty="0"/>
+          </a:p>
+        </p:txBody>
+      </p:sp>
+      <p:sp>
+        <p:nvSpPr>
+          <p:cNvPr id="27" name="Text 25"/>
+          <p:cNvSpPr txBox="1"/>
+          <p:nvPr/>
+        </p:nvSpPr>
+        <p:spPr>
+          <a:xfrm>
+            <a:off x="6345936" y="3767328"/>
+            <a:ext cx="384048" cy="274320"/>
+          </a:xfrm>
+          <a:prstGeom prst="rect">
+            <a:avLst/>
+          </a:prstGeom>
+          <a:noFill/>
+          <a:ln/>
+        </p:spPr>
+        <p:txBody>
+          <a:bodyPr wrap="square" lIns="0" tIns="0" rIns="0" bIns="0" rtlCol="0" anchor="ctr"/>
+          <a:lstStyle/>
+          <a:p>
+            <a:pPr indent="0" marL="0">
+              <a:buNone/>
+            </a:pPr>
+            <a:r>
+              <a:rPr lang="en-US" sz="1100" b="1" dirty="0">
+                <a:solidFill>
+                  <a:srgbClr val="66705F"/>
+                </a:solidFill>
+                <a:latin typeface="IBM Plex Mono" pitchFamily="34" charset="0"/>
+                <a:ea typeface="IBM Plex Mono" pitchFamily="34" charset="-122"/>
+                <a:cs typeface="IBM Plex Mono" pitchFamily="34" charset="-120"/>
+              </a:rPr>
+              <a:t>8</a:t>
+            </a:r>
+            <a:endParaRPr lang="en-US" sz="1100" dirty="0"/>
+          </a:p>
+        </p:txBody>
+      </p:sp>
+      <p:sp>
+        <p:nvSpPr>
+          <p:cNvPr id="28" name="Text 26"/>
+          <p:cNvSpPr txBox="1"/>
+          <p:nvPr/>
+        </p:nvSpPr>
+        <p:spPr>
+          <a:xfrm>
+            <a:off x="6766560" y="3781044"/>
+            <a:ext cx="4782312" cy="219456"/>
+          </a:xfrm>
+          <a:prstGeom prst="rect">
+            <a:avLst/>
+          </a:prstGeom>
+          <a:noFill/>
+          <a:ln/>
+        </p:spPr>
+        <p:txBody>
+          <a:bodyPr wrap="square" lIns="0" tIns="0" rIns="0" bIns="0" rtlCol="0" anchor="ctr"/>
+          <a:lstStyle/>
+          <a:p>
+            <a:pPr indent="0" marL="0">
+              <a:buNone/>
+            </a:pPr>
+            <a:r>
+              <a:rPr lang="en-US" sz="850" b="1" spc="150" kern="0" dirty="0">
+                <a:solidFill>
+                  <a:srgbClr val="000000"/>
+                </a:solidFill>
+                <a:latin typeface="IBM Plex Mono" pitchFamily="34" charset="0"/>
+                <a:ea typeface="IBM Plex Mono" pitchFamily="34" charset="-122"/>
+                <a:cs typeface="IBM Plex Mono" pitchFamily="34" charset="-120"/>
+              </a:rPr>
+              <a:t>US EPA</a:t>
+            </a:r>
+            <a:endParaRPr lang="en-US" sz="850" dirty="0"/>
+          </a:p>
+        </p:txBody>
+      </p:sp>
+      <p:sp>
+        <p:nvSpPr>
+          <p:cNvPr id="29" name="Text 27"/>
+          <p:cNvSpPr txBox="1"/>
+          <p:nvPr/>
+        </p:nvSpPr>
+        <p:spPr>
+          <a:xfrm>
+            <a:off x="6766560" y="4005072"/>
+            <a:ext cx="4782312" cy="566928"/>
+          </a:xfrm>
+          <a:prstGeom prst="rect">
+            <a:avLst/>
+          </a:prstGeom>
+          <a:noFill/>
+          <a:ln/>
+        </p:spPr>
+        <p:txBody>
+          <a:bodyPr wrap="square" lIns="0" tIns="0" rIns="0" bIns="0" rtlCol="0" anchor="ctr"/>
+          <a:lstStyle/>
+          <a:p>
+            <a:pPr indent="0" marL="0">
+              <a:lnSpc>
+                <a:spcPct val="120000"/>
+              </a:lnSpc>
+              <a:buNone/>
+            </a:pPr>
+            <a:r>
+              <a:rPr lang="en-US" sz="850" dirty="0">
+                <a:solidFill>
+                  <a:srgbClr val="33332F"/>
+                </a:solidFill>
+                <a:latin typeface="Helvetica Neue" pitchFamily="34" charset="0"/>
+                <a:ea typeface="Helvetica Neue" pitchFamily="34" charset="-122"/>
+                <a:cs typeface="Helvetica Neue" pitchFamily="34" charset="-120"/>
+              </a:rPr>
+              <a:t>Proposed rule, 89 FR 19952 — open burning / open detonation of waste explosives; 67 US facilities identified.</a:t>
+            </a:r>
+            <a:endParaRPr lang="en-US" sz="850" dirty="0"/>
+          </a:p>
+        </p:txBody>
+      </p:sp>
+      <p:sp>
+        <p:nvSpPr>
+          <p:cNvPr id="30" name="Text 28"/>
+          <p:cNvSpPr txBox="1"/>
+          <p:nvPr/>
+        </p:nvSpPr>
+        <p:spPr>
+          <a:xfrm>
+            <a:off x="6345936" y="4608576"/>
+            <a:ext cx="384048" cy="274320"/>
+          </a:xfrm>
+          <a:prstGeom prst="rect">
+            <a:avLst/>
+          </a:prstGeom>
+          <a:noFill/>
+          <a:ln/>
+        </p:spPr>
+        <p:txBody>
+          <a:bodyPr wrap="square" lIns="0" tIns="0" rIns="0" bIns="0" rtlCol="0" anchor="ctr"/>
+          <a:lstStyle/>
+          <a:p>
+            <a:pPr indent="0" marL="0">
+              <a:buNone/>
+            </a:pPr>
+            <a:r>
+              <a:rPr lang="en-US" sz="1100" b="1" dirty="0">
+                <a:solidFill>
+                  <a:srgbClr val="66705F"/>
+                </a:solidFill>
+                <a:latin typeface="IBM Plex Mono" pitchFamily="34" charset="0"/>
+                <a:ea typeface="IBM Plex Mono" pitchFamily="34" charset="-122"/>
+                <a:cs typeface="IBM Plex Mono" pitchFamily="34" charset="-120"/>
+              </a:rPr>
+              <a:t>9</a:t>
+            </a:r>
+            <a:endParaRPr lang="en-US" sz="1100" dirty="0"/>
+          </a:p>
+        </p:txBody>
+      </p:sp>
+      <p:sp>
+        <p:nvSpPr>
+          <p:cNvPr id="31" name="Text 29"/>
+          <p:cNvSpPr txBox="1"/>
+          <p:nvPr/>
+        </p:nvSpPr>
+        <p:spPr>
+          <a:xfrm>
+            <a:off x="6766560" y="4622292"/>
+            <a:ext cx="4782312" cy="219456"/>
+          </a:xfrm>
+          <a:prstGeom prst="rect">
+            <a:avLst/>
+          </a:prstGeom>
+          <a:noFill/>
+          <a:ln/>
+        </p:spPr>
+        <p:txBody>
+          <a:bodyPr wrap="square" lIns="0" tIns="0" rIns="0" bIns="0" rtlCol="0" anchor="ctr"/>
+          <a:lstStyle/>
+          <a:p>
+            <a:pPr indent="0" marL="0">
+              <a:buNone/>
+            </a:pPr>
+            <a:r>
+              <a:rPr lang="en-US" sz="850" b="1" spc="150" kern="0" dirty="0">
+                <a:solidFill>
+                  <a:srgbClr val="000000"/>
+                </a:solidFill>
+                <a:latin typeface="IBM Plex Mono" pitchFamily="34" charset="0"/>
+                <a:ea typeface="IBM Plex Mono" pitchFamily="34" charset="-122"/>
+                <a:cs typeface="IBM Plex Mono" pitchFamily="34" charset="-120"/>
+              </a:rPr>
+              <a:t>INDUSTRY / AGENCY REPORTING</a:t>
+            </a:r>
+            <a:endParaRPr lang="en-US" sz="850" dirty="0"/>
+          </a:p>
+        </p:txBody>
+      </p:sp>
+      <p:sp>
+        <p:nvSpPr>
+          <p:cNvPr id="32" name="Text 30"/>
+          <p:cNvSpPr txBox="1"/>
+          <p:nvPr/>
+        </p:nvSpPr>
+        <p:spPr>
+          <a:xfrm>
+            <a:off x="6766560" y="4846320"/>
+            <a:ext cx="4782312" cy="566928"/>
+          </a:xfrm>
+          <a:prstGeom prst="rect">
+            <a:avLst/>
+          </a:prstGeom>
+          <a:noFill/>
+          <a:ln/>
+        </p:spPr>
+        <p:txBody>
+          <a:bodyPr wrap="square" lIns="0" tIns="0" rIns="0" bIns="0" rtlCol="0" anchor="ctr"/>
+          <a:lstStyle/>
+          <a:p>
+            <a:pPr indent="0" marL="0">
+              <a:lnSpc>
+                <a:spcPct val="120000"/>
+              </a:lnSpc>
+              <a:buNone/>
+            </a:pPr>
+            <a:r>
+              <a:rPr lang="en-US" sz="850" dirty="0">
+                <a:solidFill>
+                  <a:srgbClr val="33332F"/>
+                </a:solidFill>
+                <a:latin typeface="Helvetica Neue" pitchFamily="34" charset="0"/>
+                <a:ea typeface="Helvetica Neue" pitchFamily="34" charset="-122"/>
+                <a:cs typeface="Helvetica Neue" pitchFamily="34" charset="-120"/>
+              </a:rPr>
+              <a:t>Open burning / open detonation unit cost of approximately US$750 per ton.</a:t>
+            </a:r>
+            <a:endParaRPr lang="en-US" sz="850" dirty="0"/>
+          </a:p>
+        </p:txBody>
+      </p:sp>
+      <p:sp>
+        <p:nvSpPr>
+          <p:cNvPr id="33" name="Text 31"/>
+          <p:cNvSpPr txBox="1"/>
+          <p:nvPr/>
+        </p:nvSpPr>
+        <p:spPr>
+          <a:xfrm>
+            <a:off x="6345936" y="5449824"/>
+            <a:ext cx="384048" cy="274320"/>
+          </a:xfrm>
+          <a:prstGeom prst="rect">
+            <a:avLst/>
+          </a:prstGeom>
+          <a:noFill/>
+          <a:ln/>
+        </p:spPr>
+        <p:txBody>
+          <a:bodyPr wrap="square" lIns="0" tIns="0" rIns="0" bIns="0" rtlCol="0" anchor="ctr"/>
+          <a:lstStyle/>
+          <a:p>
+            <a:pPr indent="0" marL="0">
+              <a:buNone/>
+            </a:pPr>
+            <a:r>
+              <a:rPr lang="en-US" sz="1100" b="1" dirty="0">
+                <a:solidFill>
+                  <a:srgbClr val="66705F"/>
+                </a:solidFill>
+                <a:latin typeface="IBM Plex Mono" pitchFamily="34" charset="0"/>
+                <a:ea typeface="IBM Plex Mono" pitchFamily="34" charset="-122"/>
+                <a:cs typeface="IBM Plex Mono" pitchFamily="34" charset="-120"/>
+              </a:rPr>
+              <a:t>10</a:t>
+            </a:r>
+            <a:endParaRPr lang="en-US" sz="1100" dirty="0"/>
+          </a:p>
+        </p:txBody>
+      </p:sp>
+      <p:sp>
+        <p:nvSpPr>
+          <p:cNvPr id="34" name="Text 32"/>
+          <p:cNvSpPr txBox="1"/>
+          <p:nvPr/>
+        </p:nvSpPr>
+        <p:spPr>
+          <a:xfrm>
+            <a:off x="6766560" y="5463540"/>
+            <a:ext cx="4782312" cy="219456"/>
+          </a:xfrm>
+          <a:prstGeom prst="rect">
+            <a:avLst/>
+          </a:prstGeom>
+          <a:noFill/>
+          <a:ln/>
+        </p:spPr>
+        <p:txBody>
+          <a:bodyPr wrap="square" lIns="0" tIns="0" rIns="0" bIns="0" rtlCol="0" anchor="ctr"/>
+          <a:lstStyle/>
+          <a:p>
+            <a:pPr indent="0" marL="0">
+              <a:buNone/>
+            </a:pPr>
+            <a:r>
+              <a:rPr lang="en-US" sz="850" b="1" spc="150" kern="0" dirty="0">
+                <a:solidFill>
+                  <a:srgbClr val="000000"/>
+                </a:solidFill>
+                <a:latin typeface="IBM Plex Mono" pitchFamily="34" charset="0"/>
+                <a:ea typeface="IBM Plex Mono" pitchFamily="34" charset="-122"/>
+                <a:cs typeface="IBM Plex Mono" pitchFamily="34" charset="-120"/>
+              </a:rPr>
+              <a:t>MARKET &amp; AGENCY REPORTING</a:t>
+            </a:r>
+            <a:endParaRPr lang="en-US" sz="850" dirty="0"/>
+          </a:p>
+        </p:txBody>
+      </p:sp>
+      <p:sp>
+        <p:nvSpPr>
+          <p:cNvPr id="35" name="Text 33"/>
+          <p:cNvSpPr txBox="1"/>
+          <p:nvPr/>
+        </p:nvSpPr>
+        <p:spPr>
+          <a:xfrm>
+            <a:off x="6766560" y="5687568"/>
+            <a:ext cx="4782312" cy="566928"/>
+          </a:xfrm>
+          <a:prstGeom prst="rect">
+            <a:avLst/>
+          </a:prstGeom>
+          <a:noFill/>
+          <a:ln/>
+        </p:spPr>
+        <p:txBody>
+          <a:bodyPr wrap="square" lIns="0" tIns="0" rIns="0" bIns="0" rtlCol="0" anchor="ctr"/>
+          <a:lstStyle/>
+          <a:p>
+            <a:pPr indent="0" marL="0">
+              <a:lnSpc>
+                <a:spcPct val="120000"/>
+              </a:lnSpc>
+              <a:buNone/>
+            </a:pPr>
+            <a:r>
+              <a:rPr lang="en-US" sz="850" dirty="0">
+                <a:solidFill>
+                  <a:srgbClr val="33332F"/>
+                </a:solidFill>
+                <a:latin typeface="Helvetica Neue" pitchFamily="34" charset="0"/>
+                <a:ea typeface="Helvetica Neue" pitchFamily="34" charset="-122"/>
+                <a:cs typeface="Helvetica Neue" pitchFamily="34" charset="-120"/>
+              </a:rPr>
+              <a:t>Antimony: price move of approximately 2,600% since China’s export restrictions, past US$50,000/ton; US Department of Defense commitment to secure supply reported at approximately US$1bn.</a:t>
+            </a:r>
+            <a:endParaRPr lang="en-US" sz="850" dirty="0"/>
+          </a:p>
+        </p:txBody>
+      </p:sp>
+      <p:sp>
+        <p:nvSpPr>
+          <p:cNvPr id="36" name="Text 34"/>
+          <p:cNvSpPr txBox="1"/>
+          <p:nvPr/>
+        </p:nvSpPr>
+        <p:spPr>
+          <a:xfrm>
+            <a:off x="640080" y="6382512"/>
+            <a:ext cx="5486400" cy="256032"/>
+          </a:xfrm>
+          <a:prstGeom prst="rect">
+            <a:avLst/>
+          </a:prstGeom>
+          <a:noFill/>
+          <a:ln/>
+        </p:spPr>
+        <p:txBody>
+          <a:bodyPr wrap="square" lIns="0" tIns="0" rIns="0" bIns="0" rtlCol="0" anchor="ctr"/>
+          <a:lstStyle/>
+          <a:p>
+            <a:pPr indent="0" marL="0">
+              <a:buNone/>
+            </a:pPr>
+            <a:r>
+              <a:rPr lang="en-US" sz="800" spc="200" kern="0" dirty="0">
+                <a:solidFill>
+                  <a:srgbClr val="6E6C66"/>
+                </a:solidFill>
+                <a:latin typeface="IBM Plex Mono" pitchFamily="34" charset="0"/>
+                <a:ea typeface="IBM Plex Mono" pitchFamily="34" charset="-122"/>
+                <a:cs typeface="IBM Plex Mono" pitchFamily="34" charset="-120"/>
+              </a:rPr>
+              <a:t>16  ·  TWB DESIGNS — CONFIDENTIAL</a:t>
+            </a:r>
+            <a:endParaRPr lang="en-US" sz="800" dirty="0"/>
+          </a:p>
+        </p:txBody>
+      </p:sp>
+    </p:spTree>
+  </p:cSld>
+  <p:clrMapOvr>
+    <a:masterClrMapping/>
+  </p:clrMapOvr>
+</p:sld>
+</file>
+
+<file path=ppt/slides/slide17.xml><?xml version="1.0" encoding="utf-8"?>
+<p:sld xmlns:a="http://schemas.openxmlformats.org/drawingml/2006/main" xmlns:r="http://schemas.openxmlformats.org/officeDocument/2006/relationships" xmlns:p="http://schemas.openxmlformats.org/presentationml/2006/main">
+  <p:cSld name="Slide 17">
+    <p:bg>
+      <p:bgPr>
+        <a:solidFill>
+          <a:srgbClr val="FFFFFF"/>
+        </a:solidFill>
+      </p:bgPr>
+    </p:bg>
+    <p:spTree>
+      <p:nvGrpSpPr>
+        <p:cNvPr id="1" name=""/>
+        <p:cNvGrpSpPr/>
+        <p:nvPr/>
+      </p:nvGrpSpPr>
+      <p:grpSpPr>
+        <a:xfrm>
+          <a:off x="0" y="0"/>
+          <a:ext cx="0" cy="0"/>
+          <a:chOff x="0" y="0"/>
+          <a:chExt cx="0" cy="0"/>
+        </a:xfrm>
+      </p:grpSpPr>
+      <p:sp>
+        <p:nvSpPr>
+          <p:cNvPr id="2" name="Text 0"/>
+          <p:cNvSpPr txBox="1"/>
+          <p:nvPr/>
+        </p:nvSpPr>
+        <p:spPr>
+          <a:xfrm>
+            <a:off x="640080" y="475488"/>
+            <a:ext cx="10908792" cy="274320"/>
+          </a:xfrm>
+          <a:prstGeom prst="rect">
+            <a:avLst/>
+          </a:prstGeom>
+          <a:noFill/>
+          <a:ln/>
+        </p:spPr>
+        <p:txBody>
+          <a:bodyPr wrap="square" lIns="0" tIns="0" rIns="0" bIns="0" rtlCol="0" anchor="ctr"/>
+          <a:lstStyle/>
+          <a:p>
+            <a:pPr algn="l" indent="0" marL="0">
+              <a:buNone/>
+            </a:pPr>
+            <a:r>
+              <a:rPr lang="en-US" sz="1000" spc="200" kern="0" dirty="0">
+                <a:solidFill>
+                  <a:srgbClr val="6E6C66"/>
+                </a:solidFill>
+                <a:latin typeface="IBM Plex Mono" pitchFamily="34" charset="0"/>
+                <a:ea typeface="IBM Plex Mono" pitchFamily="34" charset="-122"/>
+                <a:cs typeface="IBM Plex Mono" pitchFamily="34" charset="-120"/>
+              </a:rPr>
+              <a:t>SOURCES &amp; CITATIONS — 2 OF 2</a:t>
+            </a:r>
+            <a:endParaRPr lang="en-US" sz="1000" dirty="0"/>
+          </a:p>
+        </p:txBody>
+      </p:sp>
+      <p:sp>
+        <p:nvSpPr>
+          <p:cNvPr id="3" name="Text 1"/>
+          <p:cNvSpPr txBox="1"/>
+          <p:nvPr/>
+        </p:nvSpPr>
+        <p:spPr>
+          <a:xfrm>
+            <a:off x="640080" y="822960"/>
+            <a:ext cx="7863840" cy="548640"/>
+          </a:xfrm>
+          <a:prstGeom prst="rect">
+            <a:avLst/>
+          </a:prstGeom>
+          <a:noFill/>
+          <a:ln/>
+        </p:spPr>
+        <p:txBody>
+          <a:bodyPr wrap="square" lIns="0" tIns="0" rIns="0" bIns="0" rtlCol="0" anchor="ctr"/>
+          <a:lstStyle/>
+          <a:p>
+            <a:pPr indent="0" marL="0">
+              <a:buNone/>
+            </a:pPr>
+            <a:r>
+              <a:rPr lang="en-US" sz="2500" spc="-30" kern="0" dirty="0">
+                <a:solidFill>
+                  <a:srgbClr val="000000"/>
+                </a:solidFill>
+                <a:latin typeface="Helvetica Neue" pitchFamily="34" charset="0"/>
+                <a:ea typeface="Helvetica Neue" pitchFamily="34" charset="-122"/>
+                <a:cs typeface="Helvetica Neue" pitchFamily="34" charset="-120"/>
+              </a:rPr>
+              <a:t>Sources, continued.</a:t>
+            </a:r>
+            <a:endParaRPr lang="en-US" sz="2500" dirty="0"/>
+          </a:p>
+        </p:txBody>
+      </p:sp>
+      <p:sp>
+        <p:nvSpPr>
+          <p:cNvPr id="4" name="Shape 2"/>
+          <p:cNvSpPr/>
+          <p:nvPr/>
+        </p:nvSpPr>
+        <p:spPr>
+          <a:xfrm>
+            <a:off x="640080" y="1481328"/>
+            <a:ext cx="10908792" cy="0"/>
+          </a:xfrm>
+          <a:prstGeom prst="line">
+            <a:avLst/>
+          </a:prstGeom>
+          <a:noFill/>
+          <a:ln w="9525">
+            <a:solidFill>
+              <a:srgbClr val="E2E1DA"/>
+            </a:solidFill>
+            <a:prstDash val="solid"/>
+          </a:ln>
+        </p:spPr>
+      </p:sp>
+      <p:sp>
+        <p:nvSpPr>
+          <p:cNvPr id="5" name="Text 3"/>
+          <p:cNvSpPr txBox="1"/>
+          <p:nvPr/>
+        </p:nvSpPr>
+        <p:spPr>
+          <a:xfrm>
+            <a:off x="640080" y="1691640"/>
+            <a:ext cx="384048" cy="274320"/>
+          </a:xfrm>
+          <a:prstGeom prst="rect">
+            <a:avLst/>
+          </a:prstGeom>
+          <a:noFill/>
+          <a:ln/>
+        </p:spPr>
+        <p:txBody>
+          <a:bodyPr wrap="square" lIns="0" tIns="0" rIns="0" bIns="0" rtlCol="0" anchor="ctr"/>
+          <a:lstStyle/>
+          <a:p>
+            <a:pPr indent="0" marL="0">
+              <a:buNone/>
+            </a:pPr>
+            <a:r>
+              <a:rPr lang="en-US" sz="1100" b="1" dirty="0">
+                <a:solidFill>
+                  <a:srgbClr val="66705F"/>
+                </a:solidFill>
+                <a:latin typeface="IBM Plex Mono" pitchFamily="34" charset="0"/>
+                <a:ea typeface="IBM Plex Mono" pitchFamily="34" charset="-122"/>
+                <a:cs typeface="IBM Plex Mono" pitchFamily="34" charset="-120"/>
+              </a:rPr>
+              <a:t>11</a:t>
+            </a:r>
+            <a:endParaRPr lang="en-US" sz="1100" dirty="0"/>
+          </a:p>
+        </p:txBody>
+      </p:sp>
+      <p:sp>
+        <p:nvSpPr>
+          <p:cNvPr id="6" name="Text 4"/>
+          <p:cNvSpPr txBox="1"/>
+          <p:nvPr/>
+        </p:nvSpPr>
+        <p:spPr>
+          <a:xfrm>
+            <a:off x="1060704" y="1705356"/>
+            <a:ext cx="4782312" cy="219456"/>
+          </a:xfrm>
+          <a:prstGeom prst="rect">
+            <a:avLst/>
+          </a:prstGeom>
+          <a:noFill/>
+          <a:ln/>
+        </p:spPr>
+        <p:txBody>
+          <a:bodyPr wrap="square" lIns="0" tIns="0" rIns="0" bIns="0" rtlCol="0" anchor="ctr"/>
+          <a:lstStyle/>
+          <a:p>
+            <a:pPr indent="0" marL="0">
+              <a:buNone/>
+            </a:pPr>
+            <a:r>
+              <a:rPr lang="en-US" sz="850" b="1" spc="150" kern="0" dirty="0">
+                <a:solidFill>
+                  <a:srgbClr val="000000"/>
+                </a:solidFill>
+                <a:latin typeface="IBM Plex Mono" pitchFamily="34" charset="0"/>
+                <a:ea typeface="IBM Plex Mono" pitchFamily="34" charset="-122"/>
+                <a:cs typeface="IBM Plex Mono" pitchFamily="34" charset="-120"/>
+              </a:rPr>
+              <a:t>US FEDERAL REGISTER</a:t>
+            </a:r>
+            <a:endParaRPr lang="en-US" sz="850" dirty="0"/>
+          </a:p>
+        </p:txBody>
+      </p:sp>
+      <p:sp>
+        <p:nvSpPr>
+          <p:cNvPr id="7" name="Text 5"/>
+          <p:cNvSpPr txBox="1"/>
+          <p:nvPr/>
+        </p:nvSpPr>
+        <p:spPr>
+          <a:xfrm>
+            <a:off x="1060704" y="1929384"/>
+            <a:ext cx="4782312" cy="566928"/>
+          </a:xfrm>
+          <a:prstGeom prst="rect">
+            <a:avLst/>
+          </a:prstGeom>
+          <a:noFill/>
+          <a:ln/>
+        </p:spPr>
+        <p:txBody>
+          <a:bodyPr wrap="square" lIns="0" tIns="0" rIns="0" bIns="0" rtlCol="0" anchor="ctr"/>
+          <a:lstStyle/>
+          <a:p>
+            <a:pPr indent="0" marL="0">
+              <a:lnSpc>
+                <a:spcPct val="120000"/>
+              </a:lnSpc>
+              <a:buNone/>
+            </a:pPr>
+            <a:r>
+              <a:rPr lang="en-US" sz="850" dirty="0">
+                <a:solidFill>
+                  <a:srgbClr val="33332F"/>
+                </a:solidFill>
+                <a:latin typeface="Helvetica Neue" pitchFamily="34" charset="0"/>
+                <a:ea typeface="Helvetica Neue" pitchFamily="34" charset="-122"/>
+                <a:cs typeface="Helvetica Neue" pitchFamily="34" charset="-120"/>
+              </a:rPr>
+              <a:t>2025 US Critical Minerals List, 90 FR 50494 — copper, lead and antimony added.</a:t>
+            </a:r>
+            <a:endParaRPr lang="en-US" sz="850" dirty="0"/>
+          </a:p>
+        </p:txBody>
+      </p:sp>
+      <p:sp>
+        <p:nvSpPr>
+          <p:cNvPr id="8" name="Text 6"/>
+          <p:cNvSpPr txBox="1"/>
+          <p:nvPr/>
+        </p:nvSpPr>
+        <p:spPr>
+          <a:xfrm>
+            <a:off x="640080" y="2532888"/>
+            <a:ext cx="384048" cy="274320"/>
+          </a:xfrm>
+          <a:prstGeom prst="rect">
+            <a:avLst/>
+          </a:prstGeom>
+          <a:noFill/>
+          <a:ln/>
+        </p:spPr>
+        <p:txBody>
+          <a:bodyPr wrap="square" lIns="0" tIns="0" rIns="0" bIns="0" rtlCol="0" anchor="ctr"/>
+          <a:lstStyle/>
+          <a:p>
+            <a:pPr indent="0" marL="0">
+              <a:buNone/>
+            </a:pPr>
+            <a:r>
+              <a:rPr lang="en-US" sz="1100" b="1" dirty="0">
+                <a:solidFill>
+                  <a:srgbClr val="66705F"/>
+                </a:solidFill>
+                <a:latin typeface="IBM Plex Mono" pitchFamily="34" charset="0"/>
+                <a:ea typeface="IBM Plex Mono" pitchFamily="34" charset="-122"/>
+                <a:cs typeface="IBM Plex Mono" pitchFamily="34" charset="-120"/>
+              </a:rPr>
+              <a:t>12</a:t>
+            </a:r>
+            <a:endParaRPr lang="en-US" sz="1100" dirty="0"/>
+          </a:p>
+        </p:txBody>
+      </p:sp>
+      <p:sp>
+        <p:nvSpPr>
+          <p:cNvPr id="9" name="Text 7"/>
+          <p:cNvSpPr txBox="1"/>
+          <p:nvPr/>
+        </p:nvSpPr>
+        <p:spPr>
+          <a:xfrm>
+            <a:off x="1060704" y="2546604"/>
+            <a:ext cx="4782312" cy="219456"/>
+          </a:xfrm>
+          <a:prstGeom prst="rect">
+            <a:avLst/>
+          </a:prstGeom>
+          <a:noFill/>
+          <a:ln/>
+        </p:spPr>
+        <p:txBody>
+          <a:bodyPr wrap="square" lIns="0" tIns="0" rIns="0" bIns="0" rtlCol="0" anchor="ctr"/>
+          <a:lstStyle/>
+          <a:p>
+            <a:pPr indent="0" marL="0">
+              <a:buNone/>
+            </a:pPr>
+            <a:r>
+              <a:rPr lang="en-US" sz="850" b="1" spc="150" kern="0" dirty="0">
+                <a:solidFill>
+                  <a:srgbClr val="000000"/>
+                </a:solidFill>
+                <a:latin typeface="IBM Plex Mono" pitchFamily="34" charset="0"/>
+                <a:ea typeface="IBM Plex Mono" pitchFamily="34" charset="-122"/>
+                <a:cs typeface="IBM Plex Mono" pitchFamily="34" charset="-120"/>
+              </a:rPr>
+              <a:t>WORLD BANK ET AL.</a:t>
+            </a:r>
+            <a:endParaRPr lang="en-US" sz="850" dirty="0"/>
+          </a:p>
+        </p:txBody>
+      </p:sp>
+      <p:sp>
+        <p:nvSpPr>
+          <p:cNvPr id="10" name="Text 8"/>
+          <p:cNvSpPr txBox="1"/>
+          <p:nvPr/>
+        </p:nvSpPr>
+        <p:spPr>
+          <a:xfrm>
+            <a:off x="1060704" y="2770632"/>
+            <a:ext cx="4782312" cy="566928"/>
+          </a:xfrm>
+          <a:prstGeom prst="rect">
+            <a:avLst/>
+          </a:prstGeom>
+          <a:noFill/>
+          <a:ln/>
+        </p:spPr>
+        <p:txBody>
+          <a:bodyPr wrap="square" lIns="0" tIns="0" rIns="0" bIns="0" rtlCol="0" anchor="ctr"/>
+          <a:lstStyle/>
+          <a:p>
+            <a:pPr indent="0" marL="0">
+              <a:lnSpc>
+                <a:spcPct val="120000"/>
+              </a:lnSpc>
+              <a:buNone/>
+            </a:pPr>
+            <a:r>
+              <a:rPr lang="en-US" sz="850" dirty="0">
+                <a:solidFill>
+                  <a:srgbClr val="33332F"/>
+                </a:solidFill>
+                <a:latin typeface="Helvetica Neue" pitchFamily="34" charset="0"/>
+                <a:ea typeface="Helvetica Neue" pitchFamily="34" charset="-122"/>
+                <a:cs typeface="Helvetica Neue" pitchFamily="34" charset="-120"/>
+              </a:rPr>
+              <a:t>Ukraine Rapid Damage and Needs Assessment (RDNA4), February 2025 — demining and explosive-ordnance clearance requirement in excess of US$30bn.</a:t>
+            </a:r>
+            <a:endParaRPr lang="en-US" sz="850" dirty="0"/>
+          </a:p>
+        </p:txBody>
+      </p:sp>
+      <p:sp>
+        <p:nvSpPr>
+          <p:cNvPr id="11" name="Text 9"/>
+          <p:cNvSpPr txBox="1"/>
+          <p:nvPr/>
+        </p:nvSpPr>
+        <p:spPr>
+          <a:xfrm>
+            <a:off x="640080" y="3374136"/>
+            <a:ext cx="384048" cy="274320"/>
+          </a:xfrm>
+          <a:prstGeom prst="rect">
+            <a:avLst/>
+          </a:prstGeom>
+          <a:noFill/>
+          <a:ln/>
+        </p:spPr>
+        <p:txBody>
+          <a:bodyPr wrap="square" lIns="0" tIns="0" rIns="0" bIns="0" rtlCol="0" anchor="ctr"/>
+          <a:lstStyle/>
+          <a:p>
+            <a:pPr indent="0" marL="0">
+              <a:buNone/>
+            </a:pPr>
+            <a:r>
+              <a:rPr lang="en-US" sz="1100" b="1" dirty="0">
+                <a:solidFill>
+                  <a:srgbClr val="66705F"/>
+                </a:solidFill>
+                <a:latin typeface="IBM Plex Mono" pitchFamily="34" charset="0"/>
+                <a:ea typeface="IBM Plex Mono" pitchFamily="34" charset="-122"/>
+                <a:cs typeface="IBM Plex Mono" pitchFamily="34" charset="-120"/>
+              </a:rPr>
+              <a:t>13</a:t>
+            </a:r>
+            <a:endParaRPr lang="en-US" sz="1100" dirty="0"/>
+          </a:p>
+        </p:txBody>
+      </p:sp>
+      <p:sp>
+        <p:nvSpPr>
+          <p:cNvPr id="12" name="Text 10"/>
+          <p:cNvSpPr txBox="1"/>
+          <p:nvPr/>
+        </p:nvSpPr>
+        <p:spPr>
+          <a:xfrm>
+            <a:off x="1060704" y="3387852"/>
+            <a:ext cx="4782312" cy="219456"/>
+          </a:xfrm>
+          <a:prstGeom prst="rect">
+            <a:avLst/>
+          </a:prstGeom>
+          <a:noFill/>
+          <a:ln/>
+        </p:spPr>
+        <p:txBody>
+          <a:bodyPr wrap="square" lIns="0" tIns="0" rIns="0" bIns="0" rtlCol="0" anchor="ctr"/>
+          <a:lstStyle/>
+          <a:p>
+            <a:pPr indent="0" marL="0">
+              <a:buNone/>
+            </a:pPr>
+            <a:r>
+              <a:rPr lang="en-US" sz="850" b="1" spc="150" kern="0" dirty="0">
+                <a:solidFill>
+                  <a:srgbClr val="000000"/>
+                </a:solidFill>
+                <a:latin typeface="IBM Plex Mono" pitchFamily="34" charset="0"/>
+                <a:ea typeface="IBM Plex Mono" pitchFamily="34" charset="-122"/>
+                <a:cs typeface="IBM Plex Mono" pitchFamily="34" charset="-120"/>
+              </a:rPr>
+              <a:t>US DFARS</a:t>
+            </a:r>
+            <a:endParaRPr lang="en-US" sz="850" dirty="0"/>
+          </a:p>
+        </p:txBody>
+      </p:sp>
+      <p:sp>
+        <p:nvSpPr>
+          <p:cNvPr id="13" name="Text 11"/>
+          <p:cNvSpPr txBox="1"/>
+          <p:nvPr/>
+        </p:nvSpPr>
+        <p:spPr>
+          <a:xfrm>
+            <a:off x="1060704" y="3611880"/>
+            <a:ext cx="4782312" cy="566928"/>
+          </a:xfrm>
+          <a:prstGeom prst="rect">
+            <a:avLst/>
+          </a:prstGeom>
+          <a:noFill/>
+          <a:ln/>
+        </p:spPr>
+        <p:txBody>
+          <a:bodyPr wrap="square" lIns="0" tIns="0" rIns="0" bIns="0" rtlCol="0" anchor="ctr"/>
+          <a:lstStyle/>
+          <a:p>
+            <a:pPr indent="0" marL="0">
+              <a:lnSpc>
+                <a:spcPct val="120000"/>
+              </a:lnSpc>
+              <a:buNone/>
+            </a:pPr>
+            <a:r>
+              <a:rPr lang="en-US" sz="850" dirty="0">
+                <a:solidFill>
+                  <a:srgbClr val="33332F"/>
+                </a:solidFill>
+                <a:latin typeface="Helvetica Neue" pitchFamily="34" charset="0"/>
+                <a:ea typeface="Helvetica Neue" pitchFamily="34" charset="-122"/>
+                <a:cs typeface="Helvetica Neue" pitchFamily="34" charset="-120"/>
+              </a:rPr>
+              <a:t>DFARS 225.872 — Canada as a qualifying country; Canadian end products exempt from Buy American restrictions in US defence acquisition.</a:t>
+            </a:r>
+            <a:endParaRPr lang="en-US" sz="850" dirty="0"/>
+          </a:p>
+        </p:txBody>
+      </p:sp>
+      <p:sp>
+        <p:nvSpPr>
+          <p:cNvPr id="14" name="Text 12"/>
+          <p:cNvSpPr txBox="1"/>
+          <p:nvPr/>
+        </p:nvSpPr>
+        <p:spPr>
+          <a:xfrm>
+            <a:off x="640080" y="4215384"/>
+            <a:ext cx="384048" cy="274320"/>
+          </a:xfrm>
+          <a:prstGeom prst="rect">
+            <a:avLst/>
+          </a:prstGeom>
+          <a:noFill/>
+          <a:ln/>
+        </p:spPr>
+        <p:txBody>
+          <a:bodyPr wrap="square" lIns="0" tIns="0" rIns="0" bIns="0" rtlCol="0" anchor="ctr"/>
+          <a:lstStyle/>
+          <a:p>
+            <a:pPr indent="0" marL="0">
+              <a:buNone/>
+            </a:pPr>
+            <a:r>
+              <a:rPr lang="en-US" sz="1100" b="1" dirty="0">
+                <a:solidFill>
+                  <a:srgbClr val="66705F"/>
+                </a:solidFill>
+                <a:latin typeface="IBM Plex Mono" pitchFamily="34" charset="0"/>
+                <a:ea typeface="IBM Plex Mono" pitchFamily="34" charset="-122"/>
+                <a:cs typeface="IBM Plex Mono" pitchFamily="34" charset="-120"/>
+              </a:rPr>
+              <a:t>14</a:t>
+            </a:r>
+            <a:endParaRPr lang="en-US" sz="1100" dirty="0"/>
+          </a:p>
+        </p:txBody>
+      </p:sp>
+      <p:sp>
+        <p:nvSpPr>
+          <p:cNvPr id="15" name="Text 13"/>
+          <p:cNvSpPr txBox="1"/>
+          <p:nvPr/>
+        </p:nvSpPr>
+        <p:spPr>
+          <a:xfrm>
+            <a:off x="1060704" y="4229100"/>
+            <a:ext cx="4782312" cy="219456"/>
+          </a:xfrm>
+          <a:prstGeom prst="rect">
+            <a:avLst/>
+          </a:prstGeom>
+          <a:noFill/>
+          <a:ln/>
+        </p:spPr>
+        <p:txBody>
+          <a:bodyPr wrap="square" lIns="0" tIns="0" rIns="0" bIns="0" rtlCol="0" anchor="ctr"/>
+          <a:lstStyle/>
+          <a:p>
+            <a:pPr indent="0" marL="0">
+              <a:buNone/>
+            </a:pPr>
+            <a:r>
+              <a:rPr lang="en-US" sz="850" b="1" spc="150" kern="0" dirty="0">
+                <a:solidFill>
+                  <a:srgbClr val="000000"/>
+                </a:solidFill>
+                <a:latin typeface="IBM Plex Mono" pitchFamily="34" charset="0"/>
+                <a:ea typeface="IBM Plex Mono" pitchFamily="34" charset="-122"/>
+                <a:cs typeface="IBM Plex Mono" pitchFamily="34" charset="-120"/>
+              </a:rPr>
+              <a:t>US CFR</a:t>
+            </a:r>
+            <a:endParaRPr lang="en-US" sz="850" dirty="0"/>
+          </a:p>
+        </p:txBody>
+      </p:sp>
+      <p:sp>
+        <p:nvSpPr>
+          <p:cNvPr id="16" name="Text 14"/>
+          <p:cNvSpPr txBox="1"/>
+          <p:nvPr/>
+        </p:nvSpPr>
+        <p:spPr>
+          <a:xfrm>
+            <a:off x="1060704" y="4453128"/>
+            <a:ext cx="4782312" cy="566928"/>
+          </a:xfrm>
+          <a:prstGeom prst="rect">
+            <a:avLst/>
+          </a:prstGeom>
+          <a:noFill/>
+          <a:ln/>
+        </p:spPr>
+        <p:txBody>
+          <a:bodyPr wrap="square" lIns="0" tIns="0" rIns="0" bIns="0" rtlCol="0" anchor="ctr"/>
+          <a:lstStyle/>
+          <a:p>
+            <a:pPr indent="0" marL="0">
+              <a:lnSpc>
+                <a:spcPct val="120000"/>
+              </a:lnSpc>
+              <a:buNone/>
+            </a:pPr>
+            <a:r>
+              <a:rPr lang="en-US" sz="850" dirty="0">
+                <a:solidFill>
+                  <a:srgbClr val="33332F"/>
+                </a:solidFill>
+                <a:latin typeface="Helvetica Neue" pitchFamily="34" charset="0"/>
+                <a:ea typeface="Helvetica Neue" pitchFamily="34" charset="-122"/>
+                <a:cs typeface="Helvetica Neue" pitchFamily="34" charset="-120"/>
+              </a:rPr>
+              <a:t>40 CFR 260.10 — definitions; closed-chamber destruction is categorically not open burning.</a:t>
+            </a:r>
+            <a:endParaRPr lang="en-US" sz="850" dirty="0"/>
+          </a:p>
+        </p:txBody>
+      </p:sp>
+      <p:sp>
+        <p:nvSpPr>
+          <p:cNvPr id="17" name="Text 15"/>
+          <p:cNvSpPr txBox="1"/>
+          <p:nvPr/>
+        </p:nvSpPr>
+        <p:spPr>
+          <a:xfrm>
+            <a:off x="6345936" y="1691640"/>
+            <a:ext cx="384048" cy="274320"/>
+          </a:xfrm>
+          <a:prstGeom prst="rect">
+            <a:avLst/>
+          </a:prstGeom>
+          <a:noFill/>
+          <a:ln/>
+        </p:spPr>
+        <p:txBody>
+          <a:bodyPr wrap="square" lIns="0" tIns="0" rIns="0" bIns="0" rtlCol="0" anchor="ctr"/>
+          <a:lstStyle/>
+          <a:p>
+            <a:pPr indent="0" marL="0">
+              <a:buNone/>
+            </a:pPr>
+            <a:r>
+              <a:rPr lang="en-US" sz="1100" b="1" dirty="0">
+                <a:solidFill>
+                  <a:srgbClr val="66705F"/>
+                </a:solidFill>
+                <a:latin typeface="IBM Plex Mono" pitchFamily="34" charset="0"/>
+                <a:ea typeface="IBM Plex Mono" pitchFamily="34" charset="-122"/>
+                <a:cs typeface="IBM Plex Mono" pitchFamily="34" charset="-120"/>
+              </a:rPr>
+              <a:t>15</a:t>
+            </a:r>
+            <a:endParaRPr lang="en-US" sz="1100" dirty="0"/>
+          </a:p>
+        </p:txBody>
+      </p:sp>
+      <p:sp>
+        <p:nvSpPr>
+          <p:cNvPr id="18" name="Text 16"/>
+          <p:cNvSpPr txBox="1"/>
+          <p:nvPr/>
+        </p:nvSpPr>
+        <p:spPr>
+          <a:xfrm>
+            <a:off x="6766560" y="1705356"/>
+            <a:ext cx="4782312" cy="219456"/>
+          </a:xfrm>
+          <a:prstGeom prst="rect">
+            <a:avLst/>
+          </a:prstGeom>
+          <a:noFill/>
+          <a:ln/>
+        </p:spPr>
+        <p:txBody>
+          <a:bodyPr wrap="square" lIns="0" tIns="0" rIns="0" bIns="0" rtlCol="0" anchor="ctr"/>
+          <a:lstStyle/>
+          <a:p>
+            <a:pPr indent="0" marL="0">
+              <a:buNone/>
+            </a:pPr>
+            <a:r>
+              <a:rPr lang="en-US" sz="850" b="1" spc="150" kern="0" dirty="0">
+                <a:solidFill>
+                  <a:srgbClr val="000000"/>
+                </a:solidFill>
+                <a:latin typeface="IBM Plex Mono" pitchFamily="34" charset="0"/>
+                <a:ea typeface="IBM Plex Mono" pitchFamily="34" charset="-122"/>
+                <a:cs typeface="IBM Plex Mono" pitchFamily="34" charset="-120"/>
+              </a:rPr>
+              <a:t>US DEPT. OF STATE</a:t>
+            </a:r>
+            <a:endParaRPr lang="en-US" sz="850" dirty="0"/>
+          </a:p>
+        </p:txBody>
+      </p:sp>
+      <p:sp>
+        <p:nvSpPr>
+          <p:cNvPr id="19" name="Text 17"/>
+          <p:cNvSpPr txBox="1"/>
+          <p:nvPr/>
+        </p:nvSpPr>
+        <p:spPr>
+          <a:xfrm>
+            <a:off x="6766560" y="1929384"/>
+            <a:ext cx="4782312" cy="566928"/>
+          </a:xfrm>
+          <a:prstGeom prst="rect">
+            <a:avLst/>
+          </a:prstGeom>
+          <a:noFill/>
+          <a:ln/>
+        </p:spPr>
+        <p:txBody>
+          <a:bodyPr wrap="square" lIns="0" tIns="0" rIns="0" bIns="0" rtlCol="0" anchor="ctr"/>
+          <a:lstStyle/>
+          <a:p>
+            <a:pPr indent="0" marL="0">
+              <a:lnSpc>
+                <a:spcPct val="120000"/>
+              </a:lnSpc>
+              <a:buNone/>
+            </a:pPr>
+            <a:r>
+              <a:rPr lang="en-US" sz="850" dirty="0">
+                <a:solidFill>
+                  <a:srgbClr val="33332F"/>
+                </a:solidFill>
+                <a:latin typeface="Helvetica Neue" pitchFamily="34" charset="0"/>
+                <a:ea typeface="Helvetica Neue" pitchFamily="34" charset="-122"/>
+                <a:cs typeface="Helvetica Neue" pitchFamily="34" charset="-120"/>
+              </a:rPr>
+              <a:t>Conventional weapons destruction assistance — in excess of US$4bn provided to partner nations since 1993.</a:t>
+            </a:r>
+            <a:endParaRPr lang="en-US" sz="850" dirty="0"/>
+          </a:p>
+        </p:txBody>
+      </p:sp>
+      <p:sp>
+        <p:nvSpPr>
+          <p:cNvPr id="20" name="Text 18"/>
+          <p:cNvSpPr txBox="1"/>
+          <p:nvPr/>
+        </p:nvSpPr>
+        <p:spPr>
+          <a:xfrm>
+            <a:off x="6345936" y="2532888"/>
+            <a:ext cx="384048" cy="274320"/>
+          </a:xfrm>
+          <a:prstGeom prst="rect">
+            <a:avLst/>
+          </a:prstGeom>
+          <a:noFill/>
+          <a:ln/>
+        </p:spPr>
+        <p:txBody>
+          <a:bodyPr wrap="square" lIns="0" tIns="0" rIns="0" bIns="0" rtlCol="0" anchor="ctr"/>
+          <a:lstStyle/>
+          <a:p>
+            <a:pPr indent="0" marL="0">
+              <a:buNone/>
+            </a:pPr>
+            <a:r>
+              <a:rPr lang="en-US" sz="1100" b="1" dirty="0">
+                <a:solidFill>
+                  <a:srgbClr val="66705F"/>
+                </a:solidFill>
+                <a:latin typeface="IBM Plex Mono" pitchFamily="34" charset="0"/>
+                <a:ea typeface="IBM Plex Mono" pitchFamily="34" charset="-122"/>
+                <a:cs typeface="IBM Plex Mono" pitchFamily="34" charset="-120"/>
+              </a:rPr>
+              <a:t>16</a:t>
+            </a:r>
+            <a:endParaRPr lang="en-US" sz="1100" dirty="0"/>
+          </a:p>
+        </p:txBody>
+      </p:sp>
+      <p:sp>
+        <p:nvSpPr>
+          <p:cNvPr id="21" name="Text 19"/>
+          <p:cNvSpPr txBox="1"/>
+          <p:nvPr/>
+        </p:nvSpPr>
+        <p:spPr>
+          <a:xfrm>
+            <a:off x="6766560" y="2546604"/>
+            <a:ext cx="4782312" cy="219456"/>
+          </a:xfrm>
+          <a:prstGeom prst="rect">
+            <a:avLst/>
+          </a:prstGeom>
+          <a:noFill/>
+          <a:ln/>
+        </p:spPr>
+        <p:txBody>
+          <a:bodyPr wrap="square" lIns="0" tIns="0" rIns="0" bIns="0" rtlCol="0" anchor="ctr"/>
+          <a:lstStyle/>
+          <a:p>
+            <a:pPr indent="0" marL="0">
+              <a:buNone/>
+            </a:pPr>
+            <a:r>
+              <a:rPr lang="en-US" sz="850" b="1" spc="150" kern="0" dirty="0">
+                <a:solidFill>
+                  <a:srgbClr val="000000"/>
+                </a:solidFill>
+                <a:latin typeface="IBM Plex Mono" pitchFamily="34" charset="0"/>
+                <a:ea typeface="IBM Plex Mono" pitchFamily="34" charset="-122"/>
+                <a:cs typeface="IBM Plex Mono" pitchFamily="34" charset="-120"/>
+              </a:rPr>
+              <a:t>TWB DESIGNS</a:t>
+            </a:r>
+            <a:endParaRPr lang="en-US" sz="850" dirty="0"/>
+          </a:p>
+        </p:txBody>
+      </p:sp>
+      <p:sp>
+        <p:nvSpPr>
+          <p:cNvPr id="22" name="Text 20"/>
+          <p:cNvSpPr txBox="1"/>
+          <p:nvPr/>
+        </p:nvSpPr>
+        <p:spPr>
+          <a:xfrm>
+            <a:off x="6766560" y="2770632"/>
+            <a:ext cx="4782312" cy="566928"/>
+          </a:xfrm>
+          <a:prstGeom prst="rect">
+            <a:avLst/>
+          </a:prstGeom>
+          <a:noFill/>
+          <a:ln/>
+        </p:spPr>
+        <p:txBody>
+          <a:bodyPr wrap="square" lIns="0" tIns="0" rIns="0" bIns="0" rtlCol="0" anchor="ctr"/>
+          <a:lstStyle/>
+          <a:p>
+            <a:pPr indent="0" marL="0">
+              <a:lnSpc>
+                <a:spcPct val="120000"/>
+              </a:lnSpc>
+              <a:buNone/>
+            </a:pPr>
+            <a:r>
+              <a:rPr lang="en-US" sz="850" dirty="0">
+                <a:solidFill>
+                  <a:srgbClr val="33332F"/>
+                </a:solidFill>
+                <a:latin typeface="Helvetica Neue" pitchFamily="34" charset="0"/>
+                <a:ea typeface="Helvetica Neue" pitchFamily="34" charset="-122"/>
+                <a:cs typeface="Helvetica Neue" pitchFamily="34" charset="-120"/>
+              </a:rPr>
+              <a:t>Company record: eMACS in service since 2001, co-developed with the Royal Canadian Mounted Police. Deployment footprint and scope as stated.</a:t>
+            </a:r>
+            <a:endParaRPr lang="en-US" sz="850" dirty="0"/>
+          </a:p>
+        </p:txBody>
+      </p:sp>
+      <p:sp>
+        <p:nvSpPr>
+          <p:cNvPr id="23" name="Text 21"/>
+          <p:cNvSpPr txBox="1"/>
+          <p:nvPr/>
+        </p:nvSpPr>
+        <p:spPr>
+          <a:xfrm>
+            <a:off x="6345936" y="3374136"/>
+            <a:ext cx="384048" cy="274320"/>
+          </a:xfrm>
+          <a:prstGeom prst="rect">
+            <a:avLst/>
+          </a:prstGeom>
+          <a:noFill/>
+          <a:ln/>
+        </p:spPr>
+        <p:txBody>
+          <a:bodyPr wrap="square" lIns="0" tIns="0" rIns="0" bIns="0" rtlCol="0" anchor="ctr"/>
+          <a:lstStyle/>
+          <a:p>
+            <a:pPr indent="0" marL="0">
+              <a:buNone/>
+            </a:pPr>
+            <a:r>
+              <a:rPr lang="en-US" sz="1100" b="1" dirty="0">
+                <a:solidFill>
+                  <a:srgbClr val="66705F"/>
+                </a:solidFill>
+                <a:latin typeface="IBM Plex Mono" pitchFamily="34" charset="0"/>
+                <a:ea typeface="IBM Plex Mono" pitchFamily="34" charset="-122"/>
+                <a:cs typeface="IBM Plex Mono" pitchFamily="34" charset="-120"/>
+              </a:rPr>
+              <a:t>17</a:t>
+            </a:r>
+            <a:endParaRPr lang="en-US" sz="1100" dirty="0"/>
+          </a:p>
+        </p:txBody>
+      </p:sp>
+      <p:sp>
+        <p:nvSpPr>
+          <p:cNvPr id="24" name="Text 22"/>
+          <p:cNvSpPr txBox="1"/>
+          <p:nvPr/>
+        </p:nvSpPr>
+        <p:spPr>
+          <a:xfrm>
+            <a:off x="6766560" y="3387852"/>
+            <a:ext cx="4782312" cy="219456"/>
+          </a:xfrm>
+          <a:prstGeom prst="rect">
+            <a:avLst/>
+          </a:prstGeom>
+          <a:noFill/>
+          <a:ln/>
+        </p:spPr>
+        <p:txBody>
+          <a:bodyPr wrap="square" lIns="0" tIns="0" rIns="0" bIns="0" rtlCol="0" anchor="ctr"/>
+          <a:lstStyle/>
+          <a:p>
+            <a:pPr indent="0" marL="0">
+              <a:buNone/>
+            </a:pPr>
+            <a:r>
+              <a:rPr lang="en-US" sz="850" b="1" spc="150" kern="0" dirty="0">
+                <a:solidFill>
+                  <a:srgbClr val="000000"/>
+                </a:solidFill>
+                <a:latin typeface="IBM Plex Mono" pitchFamily="34" charset="0"/>
+                <a:ea typeface="IBM Plex Mono" pitchFamily="34" charset="-122"/>
+                <a:cs typeface="IBM Plex Mono" pitchFamily="34" charset="-120"/>
+              </a:rPr>
+              <a:t>TWB DESIGNS</a:t>
+            </a:r>
+            <a:endParaRPr lang="en-US" sz="850" dirty="0"/>
+          </a:p>
+        </p:txBody>
+      </p:sp>
+      <p:sp>
+        <p:nvSpPr>
+          <p:cNvPr id="25" name="Text 23"/>
+          <p:cNvSpPr txBox="1"/>
+          <p:nvPr/>
+        </p:nvSpPr>
+        <p:spPr>
+          <a:xfrm>
+            <a:off x="6766560" y="3611880"/>
+            <a:ext cx="4782312" cy="566928"/>
+          </a:xfrm>
+          <a:prstGeom prst="rect">
+            <a:avLst/>
+          </a:prstGeom>
+          <a:noFill/>
+          <a:ln/>
+        </p:spPr>
+        <p:txBody>
+          <a:bodyPr wrap="square" lIns="0" tIns="0" rIns="0" bIns="0" rtlCol="0" anchor="ctr"/>
+          <a:lstStyle/>
+          <a:p>
+            <a:pPr indent="0" marL="0">
+              <a:lnSpc>
+                <a:spcPct val="120000"/>
+              </a:lnSpc>
+              <a:buNone/>
+            </a:pPr>
+            <a:r>
+              <a:rPr lang="en-US" sz="850" dirty="0">
+                <a:solidFill>
+                  <a:srgbClr val="33332F"/>
+                </a:solidFill>
+                <a:latin typeface="Helvetica Neue" pitchFamily="34" charset="0"/>
+                <a:ea typeface="Helvetica Neue" pitchFamily="34" charset="-122"/>
+                <a:cs typeface="Helvetica Neue" pitchFamily="34" charset="-120"/>
+              </a:rPr>
+              <a:t>TWB analysis: TAM / SAM / SOM construction, sector M&amp;A multiples (4–7× EBITDA; disclosed sector transactions 1.5–3.1× revenue), and the phase plan. Presented as our construction, not third-party research.</a:t>
+            </a:r>
+            <a:endParaRPr lang="en-US" sz="850" dirty="0"/>
+          </a:p>
+        </p:txBody>
+      </p:sp>
+      <p:sp>
+        <p:nvSpPr>
+          <p:cNvPr id="26" name="Text 24"/>
+          <p:cNvSpPr txBox="1"/>
+          <p:nvPr/>
+        </p:nvSpPr>
+        <p:spPr>
+          <a:xfrm>
+            <a:off x="6345936" y="4215384"/>
+            <a:ext cx="384048" cy="274320"/>
+          </a:xfrm>
+          <a:prstGeom prst="rect">
+            <a:avLst/>
+          </a:prstGeom>
+          <a:noFill/>
+          <a:ln/>
+        </p:spPr>
+        <p:txBody>
+          <a:bodyPr wrap="square" lIns="0" tIns="0" rIns="0" bIns="0" rtlCol="0" anchor="ctr"/>
+          <a:lstStyle/>
+          <a:p>
+            <a:pPr indent="0" marL="0">
+              <a:buNone/>
+            </a:pPr>
+            <a:r>
+              <a:rPr lang="en-US" sz="1100" b="1" dirty="0">
+                <a:solidFill>
+                  <a:srgbClr val="66705F"/>
+                </a:solidFill>
+                <a:latin typeface="IBM Plex Mono" pitchFamily="34" charset="0"/>
+                <a:ea typeface="IBM Plex Mono" pitchFamily="34" charset="-122"/>
+                <a:cs typeface="IBM Plex Mono" pitchFamily="34" charset="-120"/>
+              </a:rPr>
+              <a:t>18</a:t>
+            </a:r>
+            <a:endParaRPr lang="en-US" sz="1100" dirty="0"/>
+          </a:p>
+        </p:txBody>
+      </p:sp>
+      <p:sp>
+        <p:nvSpPr>
+          <p:cNvPr id="27" name="Text 25"/>
+          <p:cNvSpPr txBox="1"/>
+          <p:nvPr/>
+        </p:nvSpPr>
+        <p:spPr>
+          <a:xfrm>
+            <a:off x="6766560" y="4229100"/>
+            <a:ext cx="4782312" cy="219456"/>
+          </a:xfrm>
+          <a:prstGeom prst="rect">
+            <a:avLst/>
+          </a:prstGeom>
+          <a:noFill/>
+          <a:ln/>
+        </p:spPr>
+        <p:txBody>
+          <a:bodyPr wrap="square" lIns="0" tIns="0" rIns="0" bIns="0" rtlCol="0" anchor="ctr"/>
+          <a:lstStyle/>
+          <a:p>
+            <a:pPr indent="0" marL="0">
+              <a:buNone/>
+            </a:pPr>
+            <a:r>
+              <a:rPr lang="en-US" sz="850" b="1" spc="150" kern="0" dirty="0">
+                <a:solidFill>
+                  <a:srgbClr val="000000"/>
+                </a:solidFill>
+                <a:latin typeface="IBM Plex Mono" pitchFamily="34" charset="0"/>
+                <a:ea typeface="IBM Plex Mono" pitchFamily="34" charset="-122"/>
+                <a:cs typeface="IBM Plex Mono" pitchFamily="34" charset="-120"/>
+              </a:rPr>
+              <a:t>US ARMY / PEO AMMUNITION</a:t>
+            </a:r>
+            <a:endParaRPr lang="en-US" sz="850" dirty="0"/>
+          </a:p>
+        </p:txBody>
+      </p:sp>
+      <p:sp>
+        <p:nvSpPr>
+          <p:cNvPr id="28" name="Text 26"/>
+          <p:cNvSpPr txBox="1"/>
+          <p:nvPr/>
+        </p:nvSpPr>
+        <p:spPr>
+          <a:xfrm>
+            <a:off x="6766560" y="4453128"/>
+            <a:ext cx="4782312" cy="566928"/>
+          </a:xfrm>
+          <a:prstGeom prst="rect">
+            <a:avLst/>
+          </a:prstGeom>
+          <a:noFill/>
+          <a:ln/>
+        </p:spPr>
+        <p:txBody>
+          <a:bodyPr wrap="square" lIns="0" tIns="0" rIns="0" bIns="0" rtlCol="0" anchor="ctr"/>
+          <a:lstStyle/>
+          <a:p>
+            <a:pPr indent="0" marL="0">
+              <a:lnSpc>
+                <a:spcPct val="120000"/>
+              </a:lnSpc>
+              <a:buNone/>
+            </a:pPr>
+            <a:r>
+              <a:rPr lang="en-US" sz="850" dirty="0">
+                <a:solidFill>
+                  <a:srgbClr val="33332F"/>
+                </a:solidFill>
+                <a:latin typeface="Helvetica Neue" pitchFamily="34" charset="0"/>
+                <a:ea typeface="Helvetica Neue" pitchFamily="34" charset="-122"/>
+                <a:cs typeface="Helvetica Neue" pitchFamily="34" charset="-120"/>
+              </a:rPr>
+              <a:t>Demilitarization throughput: approximately 82,000 tons destroyed in FY2015 (PEO Ammunition, NDIA Global Demilitarization Symposium, December 2015); FY2026 funded plan of 29,313 tons at $155.05M (Army FY2026 President’s Budget). Stockpile drawdown has slowed as funded capacity has fallen.</a:t>
+            </a:r>
+            <a:endParaRPr lang="en-US" sz="850" dirty="0"/>
+          </a:p>
+        </p:txBody>
+      </p:sp>
+      <p:sp>
+        <p:nvSpPr>
+          <p:cNvPr id="29" name="Shape 27"/>
+          <p:cNvSpPr/>
+          <p:nvPr/>
+        </p:nvSpPr>
+        <p:spPr>
+          <a:xfrm>
+            <a:off x="640080" y="5650992"/>
+            <a:ext cx="10908792" cy="676656"/>
+          </a:xfrm>
+          <a:prstGeom prst="rect">
+            <a:avLst/>
+          </a:prstGeom>
+          <a:solidFill>
+            <a:srgbClr val="F1F3F0"/>
+          </a:solidFill>
+          <a:ln w="9525">
+            <a:solidFill>
+              <a:srgbClr val="D3D9D0"/>
+            </a:solidFill>
+            <a:prstDash val="solid"/>
+          </a:ln>
+        </p:spPr>
+      </p:sp>
+      <p:sp>
+        <p:nvSpPr>
+          <p:cNvPr id="30" name="Shape 28"/>
+          <p:cNvSpPr/>
+          <p:nvPr/>
+        </p:nvSpPr>
+        <p:spPr>
+          <a:xfrm>
+            <a:off x="620878" y="5631790"/>
+            <a:ext cx="59436" cy="12802"/>
+          </a:xfrm>
+          <a:prstGeom prst="rect">
+            <a:avLst/>
+          </a:prstGeom>
+          <a:solidFill>
+            <a:srgbClr val="66705F"/>
+          </a:solidFill>
+          <a:ln/>
+        </p:spPr>
+      </p:sp>
+      <p:sp>
+        <p:nvSpPr>
+          <p:cNvPr id="31" name="Shape 29"/>
+          <p:cNvSpPr/>
+          <p:nvPr/>
+        </p:nvSpPr>
+        <p:spPr>
+          <a:xfrm>
+            <a:off x="620878" y="5631790"/>
+            <a:ext cx="12802" cy="59436"/>
+          </a:xfrm>
+          <a:prstGeom prst="rect">
+            <a:avLst/>
+          </a:prstGeom>
+          <a:solidFill>
+            <a:srgbClr val="66705F"/>
+          </a:solidFill>
+          <a:ln/>
+        </p:spPr>
+      </p:sp>
+      <p:sp>
+        <p:nvSpPr>
+          <p:cNvPr id="32" name="Shape 30"/>
+          <p:cNvSpPr/>
+          <p:nvPr/>
+        </p:nvSpPr>
+        <p:spPr>
+          <a:xfrm>
+            <a:off x="11508638" y="5631790"/>
+            <a:ext cx="59436" cy="12802"/>
+          </a:xfrm>
+          <a:prstGeom prst="rect">
+            <a:avLst/>
+          </a:prstGeom>
+          <a:solidFill>
+            <a:srgbClr val="66705F"/>
+          </a:solidFill>
+          <a:ln/>
+        </p:spPr>
+      </p:sp>
+      <p:sp>
+        <p:nvSpPr>
+          <p:cNvPr id="33" name="Shape 31"/>
+          <p:cNvSpPr/>
+          <p:nvPr/>
+        </p:nvSpPr>
+        <p:spPr>
+          <a:xfrm>
+            <a:off x="11555273" y="5631790"/>
+            <a:ext cx="12802" cy="59436"/>
+          </a:xfrm>
+          <a:prstGeom prst="rect">
+            <a:avLst/>
+          </a:prstGeom>
+          <a:solidFill>
+            <a:srgbClr val="66705F"/>
+          </a:solidFill>
+          <a:ln/>
+        </p:spPr>
+      </p:sp>
+      <p:sp>
+        <p:nvSpPr>
+          <p:cNvPr id="34" name="Shape 32"/>
+          <p:cNvSpPr/>
+          <p:nvPr/>
+        </p:nvSpPr>
+        <p:spPr>
+          <a:xfrm>
+            <a:off x="620878" y="6334049"/>
+            <a:ext cx="59436" cy="12802"/>
+          </a:xfrm>
+          <a:prstGeom prst="rect">
+            <a:avLst/>
+          </a:prstGeom>
+          <a:solidFill>
+            <a:srgbClr val="66705F"/>
+          </a:solidFill>
+          <a:ln/>
+        </p:spPr>
+      </p:sp>
+      <p:sp>
+        <p:nvSpPr>
+          <p:cNvPr id="35" name="Shape 33"/>
+          <p:cNvSpPr/>
+          <p:nvPr/>
+        </p:nvSpPr>
+        <p:spPr>
+          <a:xfrm>
+            <a:off x="620878" y="6287414"/>
+            <a:ext cx="12802" cy="59436"/>
+          </a:xfrm>
+          <a:prstGeom prst="rect">
+            <a:avLst/>
+          </a:prstGeom>
+          <a:solidFill>
+            <a:srgbClr val="66705F"/>
+          </a:solidFill>
+          <a:ln/>
+        </p:spPr>
+      </p:sp>
+      <p:sp>
+        <p:nvSpPr>
+          <p:cNvPr id="36" name="Shape 34"/>
+          <p:cNvSpPr/>
+          <p:nvPr/>
+        </p:nvSpPr>
+        <p:spPr>
+          <a:xfrm>
+            <a:off x="11508638" y="6334049"/>
+            <a:ext cx="59436" cy="12802"/>
+          </a:xfrm>
+          <a:prstGeom prst="rect">
+            <a:avLst/>
+          </a:prstGeom>
+          <a:solidFill>
+            <a:srgbClr val="66705F"/>
+          </a:solidFill>
+          <a:ln/>
+        </p:spPr>
+      </p:sp>
+      <p:sp>
+        <p:nvSpPr>
+          <p:cNvPr id="37" name="Shape 35"/>
+          <p:cNvSpPr/>
+          <p:nvPr/>
+        </p:nvSpPr>
+        <p:spPr>
+          <a:xfrm>
+            <a:off x="11555273" y="6287414"/>
+            <a:ext cx="12802" cy="59436"/>
+          </a:xfrm>
+          <a:prstGeom prst="rect">
+            <a:avLst/>
+          </a:prstGeom>
+          <a:solidFill>
+            <a:srgbClr val="66705F"/>
+          </a:solidFill>
+          <a:ln/>
+        </p:spPr>
+      </p:sp>
+      <p:sp>
+        <p:nvSpPr>
+          <p:cNvPr id="38" name="Text 36"/>
+          <p:cNvSpPr txBox="1"/>
+          <p:nvPr/>
+        </p:nvSpPr>
+        <p:spPr>
+          <a:xfrm>
+            <a:off x="877824" y="5760720"/>
+            <a:ext cx="10433304" cy="475488"/>
+          </a:xfrm>
+          <a:prstGeom prst="rect">
+            <a:avLst/>
+          </a:prstGeom>
+          <a:noFill/>
+          <a:ln/>
+        </p:spPr>
+        <p:txBody>
+          <a:bodyPr wrap="square" lIns="0" tIns="0" rIns="0" bIns="0" rtlCol="0" anchor="ctr"/>
+          <a:lstStyle/>
+          <a:p>
+            <a:pPr indent="0" marL="0">
+              <a:lnSpc>
+                <a:spcPct val="120000"/>
+              </a:lnSpc>
+              <a:buNone/>
+            </a:pPr>
+            <a:r>
+              <a:rPr lang="en-US" sz="1000" b="1" dirty="0">
+                <a:solidFill>
+                  <a:srgbClr val="000000"/>
+                </a:solidFill>
+                <a:latin typeface="Helvetica Neue" pitchFamily="34" charset="0"/>
+                <a:ea typeface="Helvetica Neue" pitchFamily="34" charset="-122"/>
+                <a:cs typeface="Helvetica Neue" pitchFamily="34" charset="-120"/>
+              </a:rPr>
+              <a:t>Discipline: </a:t>
+            </a:r>
+            <a:pPr indent="0" marL="0">
+              <a:lnSpc>
+                <a:spcPct val="120000"/>
+              </a:lnSpc>
+              <a:buNone/>
+            </a:pPr>
+            <a:r>
+              <a:rPr lang="en-US" sz="1000" dirty="0">
+                <a:solidFill>
+                  <a:srgbClr val="33332F"/>
+                </a:solidFill>
+                <a:latin typeface="Helvetica Neue" pitchFamily="34" charset="0"/>
+                <a:ea typeface="Helvetica Neue" pitchFamily="34" charset="-122"/>
+                <a:cs typeface="Helvetica Neue" pitchFamily="34" charset="-120"/>
+              </a:rPr>
+              <a:t>no figure appears in this deck without a named source and a year. Derived figures are shown as ranges and labelled illustrative. Recovery-rate and net-cost economics are withheld until third-party verification publishes.</a:t>
+            </a:r>
+            <a:endParaRPr lang="en-US" sz="1000" dirty="0"/>
+          </a:p>
+        </p:txBody>
+      </p:sp>
+      <p:sp>
+        <p:nvSpPr>
+          <p:cNvPr id="39" name="Text 37"/>
+          <p:cNvSpPr txBox="1"/>
+          <p:nvPr/>
+        </p:nvSpPr>
+        <p:spPr>
+          <a:xfrm>
+            <a:off x="640080" y="6382512"/>
+            <a:ext cx="5486400" cy="256032"/>
+          </a:xfrm>
+          <a:prstGeom prst="rect">
+            <a:avLst/>
+          </a:prstGeom>
+          <a:noFill/>
+          <a:ln/>
+        </p:spPr>
+        <p:txBody>
+          <a:bodyPr wrap="square" lIns="0" tIns="0" rIns="0" bIns="0" rtlCol="0" anchor="ctr"/>
+          <a:lstStyle/>
+          <a:p>
+            <a:pPr indent="0" marL="0">
+              <a:buNone/>
+            </a:pPr>
+            <a:r>
+              <a:rPr lang="en-US" sz="800" spc="200" kern="0" dirty="0">
+                <a:solidFill>
+                  <a:srgbClr val="6E6C66"/>
+                </a:solidFill>
+                <a:latin typeface="IBM Plex Mono" pitchFamily="34" charset="0"/>
+                <a:ea typeface="IBM Plex Mono" pitchFamily="34" charset="-122"/>
+                <a:cs typeface="IBM Plex Mono" pitchFamily="34" charset="-120"/>
+              </a:rPr>
+              <a:t>17  ·  TWB DESIGNS — CONFIDENTIAL</a:t>
+            </a:r>
+            <a:endParaRPr lang="en-US" sz="800" dirty="0"/>
+          </a:p>
+        </p:txBody>
+      </p:sp>
+    </p:spTree>
+  </p:cSld>
+  <p:clrMapOvr>
+    <a:masterClrMapping/>
+  </p:clrMapOvr>
+</p:sld>
+</file>
+
 <file path=ppt/slides/slide2.xml><?xml version="1.0" encoding="utf-8"?>
 <p:sld xmlns:a="http://schemas.openxmlformats.org/drawingml/2006/main" xmlns:r="http://schemas.openxmlformats.org/officeDocument/2006/relationships" xmlns:p="http://schemas.openxmlformats.org/presentationml/2006/main">
   <p:cSld name="Slide 2">
@@ -7718,24 +10697,24 @@
         </p:nvSpPr>
         <p:spPr>
           <a:xfrm>
-            <a:off x="640080" y="868680"/>
-            <a:ext cx="10515600" cy="777240"/>
-          </a:xfrm>
-          <a:prstGeom prst="rect">
-            <a:avLst/>
-          </a:prstGeom>
-          <a:noFill/>
-          <a:ln/>
-        </p:spPr>
-        <p:txBody>
-          <a:bodyPr wrap="square" lIns="0" tIns="0" rIns="0" bIns="0" rtlCol="0" anchor="ctr"/>
-          <a:lstStyle/>
-          <a:p>
-            <a:pPr indent="0" marL="0">
-              <a:buNone/>
-            </a:pPr>
-            <a:r>
-              <a:rPr lang="en-US" sz="2800" spc="-30" kern="0" dirty="0">
+            <a:off x="640080" y="768096"/>
+            <a:ext cx="7498080" cy="566928"/>
+          </a:xfrm>
+          <a:prstGeom prst="rect">
+            <a:avLst/>
+          </a:prstGeom>
+          <a:noFill/>
+          <a:ln/>
+        </p:spPr>
+        <p:txBody>
+          <a:bodyPr wrap="square" lIns="0" tIns="0" rIns="0" bIns="0" rtlCol="0" anchor="ctr"/>
+          <a:lstStyle/>
+          <a:p>
+            <a:pPr indent="0" marL="0">
+              <a:buNone/>
+            </a:pPr>
+            <a:r>
+              <a:rPr lang="en-US" sz="2500" spc="-30" kern="0" dirty="0">
                 <a:solidFill>
                   <a:srgbClr val="000000"/>
                 </a:solidFill>
@@ -7745,7 +10724,7 @@
               </a:rPr>
               <a:t>The largest buildup in eighty years.</a:t>
             </a:r>
-            <a:endParaRPr lang="en-US" sz="2800" dirty="0"/>
+            <a:endParaRPr lang="en-US" sz="2500" dirty="0"/>
           </a:p>
         </p:txBody>
       </p:sp>
@@ -7757,24 +10736,24 @@
         </p:nvSpPr>
         <p:spPr>
           <a:xfrm>
-            <a:off x="640080" y="1874520"/>
-            <a:ext cx="5852160" cy="1554480"/>
-          </a:xfrm>
-          <a:prstGeom prst="rect">
-            <a:avLst/>
-          </a:prstGeom>
-          <a:noFill/>
-          <a:ln/>
-        </p:spPr>
-        <p:txBody>
-          <a:bodyPr wrap="square" lIns="0" tIns="0" rIns="0" bIns="0" rtlCol="0" anchor="t"/>
-          <a:lstStyle/>
-          <a:p>
-            <a:pPr algn="l" indent="0" marL="0">
-              <a:buNone/>
-            </a:pPr>
-            <a:r>
-              <a:rPr lang="en-US" sz="9600" spc="-250" kern="0" dirty="0">
+            <a:off x="8229600" y="786384"/>
+            <a:ext cx="3319272" cy="566928"/>
+          </a:xfrm>
+          <a:prstGeom prst="rect">
+            <a:avLst/>
+          </a:prstGeom>
+          <a:noFill/>
+          <a:ln/>
+        </p:spPr>
+        <p:txBody>
+          <a:bodyPr wrap="square" lIns="0" tIns="0" rIns="0" bIns="0" rtlCol="0" anchor="ctr"/>
+          <a:lstStyle/>
+          <a:p>
+            <a:pPr algn="r" indent="0" marL="0">
+              <a:buNone/>
+            </a:pPr>
+            <a:r>
+              <a:rPr lang="en-US" sz="3000" spc="-100" kern="0" dirty="0">
                 <a:solidFill>
                   <a:srgbClr val="000000"/>
                 </a:solidFill>
@@ -7784,39 +10763,11 @@
               </a:rPr>
               <a:t>$2.88T</a:t>
             </a:r>
-            <a:endParaRPr lang="en-US" sz="9600" dirty="0"/>
-          </a:p>
-        </p:txBody>
-      </p:sp>
-      <p:sp>
-        <p:nvSpPr>
-          <p:cNvPr id="5" name="Text 3"/>
-          <p:cNvSpPr txBox="1"/>
-          <p:nvPr/>
-        </p:nvSpPr>
-        <p:spPr>
-          <a:xfrm>
-            <a:off x="640080" y="3566160"/>
-            <a:ext cx="5486400" cy="548640"/>
-          </a:xfrm>
-          <a:prstGeom prst="rect">
-            <a:avLst/>
-          </a:prstGeom>
-          <a:noFill/>
-          <a:ln/>
-        </p:spPr>
-        <p:txBody>
-          <a:bodyPr wrap="square" lIns="0" tIns="0" rIns="0" bIns="0" rtlCol="0" anchor="ctr"/>
-          <a:lstStyle/>
-          <a:p>
-            <a:pPr algn="l" indent="0" marL="0">
-              <a:lnSpc>
-                <a:spcPct val="140000"/>
-              </a:lnSpc>
-              <a:buNone/>
-            </a:pPr>
-            <a:r>
-              <a:rPr lang="en-US" sz="1050" b="1" spc="180" kern="0" dirty="0">
+            <a:pPr algn="r" indent="0" marL="0">
+              <a:buNone/>
+            </a:pPr>
+            <a:r>
+              <a:rPr lang="en-US" sz="850" b="1" spc="120" kern="0" dirty="0">
                 <a:solidFill>
                   <a:srgbClr val="66705F"/>
                 </a:solidFill>
@@ -7824,64 +10775,62 @@
                 <a:ea typeface="IBM Plex Mono" pitchFamily="34" charset="-122"/>
                 <a:cs typeface="IBM Plex Mono" pitchFamily="34" charset="-120"/>
               </a:rPr>
-              <a:t>WORLD MILITARY EXPENDITURE, 2025 — AN ALL-TIME RECORD. $350 FOR EVERY PERSON ALIVE (SIPRI, APR 2026)</a:t>
-            </a:r>
-            <a:endParaRPr lang="en-US" sz="1050" dirty="0"/>
-          </a:p>
-        </p:txBody>
-      </p:sp>
-      <p:sp>
-        <p:nvSpPr>
-          <p:cNvPr id="6" name="Shape 4"/>
-          <p:cNvSpPr/>
-          <p:nvPr/>
-        </p:nvSpPr>
-        <p:spPr>
-          <a:xfrm>
-            <a:off x="640080" y="4434840"/>
-            <a:ext cx="5486400" cy="0"/>
-          </a:xfrm>
-          <a:prstGeom prst="line">
-            <a:avLst/>
-          </a:prstGeom>
-          <a:noFill/>
-          <a:ln w="9525">
-            <a:solidFill>
-              <a:srgbClr val="E2E1DA"/>
-            </a:solidFill>
-            <a:prstDash val="solid"/>
-          </a:ln>
-        </p:spPr>
-      </p:sp>
-      <p:sp>
-        <p:nvSpPr>
-          <p:cNvPr id="7" name="Text 5"/>
-          <p:cNvSpPr txBox="1"/>
-          <p:nvPr/>
-        </p:nvSpPr>
-        <p:spPr>
-          <a:xfrm>
-            <a:off x="640080" y="4617720"/>
-            <a:ext cx="5577840" cy="1600200"/>
-          </a:xfrm>
-          <a:prstGeom prst="rect">
-            <a:avLst/>
-          </a:prstGeom>
-          <a:noFill/>
-          <a:ln/>
-        </p:spPr>
-        <p:txBody>
-          <a:bodyPr wrap="square" lIns="0" tIns="0" rIns="0" bIns="0" rtlCol="0" anchor="ctr"/>
-          <a:lstStyle/>
-          <a:p>
-            <a:pPr indent="0" marL="0">
-              <a:lnSpc>
-                <a:spcPct val="128000"/>
-              </a:lnSpc>
-              <a:buNone/>
-            </a:pPr>
-            <a:r>
-              <a:rPr lang="en-US" sz="1350" b="1" dirty="0">
+              <a:t>   world military expenditure, 2025 — an all-time record¹</a:t>
+            </a:r>
+            <a:endParaRPr lang="en-US" sz="3000" dirty="0"/>
+          </a:p>
+        </p:txBody>
+      </p:sp>
+      <p:pic>
+        <p:nvPicPr>
+          <p:cNvPr id="5" name="Image 0" descr="/root/twb-build/deck/charts/slide2_production_conflict.png">    </p:cNvPr>
+          <p:cNvPicPr>
+            <a:picLocks noChangeAspect="1"/>
+          </p:cNvPicPr>
+          <p:nvPr/>
+        </p:nvPicPr>
+        <p:blipFill>
+          <a:blip r:embed="rId1"/>
+          <a:stretch>
+            <a:fillRect/>
+          </a:stretch>
+        </p:blipFill>
+        <p:spPr>
+          <a:xfrm>
+            <a:off x="882396" y="1444752"/>
+            <a:ext cx="10424160" cy="4638751"/>
+          </a:xfrm>
+          <a:prstGeom prst="rect">
+            <a:avLst/>
+          </a:prstGeom>
+        </p:spPr>
+      </p:pic>
+      <p:sp>
+        <p:nvSpPr>
+          <p:cNvPr id="6" name="Text 3"/>
+          <p:cNvSpPr txBox="1"/>
+          <p:nvPr/>
+        </p:nvSpPr>
+        <p:spPr>
+          <a:xfrm>
+            <a:off x="640080" y="6163056"/>
+            <a:ext cx="7863840" cy="292608"/>
+          </a:xfrm>
+          <a:prstGeom prst="rect">
+            <a:avLst/>
+          </a:prstGeom>
+          <a:noFill/>
+          <a:ln/>
+        </p:spPr>
+        <p:txBody>
+          <a:bodyPr wrap="square" lIns="0" tIns="0" rIns="0" bIns="0" rtlCol="0" anchor="ctr"/>
+          <a:lstStyle/>
+          <a:p>
+            <a:pPr indent="0" marL="0">
+              <a:buNone/>
+            </a:pPr>
+            <a:r>
+              <a:rPr lang="en-US" sz="1050" b="1" dirty="0">
                 <a:solidFill>
                   <a:srgbClr val="000000"/>
                 </a:solidFill>
@@ -7892,13 +10841,10 @@
               <a:t>Production is a crowded trade. </a:t>
             </a:r>
             <a:pPr indent="0" marL="0">
-              <a:lnSpc>
-                <a:spcPct val="128000"/>
-              </a:lnSpc>
-              <a:buNone/>
-            </a:pPr>
-            <a:r>
-              <a:rPr lang="en-US" sz="1350" dirty="0">
+              <a:buNone/>
+            </a:pPr>
+            <a:r>
+              <a:rPr lang="en-US" sz="1050" dirty="0">
                 <a:solidFill>
                   <a:srgbClr val="33332F"/>
                 </a:solidFill>
@@ -7906,327 +10852,74 @@
                 <a:ea typeface="Helvetica Neue" pitchFamily="34" charset="-122"/>
                 <a:cs typeface="Helvetica Neue" pitchFamily="34" charset="-120"/>
               </a:rPr>
-              <a:t>What is not priced in: every one of those rounds must one day be unmade — and that market has no incumbent, no index, and almost no capacity.</a:t>
-            </a:r>
-            <a:endParaRPr lang="en-US" sz="1350" dirty="0"/>
-          </a:p>
-        </p:txBody>
-      </p:sp>
-      <p:sp>
-        <p:nvSpPr>
-          <p:cNvPr id="8" name="Shape 6"/>
-          <p:cNvSpPr/>
-          <p:nvPr/>
-        </p:nvSpPr>
-        <p:spPr>
-          <a:xfrm>
-            <a:off x="6720840" y="1874520"/>
-            <a:ext cx="4846320" cy="0"/>
-          </a:xfrm>
-          <a:prstGeom prst="line">
-            <a:avLst/>
-          </a:prstGeom>
-          <a:noFill/>
-          <a:ln w="9525">
-            <a:solidFill>
-              <a:srgbClr val="E2E1DA"/>
-            </a:solidFill>
-            <a:prstDash val="solid"/>
-          </a:ln>
-        </p:spPr>
-      </p:sp>
-      <p:sp>
-        <p:nvSpPr>
-          <p:cNvPr id="9" name="Text 7"/>
-          <p:cNvSpPr txBox="1"/>
-          <p:nvPr/>
-        </p:nvSpPr>
-        <p:spPr>
-          <a:xfrm>
-            <a:off x="6720840" y="2002536"/>
-            <a:ext cx="2743200" cy="731520"/>
-          </a:xfrm>
-          <a:prstGeom prst="rect">
-            <a:avLst/>
-          </a:prstGeom>
-          <a:noFill/>
-          <a:ln/>
-        </p:spPr>
-        <p:txBody>
-          <a:bodyPr wrap="square" lIns="0" tIns="0" rIns="0" bIns="0" rtlCol="0" anchor="t"/>
-          <a:lstStyle/>
-          <a:p>
-            <a:pPr algn="l" indent="0" marL="0">
-              <a:buNone/>
-            </a:pPr>
-            <a:r>
-              <a:rPr lang="en-US" sz="4400" spc="-100" kern="0" dirty="0">
-                <a:solidFill>
-                  <a:srgbClr val="000000"/>
-                </a:solidFill>
-                <a:latin typeface="Helvetica Neue" pitchFamily="34" charset="0"/>
-                <a:ea typeface="Helvetica Neue" pitchFamily="34" charset="-122"/>
-                <a:cs typeface="Helvetica Neue" pitchFamily="34" charset="-120"/>
-              </a:rPr>
-              <a:t>65</a:t>
-            </a:r>
-            <a:endParaRPr lang="en-US" sz="4400" dirty="0"/>
-          </a:p>
-        </p:txBody>
-      </p:sp>
-      <p:sp>
-        <p:nvSpPr>
-          <p:cNvPr id="10" name="Text 8"/>
-          <p:cNvSpPr txBox="1"/>
-          <p:nvPr/>
-        </p:nvSpPr>
-        <p:spPr>
-          <a:xfrm>
-            <a:off x="6720840" y="2807208"/>
-            <a:ext cx="4800600" cy="548640"/>
-          </a:xfrm>
-          <a:prstGeom prst="rect">
-            <a:avLst/>
-          </a:prstGeom>
-          <a:noFill/>
-          <a:ln/>
-        </p:spPr>
-        <p:txBody>
-          <a:bodyPr wrap="square" lIns="0" tIns="0" rIns="0" bIns="0" rtlCol="0" anchor="ctr"/>
-          <a:lstStyle/>
-          <a:p>
-            <a:pPr algn="l" indent="0" marL="0">
+              <a:t>Unmaking it is not — no incumbent, no index, almost no capacity.</a:t>
+            </a:r>
+            <a:endParaRPr lang="en-US" sz="1050" dirty="0"/>
+          </a:p>
+        </p:txBody>
+      </p:sp>
+      <p:sp>
+        <p:nvSpPr>
+          <p:cNvPr id="7" name="Text 4"/>
+          <p:cNvSpPr txBox="1"/>
+          <p:nvPr/>
+        </p:nvSpPr>
+        <p:spPr>
+          <a:xfrm>
+            <a:off x="8595360" y="6153912"/>
+            <a:ext cx="2953512" cy="329184"/>
+          </a:xfrm>
+          <a:prstGeom prst="rect">
+            <a:avLst/>
+          </a:prstGeom>
+          <a:noFill/>
+          <a:ln/>
+        </p:spPr>
+        <p:txBody>
+          <a:bodyPr wrap="square" lIns="0" tIns="0" rIns="0" bIns="0" rtlCol="0" anchor="ctr"/>
+          <a:lstStyle/>
+          <a:p>
+            <a:pPr algn="r" indent="0" marL="0">
               <a:lnSpc>
-                <a:spcPct val="130000"/>
+                <a:spcPct val="125000"/>
               </a:lnSpc>
               <a:buNone/>
             </a:pPr>
             <a:r>
-              <a:rPr lang="en-US" sz="950" b="1" spc="180" kern="0" dirty="0">
-                <a:solidFill>
-                  <a:srgbClr val="66705F"/>
+              <a:rPr lang="en-US" sz="700" b="1" spc="140" kern="0" dirty="0">
+                <a:solidFill>
+                  <a:srgbClr val="6E6C66"/>
                 </a:solidFill>
                 <a:latin typeface="IBM Plex Mono" pitchFamily="34" charset="0"/>
                 <a:ea typeface="IBM Plex Mono" pitchFamily="34" charset="-122"/>
                 <a:cs typeface="IBM Plex Mono" pitchFamily="34" charset="-120"/>
               </a:rPr>
-              <a:t>ARMED CONFLICTS INVOLVING STATES, 2025 — THE MOST SINCE 1946 (UCDP)</a:t>
-            </a:r>
-            <a:endParaRPr lang="en-US" sz="950" dirty="0"/>
-          </a:p>
-        </p:txBody>
-      </p:sp>
-      <p:sp>
-        <p:nvSpPr>
-          <p:cNvPr id="11" name="Shape 9"/>
-          <p:cNvSpPr/>
-          <p:nvPr/>
-        </p:nvSpPr>
-        <p:spPr>
-          <a:xfrm>
-            <a:off x="6720840" y="3337560"/>
-            <a:ext cx="4846320" cy="0"/>
-          </a:xfrm>
-          <a:prstGeom prst="line">
-            <a:avLst/>
-          </a:prstGeom>
-          <a:noFill/>
-          <a:ln w="9525">
-            <a:solidFill>
-              <a:srgbClr val="E2E1DA"/>
-            </a:solidFill>
-            <a:prstDash val="solid"/>
-          </a:ln>
-        </p:spPr>
-      </p:sp>
-      <p:sp>
-        <p:nvSpPr>
-          <p:cNvPr id="12" name="Text 10"/>
-          <p:cNvSpPr txBox="1"/>
-          <p:nvPr/>
-        </p:nvSpPr>
-        <p:spPr>
-          <a:xfrm>
-            <a:off x="6720840" y="3465576"/>
-            <a:ext cx="2743200" cy="731520"/>
-          </a:xfrm>
-          <a:prstGeom prst="rect">
-            <a:avLst/>
-          </a:prstGeom>
-          <a:noFill/>
-          <a:ln/>
-        </p:spPr>
-        <p:txBody>
-          <a:bodyPr wrap="square" lIns="0" tIns="0" rIns="0" bIns="0" rtlCol="0" anchor="t"/>
-          <a:lstStyle/>
-          <a:p>
-            <a:pPr algn="l" indent="0" marL="0">
-              <a:buNone/>
-            </a:pPr>
-            <a:r>
-              <a:rPr lang="en-US" sz="4400" spc="-100" kern="0" dirty="0">
-                <a:solidFill>
-                  <a:srgbClr val="000000"/>
-                </a:solidFill>
-                <a:latin typeface="Helvetica Neue" pitchFamily="34" charset="0"/>
-                <a:ea typeface="Helvetica Neue" pitchFamily="34" charset="-122"/>
-                <a:cs typeface="Helvetica Neue" pitchFamily="34" charset="-120"/>
-              </a:rPr>
-              <a:t>1.5M/yr</a:t>
-            </a:r>
-            <a:endParaRPr lang="en-US" sz="4400" dirty="0"/>
-          </a:p>
-        </p:txBody>
-      </p:sp>
-      <p:sp>
-        <p:nvSpPr>
-          <p:cNvPr id="13" name="Text 11"/>
-          <p:cNvSpPr txBox="1"/>
-          <p:nvPr/>
-        </p:nvSpPr>
-        <p:spPr>
-          <a:xfrm>
-            <a:off x="6720840" y="4270248"/>
-            <a:ext cx="4800600" cy="548640"/>
-          </a:xfrm>
-          <a:prstGeom prst="rect">
-            <a:avLst/>
-          </a:prstGeom>
-          <a:noFill/>
-          <a:ln/>
-        </p:spPr>
-        <p:txBody>
-          <a:bodyPr wrap="square" lIns="0" tIns="0" rIns="0" bIns="0" rtlCol="0" anchor="ctr"/>
-          <a:lstStyle/>
-          <a:p>
-            <a:pPr algn="l" indent="0" marL="0">
+              <a:t>SOURCES </a:t>
+            </a:r>
+            <a:pPr algn="r" indent="0" marL="0">
               <a:lnSpc>
-                <a:spcPct val="130000"/>
+                <a:spcPct val="125000"/>
               </a:lnSpc>
               <a:buNone/>
             </a:pPr>
             <a:r>
-              <a:rPr lang="en-US" sz="950" b="1" spc="180" kern="0" dirty="0">
-                <a:solidFill>
-                  <a:srgbClr val="66705F"/>
+              <a:rPr lang="en-US" sz="700" spc="60" kern="0" dirty="0">
+                <a:solidFill>
+                  <a:srgbClr val="6E6C66"/>
                 </a:solidFill>
                 <a:latin typeface="IBM Plex Mono" pitchFamily="34" charset="0"/>
                 <a:ea typeface="IBM Plex Mono" pitchFamily="34" charset="-122"/>
                 <a:cs typeface="IBM Plex Mono" pitchFamily="34" charset="-120"/>
               </a:rPr>
-              <a:t>ONE COMPANY'S 155MM SHELL TARGET BY 2027 (RHEINMETALL)</a:t>
-            </a:r>
-            <a:endParaRPr lang="en-US" sz="950" dirty="0"/>
-          </a:p>
-        </p:txBody>
-      </p:sp>
-      <p:sp>
-        <p:nvSpPr>
-          <p:cNvPr id="14" name="Shape 12"/>
-          <p:cNvSpPr/>
-          <p:nvPr/>
-        </p:nvSpPr>
-        <p:spPr>
-          <a:xfrm>
-            <a:off x="6720840" y="4800600"/>
-            <a:ext cx="4846320" cy="0"/>
-          </a:xfrm>
-          <a:prstGeom prst="line">
-            <a:avLst/>
-          </a:prstGeom>
-          <a:noFill/>
-          <a:ln w="9525">
-            <a:solidFill>
-              <a:srgbClr val="E2E1DA"/>
-            </a:solidFill>
-            <a:prstDash val="solid"/>
-          </a:ln>
-        </p:spPr>
-      </p:sp>
-      <p:sp>
-        <p:nvSpPr>
-          <p:cNvPr id="15" name="Text 13"/>
-          <p:cNvSpPr txBox="1"/>
-          <p:nvPr/>
-        </p:nvSpPr>
-        <p:spPr>
-          <a:xfrm>
-            <a:off x="6720840" y="4928616"/>
-            <a:ext cx="2743200" cy="731520"/>
-          </a:xfrm>
-          <a:prstGeom prst="rect">
-            <a:avLst/>
-          </a:prstGeom>
-          <a:noFill/>
-          <a:ln/>
-        </p:spPr>
-        <p:txBody>
-          <a:bodyPr wrap="square" lIns="0" tIns="0" rIns="0" bIns="0" rtlCol="0" anchor="t"/>
-          <a:lstStyle/>
-          <a:p>
-            <a:pPr algn="l" indent="0" marL="0">
-              <a:buNone/>
-            </a:pPr>
-            <a:r>
-              <a:rPr lang="en-US" sz="4400" spc="-100" kern="0" dirty="0">
-                <a:solidFill>
-                  <a:srgbClr val="000000"/>
-                </a:solidFill>
-                <a:latin typeface="Helvetica Neue" pitchFamily="34" charset="0"/>
-                <a:ea typeface="Helvetica Neue" pitchFamily="34" charset="-122"/>
-                <a:cs typeface="Helvetica Neue" pitchFamily="34" charset="-120"/>
-              </a:rPr>
-              <a:t>2×</a:t>
-            </a:r>
-            <a:endParaRPr lang="en-US" sz="4400" dirty="0"/>
-          </a:p>
-        </p:txBody>
-      </p:sp>
-      <p:sp>
-        <p:nvSpPr>
-          <p:cNvPr id="16" name="Text 14"/>
-          <p:cNvSpPr txBox="1"/>
-          <p:nvPr/>
-        </p:nvSpPr>
-        <p:spPr>
-          <a:xfrm>
-            <a:off x="6720840" y="5733288"/>
-            <a:ext cx="4800600" cy="548640"/>
-          </a:xfrm>
-          <a:prstGeom prst="rect">
-            <a:avLst/>
-          </a:prstGeom>
-          <a:noFill/>
-          <a:ln/>
-        </p:spPr>
-        <p:txBody>
-          <a:bodyPr wrap="square" lIns="0" tIns="0" rIns="0" bIns="0" rtlCol="0" anchor="ctr"/>
-          <a:lstStyle/>
-          <a:p>
-            <a:pPr algn="l" indent="0" marL="0">
-              <a:lnSpc>
-                <a:spcPct val="130000"/>
-              </a:lnSpc>
-              <a:buNone/>
-            </a:pPr>
-            <a:r>
-              <a:rPr lang="en-US" sz="950" b="1" spc="180" kern="0" dirty="0">
-                <a:solidFill>
-                  <a:srgbClr val="66705F"/>
-                </a:solidFill>
-                <a:latin typeface="IBM Plex Mono" pitchFamily="34" charset="0"/>
-                <a:ea typeface="IBM Plex Mono" pitchFamily="34" charset="-122"/>
-                <a:cs typeface="IBM Plex Mono" pitchFamily="34" charset="-120"/>
-              </a:rPr>
-              <a:t>EUROPE'S MILITARY SPENDING SINCE 2016 — DOUBLED, STILL CLIMBING (SIPRI)</a:t>
-            </a:r>
-            <a:endParaRPr lang="en-US" sz="950" dirty="0"/>
-          </a:p>
-        </p:txBody>
-      </p:sp>
-      <p:sp>
-        <p:nvSpPr>
-          <p:cNvPr id="17" name="Text 15"/>
+              <a:t>SIPRI Top 100 2002–24, regional aggregation ours, Russia excluded³ · UCDP/PRIO v26.1²</a:t>
+            </a:r>
+            <a:endParaRPr lang="en-US" sz="700" dirty="0"/>
+          </a:p>
+        </p:txBody>
+      </p:sp>
+      <p:sp>
+        <p:nvSpPr>
+          <p:cNvPr id="8" name="Text 5"/>
           <p:cNvSpPr txBox="1"/>
           <p:nvPr/>
         </p:nvSpPr>
@@ -8406,7 +11099,7 @@
                 <a:ea typeface="Helvetica Neue" pitchFamily="34" charset="-122"/>
                 <a:cs typeface="Helvetica Neue" pitchFamily="34" charset="-120"/>
               </a:rPr>
-              <a:t>303,772</a:t>
+              <a:t>309,065</a:t>
             </a:r>
             <a:endParaRPr lang="en-US" sz="7600" dirty="0"/>
           </a:p>
@@ -8448,7 +11141,7 @@
                 <a:ea typeface="IBM Plex Mono" pitchFamily="34" charset="-122"/>
                 <a:cs typeface="IBM Plex Mono" pitchFamily="34" charset="-120"/>
               </a:rPr>
-              <a:t>SHORT TONS AWAITING DESTRUCTION — US STOCKPILE, FY25 (DOD)</a:t>
+              <a:t>TONS AWAITING DEMILITARIZATION — US STOCKPILE, 30 JAN 2025 (ARMY BUDGET JUSTIFICATION)⁵</a:t>
             </a:r>
             <a:endParaRPr lang="en-US" sz="1050" dirty="0"/>
           </a:p>
@@ -8479,7 +11172,7 @@
               <a:buNone/>
             </a:pPr>
             <a:r>
-              <a:rPr lang="en-US" sz="900" spc="120" kern="0" dirty="0">
+              <a:rPr lang="en-US" sz="820" spc="100" kern="0" dirty="0">
                 <a:solidFill>
                   <a:srgbClr val="6E6C66"/>
                 </a:solidFill>
@@ -8487,9 +11180,9 @@
                 <a:ea typeface="IBM Plex Mono" pitchFamily="34" charset="-122"/>
                 <a:cs typeface="IBM Plex Mono" pitchFamily="34" charset="-120"/>
               </a:rPr>
-              <a:t>→ 361,220 T FORECAST BY FY30 · &gt;7,000 MUNITION TYPES</a:t>
-            </a:r>
-            <a:endParaRPr lang="en-US" sz="900" dirty="0"/>
+              <a:t>260,032 T CONVENTIONAL · 49,033 T MISSILE COMPONENTS · &gt;7,000 MUNITION TYPES</a:t>
+            </a:r>
+            <a:endParaRPr lang="en-US" sz="820" dirty="0"/>
           </a:p>
         </p:txBody>
       </p:sp>
@@ -8568,7 +11261,7 @@
                 <a:ea typeface="IBM Plex Mono" pitchFamily="34" charset="-122"/>
                 <a:cs typeface="IBM Plex Mono" pitchFamily="34" charset="-120"/>
               </a:rPr>
-              <a:t>IMPLIED COST TO CLEAR IT, AT PUBLISHED DEMIL RATES</a:t>
+              <a:t>IMPLIED COST TO CLEAR IT, AT PUBLISHED DEMIL RATES⁵ ⁶</a:t>
             </a:r>
             <a:endParaRPr lang="en-US" sz="1050" dirty="0"/>
           </a:p>
@@ -8610,7 +11303,7 @@
                 <a:ea typeface="IBM Plex Mono" pitchFamily="34" charset="-122"/>
                 <a:cs typeface="IBM Plex Mono" pitchFamily="34" charset="-120"/>
               </a:rPr>
-              <a:t>Illustrative: 303,772 t × $2,000–2,890/ton (GAO FY15 / NAS demil cost range). Not an official total.</a:t>
+              <a:t>Illustrative: 309,065 t × $2,000–2,890/ton (GAO FY15 / NAS demil cost range). Not an official total.</a:t>
             </a:r>
             <a:endParaRPr lang="en-US" sz="800" dirty="0"/>
           </a:p>
@@ -8891,8 +11584,8 @@
         </p:nvSpPr>
         <p:spPr>
           <a:xfrm>
-            <a:off x="6675120" y="4617720"/>
-            <a:ext cx="4663440" cy="1005840"/>
+            <a:off x="6675120" y="4590288"/>
+            <a:ext cx="4663440" cy="1097280"/>
           </a:xfrm>
           <a:prstGeom prst="rect">
             <a:avLst/>
@@ -8906,12 +11599,12 @@
           <a:p>
             <a:pPr indent="0" marL="0">
               <a:lnSpc>
-                <a:spcPct val="125000"/>
+                <a:spcPct val="128000"/>
               </a:lnSpc>
               <a:buNone/>
             </a:pPr>
             <a:r>
-              <a:rPr lang="en-US" sz="1300" b="1" dirty="0">
+              <a:rPr lang="en-US" sz="1200" b="1" dirty="0">
                 <a:solidFill>
                   <a:srgbClr val="000000"/>
                 </a:solidFill>
@@ -8919,9 +11612,26 @@
                 <a:ea typeface="Helvetica Neue" pitchFamily="34" charset="-122"/>
                 <a:cs typeface="Helvetica Neue" pitchFamily="34" charset="-120"/>
               </a:rPr>
-              <a:t>The surge now rolling off new production lines will do to allied stockpiles what it has already done to allied budgets.</a:t>
-            </a:r>
-            <a:endParaRPr lang="en-US" sz="1300" dirty="0"/>
+              <a:t>Meanwhile destruction capacity is collapsing. </a:t>
+            </a:r>
+            <a:pPr indent="0" marL="0">
+              <a:lnSpc>
+                <a:spcPct val="128000"/>
+              </a:lnSpc>
+              <a:buNone/>
+            </a:pPr>
+            <a:r>
+              <a:rPr lang="en-US" sz="1200" dirty="0">
+                <a:solidFill>
+                  <a:srgbClr val="33332F"/>
+                </a:solidFill>
+                <a:latin typeface="Helvetica Neue" pitchFamily="34" charset="0"/>
+                <a:ea typeface="Helvetica Neue" pitchFamily="34" charset="-122"/>
+                <a:cs typeface="Helvetica Neue" pitchFamily="34" charset="-120"/>
+              </a:rPr>
+              <a:t>The US destroyed roughly 82,000 tons in FY2015. Its funded plan for FY2026 is 29,313 — a 64% fall, just as the surge begins to refill the queue.¹⁸</a:t>
+            </a:r>
+            <a:endParaRPr lang="en-US" sz="1200" dirty="0"/>
           </a:p>
         </p:txBody>
       </p:sp>
@@ -9149,7 +11859,7 @@
                 <a:ea typeface="Helvetica Neue" pitchFamily="34" charset="-122"/>
                 <a:cs typeface="Helvetica Neue" pitchFamily="34" charset="-120"/>
               </a:rPr>
-              <a:t>Sheriff's detectives killed </a:t>
+              <a:t>Sheriff's detectives killed⁷ </a:t>
             </a:r>
             <a:pPr indent="0" marL="0">
               <a:lnSpc>
@@ -9272,7 +11982,7 @@
                 <a:ea typeface="Helvetica Neue" pitchFamily="34" charset="-122"/>
                 <a:cs typeface="Helvetica Neue" pitchFamily="34" charset="-120"/>
               </a:rPr>
-              <a:t>Open burning / open detonation — no containment, no emissions control. ~$750/ton, and being regulated out: the EPA's proposed rule (89 FR 19952) targets 67 US facilities still doing it.</a:t>
+              <a:t>Open burning / open detonation — no containment, no emissions control. ~$750/ton⁹, and being regulated out: the EPA's proposed rule (89 FR 19952) targets 67 US facilities still doing it.⁸</a:t>
             </a:r>
             <a:endParaRPr lang="en-US" sz="1100" dirty="0"/>
           </a:p>
@@ -9773,7 +12483,7 @@
                 <a:ea typeface="IBM Plex Mono" pitchFamily="34" charset="-122"/>
                 <a:cs typeface="IBM Plex Mono" pitchFamily="34" charset="-120"/>
               </a:rPr>
-              <a:t>ANTIMONY PRICE MOVE SINCE CHINA'S EXPORT RESTRICTIONS — PAST $50,000/TON. PENTAGON COMMITTED A REPORTED $1B TO SECURE SUPPLY</a:t>
+              <a:t>ANTIMONY PRICE MOVE SINCE CHINA'S EXPORT RESTRICTIONS — PAST $50,000/TON. PENTAGON COMMITTED A REPORTED $1B TO SECURE SUPPLY¹⁰</a:t>
             </a:r>
             <a:endParaRPr lang="en-US" sz="1050" dirty="0"/>
           </a:p>
@@ -9941,7 +12651,7 @@
                 <a:ea typeface="Helvetica Neue" pitchFamily="34" charset="-122"/>
                 <a:cs typeface="Helvetica Neue" pitchFamily="34" charset="-120"/>
               </a:rPr>
-              <a:t>Added to the US Critical Minerals List, 2025</a:t>
+              <a:t>Added to the US Critical Minerals List, 2025¹¹</a:t>
             </a:r>
             <a:endParaRPr lang="en-US" sz="950" dirty="0"/>
           </a:p>
@@ -10086,7 +12796,7 @@
                 <a:ea typeface="Helvetica Neue" pitchFamily="34" charset="-122"/>
                 <a:cs typeface="Helvetica Neue" pitchFamily="34" charset="-120"/>
               </a:rPr>
-              <a:t>Added to the US Critical Minerals List, 2025</a:t>
+              <a:t>Added to the US Critical Minerals List, 2025¹¹</a:t>
             </a:r>
             <a:endParaRPr lang="en-US" sz="950" dirty="0"/>
           </a:p>
@@ -10231,7 +12941,7 @@
                 <a:ea typeface="Helvetica Neue" pitchFamily="34" charset="-122"/>
                 <a:cs typeface="Helvetica Neue" pitchFamily="34" charset="-120"/>
               </a:rPr>
-              <a:t>China-restricted — repriced overnight</a:t>
+              <a:t>China-restricted — repriced overnight¹⁰</a:t>
             </a:r>
             <a:endParaRPr lang="en-US" sz="950" dirty="0"/>
           </a:p>
@@ -10944,7 +13654,7 @@
                 <a:ea typeface="IBM Plex Mono" pitchFamily="34" charset="-122"/>
                 <a:cs typeface="IBM Plex Mono" pitchFamily="34" charset="-120"/>
               </a:rPr>
-              <a:t>EBITDA WHERE FOUNDER-HELD CAPABILITY TRADES TODAY — PRICED LIKE PLUMBING</a:t>
+              <a:t>EBITDA WHERE FOUNDER-HELD CAPABILITY TRADES TODAY — PRICED LIKE PLUMBING¹⁷</a:t>
             </a:r>
             <a:endParaRPr lang="en-US" sz="950" dirty="0"/>
           </a:p>
@@ -11452,24 +14162,24 @@
         </p:nvSpPr>
         <p:spPr>
           <a:xfrm>
-            <a:off x="640080" y="868680"/>
-            <a:ext cx="10789920" cy="777240"/>
-          </a:xfrm>
-          <a:prstGeom prst="rect">
-            <a:avLst/>
-          </a:prstGeom>
-          <a:noFill/>
-          <a:ln/>
-        </p:spPr>
-        <p:txBody>
-          <a:bodyPr wrap="square" lIns="0" tIns="0" rIns="0" bIns="0" rtlCol="0" anchor="ctr"/>
-          <a:lstStyle/>
-          <a:p>
-            <a:pPr indent="0" marL="0">
-              <a:buNone/>
-            </a:pPr>
-            <a:r>
-              <a:rPr lang="en-US" sz="2700" spc="-30" kern="0" dirty="0">
+            <a:off x="640080" y="804672"/>
+            <a:ext cx="10789920" cy="566928"/>
+          </a:xfrm>
+          <a:prstGeom prst="rect">
+            <a:avLst/>
+          </a:prstGeom>
+          <a:noFill/>
+          <a:ln/>
+        </p:spPr>
+        <p:txBody>
+          <a:bodyPr wrap="square" lIns="0" tIns="0" rIns="0" bIns="0" rtlCol="0" anchor="ctr"/>
+          <a:lstStyle/>
+          <a:p>
+            <a:pPr indent="0" marL="0">
+              <a:buNone/>
+            </a:pPr>
+            <a:r>
+              <a:rPr lang="en-US" sz="2600" spc="-30" kern="0" dirty="0">
                 <a:solidFill>
                   <a:srgbClr val="000000"/>
                 </a:solidFill>
@@ -11479,7 +14189,7 @@
               </a:rPr>
               <a:t>The end-of-life bill of a $2.88 trillion rearmament.</a:t>
             </a:r>
-            <a:endParaRPr lang="en-US" sz="2700" dirty="0"/>
+            <a:endParaRPr lang="en-US" sz="2600" dirty="0"/>
           </a:p>
         </p:txBody>
       </p:sp>
@@ -11491,63 +14201,24 @@
         </p:nvSpPr>
         <p:spPr>
           <a:xfrm>
-            <a:off x="640080" y="1691640"/>
-            <a:ext cx="7315200" cy="201168"/>
-          </a:xfrm>
-          <a:prstGeom prst="rect">
-            <a:avLst/>
-          </a:prstGeom>
-          <a:noFill/>
-          <a:ln/>
-        </p:spPr>
-        <p:txBody>
-          <a:bodyPr wrap="square" lIns="0" tIns="0" rIns="0" bIns="0" rtlCol="0" anchor="ctr"/>
-          <a:lstStyle/>
-          <a:p>
-            <a:pPr indent="0" marL="0">
-              <a:buNone/>
-            </a:pPr>
-            <a:r>
-              <a:rPr lang="en-US" sz="1000" b="1" spc="200" kern="0" dirty="0">
-                <a:solidFill>
-                  <a:srgbClr val="66705F"/>
-                </a:solidFill>
-                <a:latin typeface="IBM Plex Mono" pitchFamily="34" charset="0"/>
-                <a:ea typeface="IBM Plex Mono" pitchFamily="34" charset="-122"/>
-                <a:cs typeface="IBM Plex Mono" pitchFamily="34" charset="-120"/>
-              </a:rPr>
-              <a:t>TOTAL ADDRESSABLE MARKET</a:t>
-            </a:r>
-            <a:endParaRPr lang="en-US" sz="1000" dirty="0"/>
-          </a:p>
-        </p:txBody>
-      </p:sp>
-      <p:sp>
-        <p:nvSpPr>
-          <p:cNvPr id="5" name="Text 3"/>
-          <p:cNvSpPr txBox="1"/>
-          <p:nvPr/>
-        </p:nvSpPr>
-        <p:spPr>
-          <a:xfrm>
-            <a:off x="640080" y="1847088"/>
-            <a:ext cx="10881360" cy="1508760"/>
-          </a:xfrm>
-          <a:prstGeom prst="rect">
-            <a:avLst/>
-          </a:prstGeom>
-          <a:noFill/>
-          <a:ln/>
-        </p:spPr>
-        <p:txBody>
-          <a:bodyPr wrap="square" lIns="0" tIns="0" rIns="0" bIns="0" rtlCol="0" anchor="t"/>
-          <a:lstStyle/>
-          <a:p>
-            <a:pPr indent="0" marL="0">
-              <a:buNone/>
-            </a:pPr>
-            <a:r>
-              <a:rPr lang="en-US" sz="9200" spc="-200" kern="0" dirty="0">
+            <a:off x="640080" y="1389888"/>
+            <a:ext cx="10881360" cy="310896"/>
+          </a:xfrm>
+          <a:prstGeom prst="rect">
+            <a:avLst/>
+          </a:prstGeom>
+          <a:noFill/>
+          <a:ln/>
+        </p:spPr>
+        <p:txBody>
+          <a:bodyPr wrap="square" lIns="0" tIns="0" rIns="0" bIns="0" rtlCol="0" anchor="ctr"/>
+          <a:lstStyle/>
+          <a:p>
+            <a:pPr indent="0" marL="0">
+              <a:buNone/>
+            </a:pPr>
+            <a:r>
+              <a:rPr lang="en-US" sz="1200" b="1" dirty="0">
                 <a:solidFill>
                   <a:srgbClr val="000000"/>
                 </a:solidFill>
@@ -11555,77 +14226,59 @@
                 <a:ea typeface="Helvetica Neue" pitchFamily="34" charset="-122"/>
                 <a:cs typeface="Helvetica Neue" pitchFamily="34" charset="-120"/>
               </a:rPr>
-              <a:t>$4–6B</a:t>
-            </a:r>
-            <a:pPr indent="0" marL="0">
-              <a:buNone/>
-            </a:pPr>
-            <a:r>
-              <a:rPr lang="en-US" sz="2000" dirty="0">
-                <a:solidFill>
-                  <a:srgbClr val="6E6C66"/>
+              <a:t>Three tiers, drawn to true relative scale. </a:t>
+            </a:r>
+            <a:pPr indent="0" marL="0">
+              <a:buNone/>
+            </a:pPr>
+            <a:r>
+              <a:rPr lang="en-US" sz="1200" dirty="0">
+                <a:solidFill>
+                  <a:srgbClr val="33332F"/>
                 </a:solidFill>
                 <a:latin typeface="Helvetica Neue" pitchFamily="34" charset="0"/>
                 <a:ea typeface="Helvetica Neue" pitchFamily="34" charset="-122"/>
                 <a:cs typeface="Helvetica Neue" pitchFamily="34" charset="-120"/>
               </a:rPr>
-              <a:t>  /yr, plus $30B+ episodic</a:t>
-            </a:r>
-            <a:endParaRPr lang="en-US" sz="9200" dirty="0"/>
-          </a:p>
-        </p:txBody>
-      </p:sp>
-      <p:sp>
-        <p:nvSpPr>
-          <p:cNvPr id="6" name="Text 4"/>
-          <p:cNvSpPr txBox="1"/>
-          <p:nvPr/>
-        </p:nvSpPr>
-        <p:spPr>
-          <a:xfrm>
-            <a:off x="640080" y="3419856"/>
-            <a:ext cx="10881360" cy="566928"/>
-          </a:xfrm>
-          <a:prstGeom prst="rect">
-            <a:avLst/>
-          </a:prstGeom>
-          <a:noFill/>
-          <a:ln/>
-        </p:spPr>
-        <p:txBody>
-          <a:bodyPr wrap="square" lIns="0" tIns="0" rIns="0" bIns="0" rtlCol="0" anchor="ctr"/>
-          <a:lstStyle/>
-          <a:p>
-            <a:pPr indent="0" marL="0">
-              <a:lnSpc>
-                <a:spcPct val="128000"/>
-              </a:lnSpc>
-              <a:buNone/>
-            </a:pPr>
-            <a:r>
-              <a:rPr lang="en-US" sz="1250" dirty="0">
-                <a:solidFill>
-                  <a:srgbClr val="33332F"/>
-                </a:solidFill>
-                <a:latin typeface="Helvetica Neue" pitchFamily="34" charset="0"/>
-                <a:ea typeface="Helvetica Neue" pitchFamily="34" charset="-122"/>
-                <a:cs typeface="Helvetica Neue" pitchFamily="34" charset="-120"/>
-              </a:rPr>
-              <a:t>Allied munitions end-of-life — destruction services, recovered materials, sovereign facility engineering across NATO + partners. Plus post-conflict recovery already priced (Ukraine, World Bank RDNA4).</a:t>
-            </a:r>
-            <a:endParaRPr lang="en-US" sz="1250" dirty="0"/>
-          </a:p>
-        </p:txBody>
-      </p:sp>
-      <p:sp>
-        <p:nvSpPr>
-          <p:cNvPr id="7" name="Shape 5"/>
+              <a:t>We are underwriting the sliver, in a market being built for us at record pace.¹⁷</a:t>
+            </a:r>
+            <a:endParaRPr lang="en-US" sz="1200" dirty="0"/>
+          </a:p>
+        </p:txBody>
+      </p:sp>
+      <p:pic>
+        <p:nvPicPr>
+          <p:cNvPr id="5" name="Image 0" descr="/root/twb-build/deck/charts/slide7_tam.png">    </p:cNvPr>
+          <p:cNvPicPr>
+            <a:picLocks noChangeAspect="1"/>
+          </p:cNvPicPr>
+          <p:nvPr/>
+        </p:nvPicPr>
+        <p:blipFill>
+          <a:blip r:embed="rId1"/>
+          <a:stretch>
+            <a:fillRect/>
+          </a:stretch>
+        </p:blipFill>
+        <p:spPr>
+          <a:xfrm>
+            <a:off x="640080" y="1810512"/>
+            <a:ext cx="10908792" cy="3006547"/>
+          </a:xfrm>
+          <a:prstGeom prst="rect">
+            <a:avLst/>
+          </a:prstGeom>
+        </p:spPr>
+      </p:pic>
+      <p:sp>
+        <p:nvSpPr>
+          <p:cNvPr id="6" name="Shape 3"/>
           <p:cNvSpPr/>
           <p:nvPr/>
         </p:nvSpPr>
         <p:spPr>
           <a:xfrm>
-            <a:off x="640080" y="4069080"/>
+            <a:off x="640080" y="5047488"/>
             <a:ext cx="10908792" cy="0"/>
           </a:xfrm>
           <a:prstGeom prst="line">
@@ -11642,14 +14295,14 @@
       </p:sp>
       <p:sp>
         <p:nvSpPr>
-          <p:cNvPr id="8" name="Text 6"/>
-          <p:cNvSpPr txBox="1"/>
-          <p:nvPr/>
-        </p:nvSpPr>
-        <p:spPr>
-          <a:xfrm>
-            <a:off x="640080" y="4224528"/>
-            <a:ext cx="5225796" cy="182880"/>
+          <p:cNvPr id="7" name="Text 4"/>
+          <p:cNvSpPr txBox="1"/>
+          <p:nvPr/>
+        </p:nvSpPr>
+        <p:spPr>
+          <a:xfrm>
+            <a:off x="640080" y="5248656"/>
+            <a:ext cx="3453384" cy="237744"/>
           </a:xfrm>
           <a:prstGeom prst="rect">
             <a:avLst/>
@@ -11667,13 +14320,13 @@
             <a:r>
               <a:rPr lang="en-US" sz="950" b="1" spc="160" kern="0" dirty="0">
                 <a:solidFill>
-                  <a:srgbClr val="6E6C66"/>
+                  <a:srgbClr val="66705F"/>
                 </a:solidFill>
                 <a:latin typeface="IBM Plex Mono" pitchFamily="34" charset="0"/>
                 <a:ea typeface="IBM Plex Mono" pitchFamily="34" charset="-122"/>
                 <a:cs typeface="IBM Plex Mono" pitchFamily="34" charset="-120"/>
               </a:rPr>
-              <a:t>SERVICEABLE MARKET (SAM)</a:t>
+              <a:t>HOW IT IS BUILT</a:t>
             </a:r>
             <a:endParaRPr lang="en-US" sz="950" dirty="0"/>
           </a:p>
@@ -11681,67 +14334,176 @@
       </p:sp>
       <p:sp>
         <p:nvSpPr>
-          <p:cNvPr id="9" name="Text 7"/>
-          <p:cNvSpPr txBox="1"/>
-          <p:nvPr/>
-        </p:nvSpPr>
-        <p:spPr>
-          <a:xfrm>
-            <a:off x="640080" y="4407408"/>
-            <a:ext cx="5225796" cy="868680"/>
-          </a:xfrm>
-          <a:prstGeom prst="rect">
-            <a:avLst/>
-          </a:prstGeom>
-          <a:noFill/>
-          <a:ln/>
-        </p:spPr>
-        <p:txBody>
-          <a:bodyPr wrap="square" lIns="0" tIns="0" rIns="0" bIns="0" rtlCol="0" anchor="t"/>
-          <a:lstStyle/>
-          <a:p>
-            <a:pPr indent="0" marL="0">
-              <a:buNone/>
-            </a:pPr>
-            <a:r>
-              <a:rPr lang="en-US" sz="4800" spc="-150" kern="0" dirty="0">
-                <a:solidFill>
-                  <a:srgbClr val="000000"/>
+          <p:cNvPr id="8" name="Text 5"/>
+          <p:cNvSpPr txBox="1"/>
+          <p:nvPr/>
+        </p:nvSpPr>
+        <p:spPr>
+          <a:xfrm>
+            <a:off x="640080" y="5522976"/>
+            <a:ext cx="3453384" cy="786384"/>
+          </a:xfrm>
+          <a:prstGeom prst="rect">
+            <a:avLst/>
+          </a:prstGeom>
+          <a:noFill/>
+          <a:ln/>
+        </p:spPr>
+        <p:txBody>
+          <a:bodyPr wrap="square" lIns="0" tIns="0" rIns="0" bIns="0" rtlCol="0" anchor="ctr"/>
+          <a:lstStyle/>
+          <a:p>
+            <a:pPr indent="0" marL="0">
+              <a:lnSpc>
+                <a:spcPct val="124000"/>
+              </a:lnSpc>
+              <a:buNone/>
+            </a:pPr>
+            <a:r>
+              <a:rPr lang="en-US" sz="950" dirty="0">
+                <a:solidFill>
+                  <a:srgbClr val="33332F"/>
                 </a:solidFill>
                 <a:latin typeface="Helvetica Neue" pitchFamily="34" charset="0"/>
                 <a:ea typeface="Helvetica Neue" pitchFamily="34" charset="-122"/>
                 <a:cs typeface="Helvetica Neue" pitchFamily="34" charset="-120"/>
               </a:rPr>
-              <a:t>$1.5–2.5B</a:t>
-            </a:r>
-            <a:pPr indent="0" marL="0">
-              <a:buNone/>
-            </a:pPr>
-            <a:r>
-              <a:rPr lang="en-US" sz="1400" dirty="0">
-                <a:solidFill>
-                  <a:srgbClr val="6E6C66"/>
+              <a:t>Published demil rates⁶ applied to the allied stockpile that has to move, plus recovered materials and sovereign facility engineering. Every assumption is on this page.</a:t>
+            </a:r>
+            <a:endParaRPr lang="en-US" sz="950" dirty="0"/>
+          </a:p>
+        </p:txBody>
+      </p:sp>
+      <p:sp>
+        <p:nvSpPr>
+          <p:cNvPr id="9" name="Text 6"/>
+          <p:cNvSpPr txBox="1"/>
+          <p:nvPr/>
+        </p:nvSpPr>
+        <p:spPr>
+          <a:xfrm>
+            <a:off x="4367784" y="5248656"/>
+            <a:ext cx="3453384" cy="237744"/>
+          </a:xfrm>
+          <a:prstGeom prst="rect">
+            <a:avLst/>
+          </a:prstGeom>
+          <a:noFill/>
+          <a:ln/>
+        </p:spPr>
+        <p:txBody>
+          <a:bodyPr wrap="square" lIns="0" tIns="0" rIns="0" bIns="0" rtlCol="0" anchor="ctr"/>
+          <a:lstStyle/>
+          <a:p>
+            <a:pPr indent="0" marL="0">
+              <a:buNone/>
+            </a:pPr>
+            <a:r>
+              <a:rPr lang="en-US" sz="950" b="1" spc="160" kern="0" dirty="0">
+                <a:solidFill>
+                  <a:srgbClr val="66705F"/>
+                </a:solidFill>
+                <a:latin typeface="IBM Plex Mono" pitchFamily="34" charset="0"/>
+                <a:ea typeface="IBM Plex Mono" pitchFamily="34" charset="-122"/>
+                <a:cs typeface="IBM Plex Mono" pitchFamily="34" charset="-120"/>
+              </a:rPr>
+              <a:t>WHY IT IS AVAILABLE</a:t>
+            </a:r>
+            <a:endParaRPr lang="en-US" sz="950" dirty="0"/>
+          </a:p>
+        </p:txBody>
+      </p:sp>
+      <p:sp>
+        <p:nvSpPr>
+          <p:cNvPr id="10" name="Text 7"/>
+          <p:cNvSpPr txBox="1"/>
+          <p:nvPr/>
+        </p:nvSpPr>
+        <p:spPr>
+          <a:xfrm>
+            <a:off x="4367784" y="5522976"/>
+            <a:ext cx="3453384" cy="786384"/>
+          </a:xfrm>
+          <a:prstGeom prst="rect">
+            <a:avLst/>
+          </a:prstGeom>
+          <a:noFill/>
+          <a:ln/>
+        </p:spPr>
+        <p:txBody>
+          <a:bodyPr wrap="square" lIns="0" tIns="0" rIns="0" bIns="0" rtlCol="0" anchor="ctr"/>
+          <a:lstStyle/>
+          <a:p>
+            <a:pPr indent="0" marL="0">
+              <a:lnSpc>
+                <a:spcPct val="124000"/>
+              </a:lnSpc>
+              <a:buNone/>
+            </a:pPr>
+            <a:r>
+              <a:rPr lang="en-US" sz="950" dirty="0">
+                <a:solidFill>
+                  <a:srgbClr val="33332F"/>
                 </a:solidFill>
                 <a:latin typeface="Helvetica Neue" pitchFamily="34" charset="0"/>
                 <a:ea typeface="Helvetica Neue" pitchFamily="34" charset="-122"/>
                 <a:cs typeface="Helvetica Neue" pitchFamily="34" charset="-120"/>
               </a:rPr>
-              <a:t> /yr</a:t>
-            </a:r>
-            <a:endParaRPr lang="en-US" sz="4800" dirty="0"/>
-          </a:p>
-        </p:txBody>
-      </p:sp>
-      <p:sp>
-        <p:nvSpPr>
-          <p:cNvPr id="10" name="Text 8"/>
-          <p:cNvSpPr txBox="1"/>
-          <p:nvPr/>
-        </p:nvSpPr>
-        <p:spPr>
-          <a:xfrm>
-            <a:off x="640080" y="5276088"/>
-            <a:ext cx="5225796" cy="502920"/>
+              <a:t>No analyst covers this market. There is no index, no comparable set, no incumbent platform to be re-rated against. That is precisely why it is still purchasable at founder-scale multiples.¹⁷</a:t>
+            </a:r>
+            <a:endParaRPr lang="en-US" sz="950" dirty="0"/>
+          </a:p>
+        </p:txBody>
+      </p:sp>
+      <p:sp>
+        <p:nvSpPr>
+          <p:cNvPr id="11" name="Text 8"/>
+          <p:cNvSpPr txBox="1"/>
+          <p:nvPr/>
+        </p:nvSpPr>
+        <p:spPr>
+          <a:xfrm>
+            <a:off x="8095488" y="5248656"/>
+            <a:ext cx="3453384" cy="237744"/>
+          </a:xfrm>
+          <a:prstGeom prst="rect">
+            <a:avLst/>
+          </a:prstGeom>
+          <a:noFill/>
+          <a:ln/>
+        </p:spPr>
+        <p:txBody>
+          <a:bodyPr wrap="square" lIns="0" tIns="0" rIns="0" bIns="0" rtlCol="0" anchor="ctr"/>
+          <a:lstStyle/>
+          <a:p>
+            <a:pPr indent="0" marL="0">
+              <a:buNone/>
+            </a:pPr>
+            <a:r>
+              <a:rPr lang="en-US" sz="950" b="1" spc="160" kern="0" dirty="0">
+                <a:solidFill>
+                  <a:srgbClr val="66705F"/>
+                </a:solidFill>
+                <a:latin typeface="IBM Plex Mono" pitchFamily="34" charset="0"/>
+                <a:ea typeface="IBM Plex Mono" pitchFamily="34" charset="-122"/>
+                <a:cs typeface="IBM Plex Mono" pitchFamily="34" charset="-120"/>
+              </a:rPr>
+              <a:t>THE EPISODIC LAYER</a:t>
+            </a:r>
+            <a:endParaRPr lang="en-US" sz="950" dirty="0"/>
+          </a:p>
+        </p:txBody>
+      </p:sp>
+      <p:sp>
+        <p:nvSpPr>
+          <p:cNvPr id="12" name="Text 9"/>
+          <p:cNvSpPr txBox="1"/>
+          <p:nvPr/>
+        </p:nvSpPr>
+        <p:spPr>
+          <a:xfrm>
+            <a:off x="8095488" y="5522976"/>
+            <a:ext cx="3453384" cy="786384"/>
           </a:xfrm>
           <a:prstGeom prst="rect">
             <a:avLst/>
@@ -11755,12 +14517,12 @@
           <a:p>
             <a:pPr indent="0" marL="0">
               <a:lnSpc>
-                <a:spcPct val="125000"/>
+                <a:spcPct val="124000"/>
               </a:lnSpc>
               <a:buNone/>
             </a:pPr>
             <a:r>
-              <a:rPr lang="en-US" sz="1000" dirty="0">
+              <a:rPr lang="en-US" sz="950" dirty="0">
                 <a:solidFill>
                   <a:srgbClr val="33332F"/>
                 </a:solidFill>
@@ -11768,46 +14530,7 @@
                 <a:ea typeface="Helvetica Neue" pitchFamily="34" charset="-122"/>
                 <a:cs typeface="Helvetica Neue" pitchFamily="34" charset="-120"/>
               </a:rPr>
-              <a:t>North America + Europe: small-arms-through-artillery destruction, metals recovery and plant engineering — the scope the platform assembles.</a:t>
-            </a:r>
-            <a:endParaRPr lang="en-US" sz="1000" dirty="0"/>
-          </a:p>
-        </p:txBody>
-      </p:sp>
-      <p:sp>
-        <p:nvSpPr>
-          <p:cNvPr id="11" name="Text 9"/>
-          <p:cNvSpPr txBox="1"/>
-          <p:nvPr/>
-        </p:nvSpPr>
-        <p:spPr>
-          <a:xfrm>
-            <a:off x="6323076" y="4224528"/>
-            <a:ext cx="5225796" cy="182880"/>
-          </a:xfrm>
-          <a:prstGeom prst="rect">
-            <a:avLst/>
-          </a:prstGeom>
-          <a:noFill/>
-          <a:ln/>
-        </p:spPr>
-        <p:txBody>
-          <a:bodyPr wrap="square" lIns="0" tIns="0" rIns="0" bIns="0" rtlCol="0" anchor="ctr"/>
-          <a:lstStyle/>
-          <a:p>
-            <a:pPr indent="0" marL="0">
-              <a:buNone/>
-            </a:pPr>
-            <a:r>
-              <a:rPr lang="en-US" sz="950" b="1" spc="160" kern="0" dirty="0">
-                <a:solidFill>
-                  <a:srgbClr val="6E6C66"/>
-                </a:solidFill>
-                <a:latin typeface="IBM Plex Mono" pitchFamily="34" charset="0"/>
-                <a:ea typeface="IBM Plex Mono" pitchFamily="34" charset="-122"/>
-                <a:cs typeface="IBM Plex Mono" pitchFamily="34" charset="-120"/>
-              </a:rPr>
-              <a:t>SERVICEABLE OBTAINABLE (SOM)</a:t>
+              <a:t>Post-conflict recovery sits on top and is already priced: Ukraine's demining and explosive-ordnance requirement alone exceeds $30B.¹²</a:t>
             </a:r>
             <a:endParaRPr lang="en-US" sz="950" dirty="0"/>
           </a:p>
@@ -11815,161 +14538,7 @@
       </p:sp>
       <p:sp>
         <p:nvSpPr>
-          <p:cNvPr id="12" name="Text 10"/>
-          <p:cNvSpPr txBox="1"/>
-          <p:nvPr/>
-        </p:nvSpPr>
-        <p:spPr>
-          <a:xfrm>
-            <a:off x="6323076" y="4407408"/>
-            <a:ext cx="5225796" cy="868680"/>
-          </a:xfrm>
-          <a:prstGeom prst="rect">
-            <a:avLst/>
-          </a:prstGeom>
-          <a:noFill/>
-          <a:ln/>
-        </p:spPr>
-        <p:txBody>
-          <a:bodyPr wrap="square" lIns="0" tIns="0" rIns="0" bIns="0" rtlCol="0" anchor="t"/>
-          <a:lstStyle/>
-          <a:p>
-            <a:pPr indent="0" marL="0">
-              <a:buNone/>
-            </a:pPr>
-            <a:r>
-              <a:rPr lang="en-US" sz="4800" spc="-150" kern="0" dirty="0">
-                <a:solidFill>
-                  <a:srgbClr val="000000"/>
-                </a:solidFill>
-                <a:latin typeface="Helvetica Neue" pitchFamily="34" charset="0"/>
-                <a:ea typeface="Helvetica Neue" pitchFamily="34" charset="-122"/>
-                <a:cs typeface="Helvetica Neue" pitchFamily="34" charset="-120"/>
-              </a:rPr>
-              <a:t>$50–100M</a:t>
-            </a:r>
-            <a:pPr indent="0" marL="0">
-              <a:buNone/>
-            </a:pPr>
-            <a:r>
-              <a:rPr lang="en-US" sz="1400" dirty="0">
-                <a:solidFill>
-                  <a:srgbClr val="6E6C66"/>
-                </a:solidFill>
-                <a:latin typeface="Helvetica Neue" pitchFamily="34" charset="0"/>
-                <a:ea typeface="Helvetica Neue" pitchFamily="34" charset="-122"/>
-                <a:cs typeface="Helvetica Neue" pitchFamily="34" charset="-120"/>
-              </a:rPr>
-              <a:t> /yr</a:t>
-            </a:r>
-            <a:endParaRPr lang="en-US" sz="4800" dirty="0"/>
-          </a:p>
-        </p:txBody>
-      </p:sp>
-      <p:sp>
-        <p:nvSpPr>
-          <p:cNvPr id="13" name="Text 11"/>
-          <p:cNvSpPr txBox="1"/>
-          <p:nvPr/>
-        </p:nvSpPr>
-        <p:spPr>
-          <a:xfrm>
-            <a:off x="6323076" y="5276088"/>
-            <a:ext cx="5225796" cy="502920"/>
-          </a:xfrm>
-          <a:prstGeom prst="rect">
-            <a:avLst/>
-          </a:prstGeom>
-          <a:noFill/>
-          <a:ln/>
-        </p:spPr>
-        <p:txBody>
-          <a:bodyPr wrap="square" lIns="0" tIns="0" rIns="0" bIns="0" rtlCol="0" anchor="ctr"/>
-          <a:lstStyle/>
-          <a:p>
-            <a:pPr indent="0" marL="0">
-              <a:lnSpc>
-                <a:spcPct val="125000"/>
-              </a:lnSpc>
-              <a:buNone/>
-            </a:pPr>
-            <a:r>
-              <a:rPr lang="en-US" sz="1000" dirty="0">
-                <a:solidFill>
-                  <a:srgbClr val="33332F"/>
-                </a:solidFill>
-                <a:latin typeface="Helvetica Neue" pitchFamily="34" charset="0"/>
-                <a:ea typeface="Helvetica Neue" pitchFamily="34" charset="-122"/>
-                <a:cs typeface="Helvetica Neue" pitchFamily="34" charset="-120"/>
-              </a:rPr>
-              <a:t>The foothold plus first assembly, five-year horizon: custody destruction of small arms ammunition and seized property — NA law enforcement, defence, first allied programs.</a:t>
-            </a:r>
-            <a:endParaRPr lang="en-US" sz="1000" dirty="0"/>
-          </a:p>
-        </p:txBody>
-      </p:sp>
-      <p:sp>
-        <p:nvSpPr>
-          <p:cNvPr id="14" name="Text 12"/>
-          <p:cNvSpPr txBox="1"/>
-          <p:nvPr/>
-        </p:nvSpPr>
-        <p:spPr>
-          <a:xfrm>
-            <a:off x="640080" y="5897880"/>
-            <a:ext cx="10881360" cy="274320"/>
-          </a:xfrm>
-          <a:prstGeom prst="rect">
-            <a:avLst/>
-          </a:prstGeom>
-          <a:noFill/>
-          <a:ln/>
-        </p:spPr>
-        <p:txBody>
-          <a:bodyPr wrap="square" lIns="0" tIns="0" rIns="0" bIns="0" rtlCol="0" anchor="ctr"/>
-          <a:lstStyle/>
-          <a:p>
-            <a:pPr indent="0" marL="0">
-              <a:lnSpc>
-                <a:spcPct val="115000"/>
-              </a:lnSpc>
-              <a:buNone/>
-            </a:pPr>
-            <a:r>
-              <a:rPr lang="en-US" sz="950" b="1" dirty="0">
-                <a:solidFill>
-                  <a:srgbClr val="000000"/>
-                </a:solidFill>
-                <a:latin typeface="Helvetica Neue" pitchFamily="34" charset="0"/>
-                <a:ea typeface="Helvetica Neue" pitchFamily="34" charset="-122"/>
-                <a:cs typeface="Helvetica Neue" pitchFamily="34" charset="-120"/>
-              </a:rPr>
-              <a:t>No analyst covers this market — which is precisely why it is available. </a:t>
-            </a:r>
-            <a:pPr indent="0" marL="0">
-              <a:lnSpc>
-                <a:spcPct val="115000"/>
-              </a:lnSpc>
-              <a:buNone/>
-            </a:pPr>
-            <a:r>
-              <a:rPr lang="en-US" sz="950" dirty="0">
-                <a:solidFill>
-                  <a:srgbClr val="6E6C66"/>
-                </a:solidFill>
-                <a:latin typeface="Helvetica Neue" pitchFamily="34" charset="0"/>
-                <a:ea typeface="Helvetica Neue" pitchFamily="34" charset="-122"/>
-                <a:cs typeface="Helvetica Neue" pitchFamily="34" charset="-120"/>
-              </a:rPr>
-              <a:t>Anchors: demil at ~$2,000–2,890/ton (GAO, NAS) · &gt;$4B US weapons-destruction spend abroad since 1993.</a:t>
-            </a:r>
-            <a:endParaRPr lang="en-US" sz="950" dirty="0"/>
-          </a:p>
-        </p:txBody>
-      </p:sp>
-      <p:sp>
-        <p:nvSpPr>
-          <p:cNvPr id="15" name="Text 13"/>
+          <p:cNvPr id="13" name="Text 10"/>
           <p:cNvSpPr txBox="1"/>
           <p:nvPr/>
         </p:nvSpPr>
@@ -12294,7 +14863,7 @@
                 <a:ea typeface="IBM Plex Mono" pitchFamily="34" charset="-122"/>
                 <a:cs typeface="IBM Plex Mono" pitchFamily="34" charset="-120"/>
               </a:rPr>
-              <a:t>EBITDA</a:t>
+              <a:t>EBITDA¹⁷</a:t>
             </a:r>
             <a:endParaRPr lang="en-US" sz="850" dirty="0"/>
           </a:p>

</xml_diff>

<commit_message>
Deck V5: ten-point demilitarization backlog series on slide 3
Extracted the SMCA B5A account tonnage from ten Army Procurement of
Ammunition justification books (FY2018-FY2027, line item 4099EP1700),
giving ten consecutive snapshots from end-FY2016 (471,767 tons) to
4 Dec 2025 (296,534 tons). Charted as a stacked area splitting
conventional ammunition from missile components: total down 37% while
missile components rose 62%, from 6.5% to 16.8% of the account.

Adds the years-to-clear figure (9.4 yrs at the FY2027 funded rate of
31,475 tons) and the funded-throughput decline. Citations 5 and 18
updated to cite the full book series.
</commit_message>
<xml_diff>
--- a/deck/TWB_Investment_Deck.pptx
+++ b/deck/TWB_Investment_Deck.pptx
@@ -1398,7 +1398,7 @@
           <a:p>
             <a:r>
               <a:rPr lang="en-US" dirty="0"/>
-              <a:t>Two numbers, one problem: tons AND dollars. The queue number is proof the best-resourced military on earth is already behind, in peacetime, before the surge lands. The dollar figure is our calculation from two verified anchors — say so plainly if asked. Ukraine's $30B cleanup bill (World Bank RDNA4) is the same logic compressed into one country.</a:t>
+              <a:t>This chart is the deck's proprietary asset — ten consecutive snapshots pulled from the Army's own budget justification books, one line item, one account definition. Nobody has assembled it publicly. Two movements matter: the total falls 37%, and missile components climb from 6.5% to 16.8% — the account is shrinking and getting harder at the same time, and missile components are the expensive, difficult disposal category. The 9.4 years is ours: 296,534 tons divided by the FY2027 funded plan of 31,475 tons, and it assumes not one new round arrives, which the previous slide has just shown to be absurd. Older context if pressed: GAO put the account at 529,373 short tons in February 2015.</a:t>
             </a:r>
             <a:endParaRPr lang="en-US" dirty="0"/>
           </a:p>
@@ -8597,7 +8597,7 @@
                 <a:ea typeface="Helvetica Neue" pitchFamily="34" charset="-122"/>
                 <a:cs typeface="Helvetica Neue" pitchFamily="34" charset="-120"/>
               </a:rPr>
-              <a:t>FY2026 President’s Budget, Procurement of Ammunition justification book (June 2025), line 4099EP1700: as of 30 January 2025 the SMCA Resource, Recovery and Disposition Account (B5A) held 309,065 tons — 260,032 tons conventional ammunition and 49,033 tons missile components. “Over 7,000 items” per Army AL&amp;T, Fall 2024, and National Academies (2019).</a:t>
+              <a:t>Procurement of Ammunition, Army — President’s Budget justification books FY2018 through FY2027, budget line item 4099EP1700 (EP1700 in FY2018), “Conventional Munitions Demilitarization”. Each book states the tonnage held in the SMCA Resource, Recovery and Disposition Account (B5A) on a stated date; the ten snapshots charted run from end-FY2016 (471,767 tons) to 4 December 2025 (296,534 tons — 246,681 conventional, 49,853 missile components). Snapshot dates are irregular and are plotted at their actual dates. “Over 7,000 items” per Army AL&amp;T, Fall 2024, and National Academies (2019).</a:t>
             </a:r>
             <a:endParaRPr lang="en-US" sz="850" dirty="0"/>
           </a:p>
@@ -10329,7 +10329,7 @@
                 <a:ea typeface="Helvetica Neue" pitchFamily="34" charset="-122"/>
                 <a:cs typeface="Helvetica Neue" pitchFamily="34" charset="-120"/>
               </a:rPr>
-              <a:t>Demilitarization throughput: approximately 82,000 tons destroyed in FY2015 (PEO Ammunition, NDIA Global Demilitarization Symposium, December 2015); FY2026 funded plan of 29,313 tons at $155.05M (Army FY2026 President’s Budget). Stockpile drawdown has slowed as funded capacity has fallen.</a:t>
+              <a:t>Demilitarization throughput: approximately 82,000 tons destroyed in FY2015 (PEO Ammunition, NDIA Global Demilitarization Symposium, December 2015). Funded plans from the same justification books: FY2023 28,568 tons; FY2024 41,566; FY2025 18,617; FY2026 29,313; FY2027 31,475 tons at $161.179M. Line-item funding fell from $235.1M (FY2021) to $161.2M (FY2027).</a:t>
             </a:r>
             <a:endParaRPr lang="en-US" sz="850" dirty="0"/>
           </a:p>
@@ -11035,24 +11035,24 @@
         </p:nvSpPr>
         <p:spPr>
           <a:xfrm>
-            <a:off x="640080" y="868680"/>
-            <a:ext cx="10789920" cy="777240"/>
-          </a:xfrm>
-          <a:prstGeom prst="rect">
-            <a:avLst/>
-          </a:prstGeom>
-          <a:noFill/>
-          <a:ln/>
-        </p:spPr>
-        <p:txBody>
-          <a:bodyPr wrap="square" lIns="0" tIns="0" rIns="0" bIns="0" rtlCol="0" anchor="ctr"/>
-          <a:lstStyle/>
-          <a:p>
-            <a:pPr indent="0" marL="0">
-              <a:buNone/>
-            </a:pPr>
-            <a:r>
-              <a:rPr lang="en-US" sz="2800" spc="-30" kern="0" dirty="0">
+            <a:off x="640080" y="768096"/>
+            <a:ext cx="10789920" cy="566928"/>
+          </a:xfrm>
+          <a:prstGeom prst="rect">
+            <a:avLst/>
+          </a:prstGeom>
+          <a:noFill/>
+          <a:ln/>
+        </p:spPr>
+        <p:txBody>
+          <a:bodyPr wrap="square" lIns="0" tIns="0" rIns="0" bIns="0" rtlCol="0" anchor="ctr"/>
+          <a:lstStyle/>
+          <a:p>
+            <a:pPr indent="0" marL="0">
+              <a:buNone/>
+            </a:pPr>
+            <a:r>
+              <a:rPr lang="en-US" sz="2500" spc="-30" kern="0" dirty="0">
                 <a:solidFill>
                   <a:srgbClr val="000000"/>
                 </a:solidFill>
@@ -11062,7 +11062,7 @@
               </a:rPr>
               <a:t>Ammunition is the only weapon you must destroy to retire.</a:t>
             </a:r>
-            <a:endParaRPr lang="en-US" sz="2800" dirty="0"/>
+            <a:endParaRPr lang="en-US" sz="2500" dirty="0"/>
           </a:p>
         </p:txBody>
       </p:sp>
@@ -11074,24 +11074,24 @@
         </p:nvSpPr>
         <p:spPr>
           <a:xfrm>
-            <a:off x="640080" y="1874520"/>
-            <a:ext cx="5577840" cy="1371600"/>
-          </a:xfrm>
-          <a:prstGeom prst="rect">
-            <a:avLst/>
-          </a:prstGeom>
-          <a:noFill/>
-          <a:ln/>
-        </p:spPr>
-        <p:txBody>
-          <a:bodyPr wrap="square" lIns="0" tIns="0" rIns="0" bIns="0" rtlCol="0" anchor="t"/>
-          <a:lstStyle/>
-          <a:p>
-            <a:pPr algn="l" indent="0" marL="0">
-              <a:buNone/>
-            </a:pPr>
-            <a:r>
-              <a:rPr lang="en-US" sz="7600" spc="-200" kern="0" dirty="0">
+            <a:off x="640080" y="1389888"/>
+            <a:ext cx="3380232" cy="420624"/>
+          </a:xfrm>
+          <a:prstGeom prst="rect">
+            <a:avLst/>
+          </a:prstGeom>
+          <a:noFill/>
+          <a:ln/>
+        </p:spPr>
+        <p:txBody>
+          <a:bodyPr wrap="square" lIns="0" tIns="0" rIns="0" bIns="0" rtlCol="0" anchor="ctr"/>
+          <a:lstStyle/>
+          <a:p>
+            <a:pPr indent="0" marL="0">
+              <a:buNone/>
+            </a:pPr>
+            <a:r>
+              <a:rPr lang="en-US" sz="3000" spc="-100" kern="0" dirty="0">
                 <a:solidFill>
                   <a:srgbClr val="000000"/>
                 </a:solidFill>
@@ -11099,9 +11099,9 @@
                 <a:ea typeface="Helvetica Neue" pitchFamily="34" charset="-122"/>
                 <a:cs typeface="Helvetica Neue" pitchFamily="34" charset="-120"/>
               </a:rPr>
-              <a:t>309,065</a:t>
-            </a:r>
-            <a:endParaRPr lang="en-US" sz="7600" dirty="0"/>
+              <a:t>296,534 t</a:t>
+            </a:r>
+            <a:endParaRPr lang="en-US" sz="3000" dirty="0"/>
           </a:p>
         </p:txBody>
       </p:sp>
@@ -11113,212 +11113,50 @@
         </p:nvSpPr>
         <p:spPr>
           <a:xfrm>
-            <a:off x="640080" y="3191256"/>
-            <a:ext cx="5394960" cy="548640"/>
-          </a:xfrm>
-          <a:prstGeom prst="rect">
-            <a:avLst/>
-          </a:prstGeom>
-          <a:noFill/>
-          <a:ln/>
-        </p:spPr>
-        <p:txBody>
-          <a:bodyPr wrap="square" lIns="0" tIns="0" rIns="0" bIns="0" rtlCol="0" anchor="ctr"/>
-          <a:lstStyle/>
-          <a:p>
-            <a:pPr algn="l" indent="0" marL="0">
+            <a:off x="640080" y="1810512"/>
+            <a:ext cx="3380232" cy="274320"/>
+          </a:xfrm>
+          <a:prstGeom prst="rect">
+            <a:avLst/>
+          </a:prstGeom>
+          <a:noFill/>
+          <a:ln/>
+        </p:spPr>
+        <p:txBody>
+          <a:bodyPr wrap="square" lIns="0" tIns="0" rIns="0" bIns="0" rtlCol="0" anchor="ctr"/>
+          <a:lstStyle/>
+          <a:p>
+            <a:pPr indent="0" marL="0">
               <a:lnSpc>
-                <a:spcPct val="140000"/>
+                <a:spcPct val="125000"/>
               </a:lnSpc>
               <a:buNone/>
             </a:pPr>
             <a:r>
-              <a:rPr lang="en-US" sz="1050" b="1" spc="180" kern="0" dirty="0">
-                <a:solidFill>
-                  <a:srgbClr val="66705F"/>
+              <a:rPr lang="en-US" sz="760" b="1" spc="120" kern="0" dirty="0">
+                <a:solidFill>
+                  <a:srgbClr val="6E6C66"/>
                 </a:solidFill>
                 <a:latin typeface="IBM Plex Mono" pitchFamily="34" charset="0"/>
                 <a:ea typeface="IBM Plex Mono" pitchFamily="34" charset="-122"/>
                 <a:cs typeface="IBM Plex Mono" pitchFamily="34" charset="-120"/>
               </a:rPr>
-              <a:t>TONS AWAITING DEMILITARIZATION — US STOCKPILE, 30 JAN 2025 (ARMY BUDGET JUSTIFICATION)⁵</a:t>
-            </a:r>
-            <a:endParaRPr lang="en-US" sz="1050" dirty="0"/>
-          </a:p>
-        </p:txBody>
-      </p:sp>
-      <p:sp>
-        <p:nvSpPr>
-          <p:cNvPr id="6" name="Text 4"/>
-          <p:cNvSpPr txBox="1"/>
-          <p:nvPr/>
-        </p:nvSpPr>
-        <p:spPr>
-          <a:xfrm>
-            <a:off x="640080" y="3730752"/>
-            <a:ext cx="5394960" cy="320040"/>
-          </a:xfrm>
-          <a:prstGeom prst="rect">
-            <a:avLst/>
-          </a:prstGeom>
-          <a:noFill/>
-          <a:ln/>
-        </p:spPr>
-        <p:txBody>
-          <a:bodyPr wrap="square" lIns="0" tIns="0" rIns="0" bIns="0" rtlCol="0" anchor="ctr"/>
-          <a:lstStyle/>
-          <a:p>
-            <a:pPr indent="0" marL="0">
-              <a:buNone/>
-            </a:pPr>
-            <a:r>
-              <a:rPr lang="en-US" sz="820" spc="100" kern="0" dirty="0">
-                <a:solidFill>
-                  <a:srgbClr val="6E6C66"/>
-                </a:solidFill>
-                <a:latin typeface="IBM Plex Mono" pitchFamily="34" charset="0"/>
-                <a:ea typeface="IBM Plex Mono" pitchFamily="34" charset="-122"/>
-                <a:cs typeface="IBM Plex Mono" pitchFamily="34" charset="-120"/>
-              </a:rPr>
-              <a:t>260,032 T CONVENTIONAL · 49,033 T MISSILE COMPONENTS · &gt;7,000 MUNITION TYPES</a:t>
-            </a:r>
-            <a:endParaRPr lang="en-US" sz="820" dirty="0"/>
-          </a:p>
-        </p:txBody>
-      </p:sp>
-      <p:sp>
-        <p:nvSpPr>
-          <p:cNvPr id="7" name="Text 5"/>
-          <p:cNvSpPr txBox="1"/>
-          <p:nvPr/>
-        </p:nvSpPr>
-        <p:spPr>
-          <a:xfrm>
-            <a:off x="6446520" y="1874520"/>
-            <a:ext cx="5120640" cy="1371600"/>
-          </a:xfrm>
-          <a:prstGeom prst="rect">
-            <a:avLst/>
-          </a:prstGeom>
-          <a:noFill/>
-          <a:ln/>
-        </p:spPr>
-        <p:txBody>
-          <a:bodyPr wrap="square" lIns="0" tIns="0" rIns="0" bIns="0" rtlCol="0" anchor="t"/>
-          <a:lstStyle/>
-          <a:p>
-            <a:pPr algn="l" indent="0" marL="0">
-              <a:buNone/>
-            </a:pPr>
-            <a:r>
-              <a:rPr lang="en-US" sz="6600" spc="-200" kern="0" dirty="0">
-                <a:solidFill>
-                  <a:srgbClr val="66705F"/>
-                </a:solidFill>
-                <a:latin typeface="Helvetica Neue" pitchFamily="34" charset="0"/>
-                <a:ea typeface="Helvetica Neue" pitchFamily="34" charset="-122"/>
-                <a:cs typeface="Helvetica Neue" pitchFamily="34" charset="-120"/>
-              </a:rPr>
-              <a:t>$0.6–0.9B</a:t>
-            </a:r>
-            <a:endParaRPr lang="en-US" sz="6600" dirty="0"/>
-          </a:p>
-        </p:txBody>
-      </p:sp>
-      <p:sp>
-        <p:nvSpPr>
-          <p:cNvPr id="8" name="Text 6"/>
-          <p:cNvSpPr txBox="1"/>
-          <p:nvPr/>
-        </p:nvSpPr>
-        <p:spPr>
-          <a:xfrm>
-            <a:off x="6446520" y="3191256"/>
-            <a:ext cx="5029200" cy="548640"/>
-          </a:xfrm>
-          <a:prstGeom prst="rect">
-            <a:avLst/>
-          </a:prstGeom>
-          <a:noFill/>
-          <a:ln/>
-        </p:spPr>
-        <p:txBody>
-          <a:bodyPr wrap="square" lIns="0" tIns="0" rIns="0" bIns="0" rtlCol="0" anchor="ctr"/>
-          <a:lstStyle/>
-          <a:p>
-            <a:pPr algn="l" indent="0" marL="0">
-              <a:lnSpc>
-                <a:spcPct val="140000"/>
-              </a:lnSpc>
-              <a:buNone/>
-            </a:pPr>
-            <a:r>
-              <a:rPr lang="en-US" sz="1050" b="1" spc="180" kern="0" dirty="0">
-                <a:solidFill>
-                  <a:srgbClr val="66705F"/>
-                </a:solidFill>
-                <a:latin typeface="IBM Plex Mono" pitchFamily="34" charset="0"/>
-                <a:ea typeface="IBM Plex Mono" pitchFamily="34" charset="-122"/>
-                <a:cs typeface="IBM Plex Mono" pitchFamily="34" charset="-120"/>
-              </a:rPr>
-              <a:t>IMPLIED COST TO CLEAR IT, AT PUBLISHED DEMIL RATES⁵ ⁶</a:t>
-            </a:r>
-            <a:endParaRPr lang="en-US" sz="1050" dirty="0"/>
-          </a:p>
-        </p:txBody>
-      </p:sp>
-      <p:sp>
-        <p:nvSpPr>
-          <p:cNvPr id="9" name="Text 7"/>
-          <p:cNvSpPr txBox="1"/>
-          <p:nvPr/>
-        </p:nvSpPr>
-        <p:spPr>
-          <a:xfrm>
-            <a:off x="6446520" y="3730752"/>
-            <a:ext cx="5120640" cy="457200"/>
-          </a:xfrm>
-          <a:prstGeom prst="rect">
-            <a:avLst/>
-          </a:prstGeom>
-          <a:noFill/>
-          <a:ln/>
-        </p:spPr>
-        <p:txBody>
-          <a:bodyPr wrap="square" lIns="0" tIns="0" rIns="0" bIns="0" rtlCol="0" anchor="ctr"/>
-          <a:lstStyle/>
-          <a:p>
-            <a:pPr indent="0" marL="0">
-              <a:lnSpc>
-                <a:spcPct val="130000"/>
-              </a:lnSpc>
-              <a:buNone/>
-            </a:pPr>
-            <a:r>
-              <a:rPr lang="en-US" sz="800" spc="60" kern="0" dirty="0">
-                <a:solidFill>
-                  <a:srgbClr val="6E6C66"/>
-                </a:solidFill>
-                <a:latin typeface="IBM Plex Mono" pitchFamily="34" charset="0"/>
-                <a:ea typeface="IBM Plex Mono" pitchFamily="34" charset="-122"/>
-                <a:cs typeface="IBM Plex Mono" pitchFamily="34" charset="-120"/>
-              </a:rPr>
-              <a:t>Illustrative: 309,065 t × $2,000–2,890/ton (GAO FY15 / NAS demil cost range). Not an official total.</a:t>
-            </a:r>
-            <a:endParaRPr lang="en-US" sz="800" dirty="0"/>
-          </a:p>
-        </p:txBody>
-      </p:sp>
-      <p:sp>
-        <p:nvSpPr>
-          <p:cNvPr id="10" name="Shape 8"/>
+              <a:t>AWAITING DEMILITARIZATION — US STOCKPILE, 4 DEC 2025⁵</a:t>
+            </a:r>
+            <a:endParaRPr lang="en-US" sz="760" dirty="0"/>
+          </a:p>
+        </p:txBody>
+      </p:sp>
+      <p:sp>
+        <p:nvSpPr>
+          <p:cNvPr id="6" name="Shape 4"/>
           <p:cNvSpPr/>
           <p:nvPr/>
         </p:nvSpPr>
         <p:spPr>
           <a:xfrm>
-            <a:off x="640080" y="4224528"/>
-            <a:ext cx="10908792" cy="0"/>
+            <a:off x="4212336" y="1426464"/>
+            <a:ext cx="0" cy="566928"/>
           </a:xfrm>
           <a:prstGeom prst="line">
             <a:avLst/>
@@ -11334,258 +11172,157 @@
       </p:sp>
       <p:sp>
         <p:nvSpPr>
-          <p:cNvPr id="11" name="Text 9"/>
-          <p:cNvSpPr txBox="1"/>
-          <p:nvPr/>
-        </p:nvSpPr>
-        <p:spPr>
-          <a:xfrm>
-            <a:off x="640080" y="4434840"/>
-            <a:ext cx="5486400" cy="1371600"/>
-          </a:xfrm>
-          <a:prstGeom prst="rect">
-            <a:avLst/>
-          </a:prstGeom>
-          <a:noFill/>
-          <a:ln/>
-        </p:spPr>
-        <p:txBody>
-          <a:bodyPr wrap="square" lIns="0" tIns="0" rIns="0" bIns="0" rtlCol="0" anchor="ctr"/>
-          <a:lstStyle/>
-          <a:p>
-            <a:pPr indent="0" marL="0">
-              <a:lnSpc>
-                <a:spcPct val="130000"/>
-              </a:lnSpc>
-              <a:buNone/>
-            </a:pPr>
-            <a:r>
-              <a:rPr lang="en-US" sz="1300" dirty="0">
-                <a:solidFill>
-                  <a:srgbClr val="33332F"/>
+          <p:cNvPr id="7" name="Text 5"/>
+          <p:cNvSpPr txBox="1"/>
+          <p:nvPr/>
+        </p:nvSpPr>
+        <p:spPr>
+          <a:xfrm>
+            <a:off x="4404360" y="1389888"/>
+            <a:ext cx="3380232" cy="420624"/>
+          </a:xfrm>
+          <a:prstGeom prst="rect">
+            <a:avLst/>
+          </a:prstGeom>
+          <a:noFill/>
+          <a:ln/>
+        </p:spPr>
+        <p:txBody>
+          <a:bodyPr wrap="square" lIns="0" tIns="0" rIns="0" bIns="0" rtlCol="0" anchor="ctr"/>
+          <a:lstStyle/>
+          <a:p>
+            <a:pPr indent="0" marL="0">
+              <a:buNone/>
+            </a:pPr>
+            <a:r>
+              <a:rPr lang="en-US" sz="3000" spc="-100" kern="0" dirty="0">
+                <a:solidFill>
+                  <a:srgbClr val="000000"/>
                 </a:solidFill>
                 <a:latin typeface="Helvetica Neue" pitchFamily="34" charset="0"/>
                 <a:ea typeface="Helvetica Neue" pitchFamily="34" charset="-122"/>
                 <a:cs typeface="Helvetica Neue" pitchFamily="34" charset="-120"/>
               </a:rPr>
-              <a:t>A warship is scrapped. A rifle sits in a rack for a century. Ammunition ages chemically </a:t>
-            </a:r>
+              <a:t>9.4 yrs</a:t>
+            </a:r>
+            <a:endParaRPr lang="en-US" sz="3000" dirty="0"/>
+          </a:p>
+        </p:txBody>
+      </p:sp>
+      <p:sp>
+        <p:nvSpPr>
+          <p:cNvPr id="8" name="Text 6"/>
+          <p:cNvSpPr txBox="1"/>
+          <p:nvPr/>
+        </p:nvSpPr>
+        <p:spPr>
+          <a:xfrm>
+            <a:off x="4404360" y="1810512"/>
+            <a:ext cx="3380232" cy="274320"/>
+          </a:xfrm>
+          <a:prstGeom prst="rect">
+            <a:avLst/>
+          </a:prstGeom>
+          <a:noFill/>
+          <a:ln/>
+        </p:spPr>
+        <p:txBody>
+          <a:bodyPr wrap="square" lIns="0" tIns="0" rIns="0" bIns="0" rtlCol="0" anchor="ctr"/>
+          <a:lstStyle/>
+          <a:p>
             <a:pPr indent="0" marL="0">
               <a:lnSpc>
-                <a:spcPct val="130000"/>
+                <a:spcPct val="125000"/>
               </a:lnSpc>
               <a:buNone/>
             </a:pPr>
             <a:r>
-              <a:rPr lang="en-US" sz="1300" dirty="0">
-                <a:solidFill>
-                  <a:srgbClr val="33332F"/>
+              <a:rPr lang="en-US" sz="760" b="1" spc="120" kern="0" dirty="0">
+                <a:solidFill>
+                  <a:srgbClr val="6E6C66"/>
+                </a:solidFill>
+                <a:latin typeface="IBM Plex Mono" pitchFamily="34" charset="0"/>
+                <a:ea typeface="IBM Plex Mono" pitchFamily="34" charset="-122"/>
+                <a:cs typeface="IBM Plex Mono" pitchFamily="34" charset="-120"/>
+              </a:rPr>
+              <a:t>TO CLEAR IT AT THE FUNDED RATE — BEFORE THE SURGE ADDS A ROUND⁵ ¹⁸</a:t>
+            </a:r>
+            <a:endParaRPr lang="en-US" sz="760" dirty="0"/>
+          </a:p>
+        </p:txBody>
+      </p:sp>
+      <p:sp>
+        <p:nvSpPr>
+          <p:cNvPr id="9" name="Shape 7"/>
+          <p:cNvSpPr/>
+          <p:nvPr/>
+        </p:nvSpPr>
+        <p:spPr>
+          <a:xfrm>
+            <a:off x="7976616" y="1426464"/>
+            <a:ext cx="0" cy="566928"/>
+          </a:xfrm>
+          <a:prstGeom prst="line">
+            <a:avLst/>
+          </a:prstGeom>
+          <a:noFill/>
+          <a:ln w="9525">
+            <a:solidFill>
+              <a:srgbClr val="E2E1DA"/>
+            </a:solidFill>
+            <a:prstDash val="solid"/>
+          </a:ln>
+        </p:spPr>
+      </p:sp>
+      <p:sp>
+        <p:nvSpPr>
+          <p:cNvPr id="10" name="Text 8"/>
+          <p:cNvSpPr txBox="1"/>
+          <p:nvPr/>
+        </p:nvSpPr>
+        <p:spPr>
+          <a:xfrm>
+            <a:off x="8168640" y="1389888"/>
+            <a:ext cx="3380232" cy="420624"/>
+          </a:xfrm>
+          <a:prstGeom prst="rect">
+            <a:avLst/>
+          </a:prstGeom>
+          <a:noFill/>
+          <a:ln/>
+        </p:spPr>
+        <p:txBody>
+          <a:bodyPr wrap="square" lIns="0" tIns="0" rIns="0" bIns="0" rtlCol="0" anchor="ctr"/>
+          <a:lstStyle/>
+          <a:p>
+            <a:pPr indent="0" marL="0">
+              <a:buNone/>
+            </a:pPr>
+            <a:r>
+              <a:rPr lang="en-US" sz="3000" spc="-100" kern="0" dirty="0">
+                <a:solidFill>
+                  <a:srgbClr val="66705F"/>
                 </a:solidFill>
                 <a:latin typeface="Helvetica Neue" pitchFamily="34" charset="0"/>
                 <a:ea typeface="Helvetica Neue" pitchFamily="34" charset="-122"/>
                 <a:cs typeface="Helvetica Neue" pitchFamily="34" charset="-120"/>
               </a:rPr>
-              <a:t>— propellants destabilise, primers corrode, calibres are orphaned every time the gun changes. Every round must be guarded, inventoried and inspected — at cost, forever — until it is destroyed.</a:t>
-            </a:r>
-            <a:endParaRPr lang="en-US" sz="1300" dirty="0"/>
-          </a:p>
-        </p:txBody>
-      </p:sp>
-      <p:sp>
-        <p:nvSpPr>
-          <p:cNvPr id="12" name="Shape 10"/>
-          <p:cNvSpPr/>
-          <p:nvPr/>
-        </p:nvSpPr>
-        <p:spPr>
-          <a:xfrm>
-            <a:off x="6446520" y="4434840"/>
-            <a:ext cx="5120640" cy="1371600"/>
-          </a:xfrm>
-          <a:prstGeom prst="rect">
-            <a:avLst/>
-          </a:prstGeom>
-          <a:solidFill>
-            <a:srgbClr val="F1F3F0"/>
-          </a:solidFill>
-          <a:ln w="9525">
-            <a:solidFill>
-              <a:srgbClr val="D3D9D0"/>
-            </a:solidFill>
-            <a:prstDash val="solid"/>
-          </a:ln>
-        </p:spPr>
-      </p:sp>
-      <p:sp>
-        <p:nvSpPr>
-          <p:cNvPr id="13" name="Shape 11"/>
-          <p:cNvSpPr/>
-          <p:nvPr/>
-        </p:nvSpPr>
-        <p:spPr>
-          <a:xfrm>
-            <a:off x="6427318" y="4415638"/>
-            <a:ext cx="59436" cy="12802"/>
-          </a:xfrm>
-          <a:prstGeom prst="rect">
-            <a:avLst/>
-          </a:prstGeom>
-          <a:solidFill>
-            <a:srgbClr val="66705F"/>
-          </a:solidFill>
-          <a:ln/>
-        </p:spPr>
-      </p:sp>
-      <p:sp>
-        <p:nvSpPr>
-          <p:cNvPr id="14" name="Shape 12"/>
-          <p:cNvSpPr/>
-          <p:nvPr/>
-        </p:nvSpPr>
-        <p:spPr>
-          <a:xfrm>
-            <a:off x="6427318" y="4415638"/>
-            <a:ext cx="12802" cy="59436"/>
-          </a:xfrm>
-          <a:prstGeom prst="rect">
-            <a:avLst/>
-          </a:prstGeom>
-          <a:solidFill>
-            <a:srgbClr val="66705F"/>
-          </a:solidFill>
-          <a:ln/>
-        </p:spPr>
-      </p:sp>
-      <p:sp>
-        <p:nvSpPr>
-          <p:cNvPr id="15" name="Shape 13"/>
-          <p:cNvSpPr/>
-          <p:nvPr/>
-        </p:nvSpPr>
-        <p:spPr>
-          <a:xfrm>
-            <a:off x="11526926" y="4415638"/>
-            <a:ext cx="59436" cy="12802"/>
-          </a:xfrm>
-          <a:prstGeom prst="rect">
-            <a:avLst/>
-          </a:prstGeom>
-          <a:solidFill>
-            <a:srgbClr val="66705F"/>
-          </a:solidFill>
-          <a:ln/>
-        </p:spPr>
-      </p:sp>
-      <p:sp>
-        <p:nvSpPr>
-          <p:cNvPr id="16" name="Shape 14"/>
-          <p:cNvSpPr/>
-          <p:nvPr/>
-        </p:nvSpPr>
-        <p:spPr>
-          <a:xfrm>
-            <a:off x="11573561" y="4415638"/>
-            <a:ext cx="12802" cy="59436"/>
-          </a:xfrm>
-          <a:prstGeom prst="rect">
-            <a:avLst/>
-          </a:prstGeom>
-          <a:solidFill>
-            <a:srgbClr val="66705F"/>
-          </a:solidFill>
-          <a:ln/>
-        </p:spPr>
-      </p:sp>
-      <p:sp>
-        <p:nvSpPr>
-          <p:cNvPr id="17" name="Shape 15"/>
-          <p:cNvSpPr/>
-          <p:nvPr/>
-        </p:nvSpPr>
-        <p:spPr>
-          <a:xfrm>
-            <a:off x="6427318" y="5812841"/>
-            <a:ext cx="59436" cy="12802"/>
-          </a:xfrm>
-          <a:prstGeom prst="rect">
-            <a:avLst/>
-          </a:prstGeom>
-          <a:solidFill>
-            <a:srgbClr val="66705F"/>
-          </a:solidFill>
-          <a:ln/>
-        </p:spPr>
-      </p:sp>
-      <p:sp>
-        <p:nvSpPr>
-          <p:cNvPr id="18" name="Shape 16"/>
-          <p:cNvSpPr/>
-          <p:nvPr/>
-        </p:nvSpPr>
-        <p:spPr>
-          <a:xfrm>
-            <a:off x="6427318" y="5766206"/>
-            <a:ext cx="12802" cy="59436"/>
-          </a:xfrm>
-          <a:prstGeom prst="rect">
-            <a:avLst/>
-          </a:prstGeom>
-          <a:solidFill>
-            <a:srgbClr val="66705F"/>
-          </a:solidFill>
-          <a:ln/>
-        </p:spPr>
-      </p:sp>
-      <p:sp>
-        <p:nvSpPr>
-          <p:cNvPr id="19" name="Shape 17"/>
-          <p:cNvSpPr/>
-          <p:nvPr/>
-        </p:nvSpPr>
-        <p:spPr>
-          <a:xfrm>
-            <a:off x="11526926" y="5812841"/>
-            <a:ext cx="59436" cy="12802"/>
-          </a:xfrm>
-          <a:prstGeom prst="rect">
-            <a:avLst/>
-          </a:prstGeom>
-          <a:solidFill>
-            <a:srgbClr val="66705F"/>
-          </a:solidFill>
-          <a:ln/>
-        </p:spPr>
-      </p:sp>
-      <p:sp>
-        <p:nvSpPr>
-          <p:cNvPr id="20" name="Shape 18"/>
-          <p:cNvSpPr/>
-          <p:nvPr/>
-        </p:nvSpPr>
-        <p:spPr>
-          <a:xfrm>
-            <a:off x="11573561" y="5766206"/>
-            <a:ext cx="12802" cy="59436"/>
-          </a:xfrm>
-          <a:prstGeom prst="rect">
-            <a:avLst/>
-          </a:prstGeom>
-          <a:solidFill>
-            <a:srgbClr val="66705F"/>
-          </a:solidFill>
-          <a:ln/>
-        </p:spPr>
-      </p:sp>
-      <p:sp>
-        <p:nvSpPr>
-          <p:cNvPr id="21" name="Text 19"/>
-          <p:cNvSpPr txBox="1"/>
-          <p:nvPr/>
-        </p:nvSpPr>
-        <p:spPr>
-          <a:xfrm>
-            <a:off x="6675120" y="4590288"/>
-            <a:ext cx="4663440" cy="1097280"/>
+              <a:t>$0.6–0.9B</a:t>
+            </a:r>
+            <a:endParaRPr lang="en-US" sz="3000" dirty="0"/>
+          </a:p>
+        </p:txBody>
+      </p:sp>
+      <p:sp>
+        <p:nvSpPr>
+          <p:cNvPr id="11" name="Text 9"/>
+          <p:cNvSpPr txBox="1"/>
+          <p:nvPr/>
+        </p:nvSpPr>
+        <p:spPr>
+          <a:xfrm>
+            <a:off x="8168640" y="1810512"/>
+            <a:ext cx="3380232" cy="274320"/>
           </a:xfrm>
           <a:prstGeom prst="rect">
             <a:avLst/>
@@ -11599,12 +11336,78 @@
           <a:p>
             <a:pPr indent="0" marL="0">
               <a:lnSpc>
-                <a:spcPct val="128000"/>
+                <a:spcPct val="125000"/>
               </a:lnSpc>
               <a:buNone/>
             </a:pPr>
             <a:r>
-              <a:rPr lang="en-US" sz="1200" b="1" dirty="0">
+              <a:rPr lang="en-US" sz="760" b="1" spc="120" kern="0" dirty="0">
+                <a:solidFill>
+                  <a:srgbClr val="6E6C66"/>
+                </a:solidFill>
+                <a:latin typeface="IBM Plex Mono" pitchFamily="34" charset="0"/>
+                <a:ea typeface="IBM Plex Mono" pitchFamily="34" charset="-122"/>
+                <a:cs typeface="IBM Plex Mono" pitchFamily="34" charset="-120"/>
+              </a:rPr>
+              <a:t>IMPLIED COST, AT PUBLISHED DEMIL RATES⁵ ⁶</a:t>
+            </a:r>
+            <a:endParaRPr lang="en-US" sz="760" dirty="0"/>
+          </a:p>
+        </p:txBody>
+      </p:sp>
+      <p:pic>
+        <p:nvPicPr>
+          <p:cNvPr id="12" name="Image 0" descr="/root/twb-build/deck/charts/slide3_backlog.png">    </p:cNvPr>
+          <p:cNvPicPr>
+            <a:picLocks noChangeAspect="1"/>
+          </p:cNvPicPr>
+          <p:nvPr/>
+        </p:nvPicPr>
+        <p:blipFill>
+          <a:blip r:embed="rId1"/>
+          <a:stretch>
+            <a:fillRect/>
+          </a:stretch>
+        </p:blipFill>
+        <p:spPr>
+          <a:xfrm>
+            <a:off x="640080" y="2212848"/>
+            <a:ext cx="10908792" cy="3589934"/>
+          </a:xfrm>
+          <a:prstGeom prst="rect">
+            <a:avLst/>
+          </a:prstGeom>
+        </p:spPr>
+      </p:pic>
+      <p:sp>
+        <p:nvSpPr>
+          <p:cNvPr id="13" name="Text 10"/>
+          <p:cNvSpPr txBox="1"/>
+          <p:nvPr/>
+        </p:nvSpPr>
+        <p:spPr>
+          <a:xfrm>
+            <a:off x="640080" y="5943600"/>
+            <a:ext cx="8001000" cy="365760"/>
+          </a:xfrm>
+          <a:prstGeom prst="rect">
+            <a:avLst/>
+          </a:prstGeom>
+          <a:noFill/>
+          <a:ln/>
+        </p:spPr>
+        <p:txBody>
+          <a:bodyPr wrap="square" lIns="0" tIns="0" rIns="0" bIns="0" rtlCol="0" anchor="ctr"/>
+          <a:lstStyle/>
+          <a:p>
+            <a:pPr indent="0" marL="0">
+              <a:lnSpc>
+                <a:spcPct val="124000"/>
+              </a:lnSpc>
+              <a:buNone/>
+            </a:pPr>
+            <a:r>
+              <a:rPr lang="en-US" sz="1000" b="1" dirty="0">
                 <a:solidFill>
                   <a:srgbClr val="000000"/>
                 </a:solidFill>
@@ -11612,16 +11415,16 @@
                 <a:ea typeface="Helvetica Neue" pitchFamily="34" charset="-122"/>
                 <a:cs typeface="Helvetica Neue" pitchFamily="34" charset="-120"/>
               </a:rPr>
-              <a:t>Meanwhile destruction capacity is collapsing. </a:t>
+              <a:t>The pile is worked down slowly — and the hard part grows inside it. </a:t>
             </a:r>
             <a:pPr indent="0" marL="0">
               <a:lnSpc>
-                <a:spcPct val="128000"/>
+                <a:spcPct val="124000"/>
               </a:lnSpc>
               <a:buNone/>
             </a:pPr>
             <a:r>
-              <a:rPr lang="en-US" sz="1200" dirty="0">
+              <a:rPr lang="en-US" sz="1000" dirty="0">
                 <a:solidFill>
                   <a:srgbClr val="33332F"/>
                 </a:solidFill>
@@ -11629,15 +11432,74 @@
                 <a:ea typeface="Helvetica Neue" pitchFamily="34" charset="-122"/>
                 <a:cs typeface="Helvetica Neue" pitchFamily="34" charset="-120"/>
               </a:rPr>
-              <a:t>The US destroyed roughly 82,000 tons in FY2015. Its funded plan for FY2026 is 29,313 — a 64% fall, just as the surge begins to refill the queue.¹⁸</a:t>
-            </a:r>
-            <a:endParaRPr lang="en-US" sz="1200" dirty="0"/>
-          </a:p>
-        </p:txBody>
-      </p:sp>
-      <p:sp>
-        <p:nvSpPr>
-          <p:cNvPr id="22" name="Text 20"/>
+              <a:t>Missile components went from 6.5% to 16.8% of the account, while funded destruction capacity fell from ~82,000 tons in FY2015 to 31,475 in FY2027.¹⁸</a:t>
+            </a:r>
+            <a:endParaRPr lang="en-US" sz="1000" dirty="0"/>
+          </a:p>
+        </p:txBody>
+      </p:sp>
+      <p:sp>
+        <p:nvSpPr>
+          <p:cNvPr id="14" name="Text 11"/>
+          <p:cNvSpPr txBox="1"/>
+          <p:nvPr/>
+        </p:nvSpPr>
+        <p:spPr>
+          <a:xfrm>
+            <a:off x="8732520" y="5943600"/>
+            <a:ext cx="2816352" cy="402336"/>
+          </a:xfrm>
+          <a:prstGeom prst="rect">
+            <a:avLst/>
+          </a:prstGeom>
+          <a:noFill/>
+          <a:ln/>
+        </p:spPr>
+        <p:txBody>
+          <a:bodyPr wrap="square" lIns="0" tIns="0" rIns="0" bIns="0" rtlCol="0" anchor="ctr"/>
+          <a:lstStyle/>
+          <a:p>
+            <a:pPr algn="r" indent="0" marL="0">
+              <a:lnSpc>
+                <a:spcPct val="125000"/>
+              </a:lnSpc>
+              <a:buNone/>
+            </a:pPr>
+            <a:r>
+              <a:rPr lang="en-US" sz="700" b="1" spc="140" kern="0" dirty="0">
+                <a:solidFill>
+                  <a:srgbClr val="6E6C66"/>
+                </a:solidFill>
+                <a:latin typeface="IBM Plex Mono" pitchFamily="34" charset="0"/>
+                <a:ea typeface="IBM Plex Mono" pitchFamily="34" charset="-122"/>
+                <a:cs typeface="IBM Plex Mono" pitchFamily="34" charset="-120"/>
+              </a:rPr>
+              <a:t>SOURCES </a:t>
+            </a:r>
+            <a:pPr algn="r" indent="0" marL="0">
+              <a:lnSpc>
+                <a:spcPct val="125000"/>
+              </a:lnSpc>
+              <a:buNone/>
+            </a:pPr>
+            <a:r>
+              <a:rPr lang="en-US" sz="700" spc="60" kern="0" dirty="0">
+                <a:solidFill>
+                  <a:srgbClr val="6E6C66"/>
+                </a:solidFill>
+                <a:latin typeface="IBM Plex Mono" pitchFamily="34" charset="0"/>
+                <a:ea typeface="IBM Plex Mono" pitchFamily="34" charset="-122"/>
+                <a:cs typeface="IBM Plex Mono" pitchFamily="34" charset="-120"/>
+              </a:rPr>
+              <a:t>Army Procurement of Ammunition justification books, FY2018–FY2027, line 4099EP1700⁵ · years-to-clear is our calculation¹⁷</a:t>
+            </a:r>
+            <a:endParaRPr lang="en-US" sz="700" dirty="0"/>
+          </a:p>
+        </p:txBody>
+      </p:sp>
+      <p:sp>
+        <p:nvSpPr>
+          <p:cNvPr id="15" name="Text 12"/>
           <p:cNvSpPr txBox="1"/>
           <p:nvPr/>
         </p:nvSpPr>

</xml_diff>